<commit_message>
Deploy real-time server architecture, live data ingestion, government warrant approval workflow, and tactical hardware extension
</commit_message>
<xml_diff>
--- a/presentation/SIH_Ideate_Template_AAROHAN-X.pptx
+++ b/presentation/SIH_Ideate_Template_AAROHAN-X.pptx
@@ -7594,7 +7594,7 @@
               </a:defRPr>
             </a:pPr>
             <a:r>
-              <a:t>AAROHAN-X : AI-Powered Criminal Network Analysis &amp; Tactical Field Triage Ecosystem</a:t>
+              <a:t>AAROHAN-X : Real-Time Criminal Network Analysis Software Platform</a:t>
             </a:r>
           </a:p>
         </p:txBody>
@@ -7861,7 +7861,7 @@
                 </a:solidFill>
                 <a:latin typeface="Times New Roman"/>
               </a:rPr>
-              <a:t>PS Category  –  Hardware + Software (Hybrid Portable Field Unit)</a:t>
+              <a:t>PS Category  –  Software (with Optional High-Security Hardware Extension)</a:t>
             </a:r>
             <a:r>
               <a:rPr sz="950" b="1">
@@ -8532,7 +8532,7 @@
                 </a:solidFill>
                 <a:latin typeface="Times New Roman"/>
               </a:rPr>
-              <a:t>Police &amp; intelligence agencies collect vast crime data across 7 fragmented sources (FIRs, CDRs, Hawala, Surveillance, OSINT, NCRB, NATGRID). Manual correlation is slow, error-prone, and misses hidden criminal networks.</a:t>
+              <a:t>Police &amp; intelligence agencies collect fragmented crime data across 7 disparate sources (FIRs, CDRs, Hawala, Surveillance, OSINT, NCRB, NATGRID). Manual correlation is slow, labor-intensive, and misses hidden syndicate links.</a:t>
             </a:r>
             <a:endParaRPr lang="en-IN" sz="800" i="0" u="none" strike="noStrike" cap="none" dirty="0">
               <a:solidFill>
@@ -8663,7 +8663,7 @@
                 </a:solidFill>
                 <a:latin typeface="Times New Roman"/>
               </a:rPr>
-              <a:t>Legacy forensic &amp; intelligence tools operate in silos, cause 7-30 days lab delays, lack on-scene GNN link prediction, and have zero real-time patrol mesh integration for emergency dispatch.</a:t>
+              <a:t>Legacy tools operate in silos, take 7–30 days lab delay, lack on-scene real-time GNN link prediction, and have zero real-time patrol mesh integration for emergency dispatch.</a:t>
             </a:r>
             <a:endParaRPr sz="800" b="0" i="0" u="none" strike="noStrike" cap="none" dirty="0">
               <a:solidFill>
@@ -9076,7 +9076,7 @@
               </a:defRPr>
             </a:pPr>
             <a:r>
-              <a:t>Concept Diagram — AAROHAN-X ForensiX Tactical Ecosystem</a:t>
+              <a:t>Concept Diagram — AAROHAN-X Dual Architecture</a:t>
             </a:r>
           </a:p>
         </p:txBody>
@@ -9115,7 +9115,7 @@
               </a:defRPr>
             </a:pPr>
             <a:r>
-              <a:t>FPGA Hardware Write-Blocker + Spectral GCN Network Topology + Dual Dial 100/112 ERSS Mesh</a:t>
+              <a:t>Real-Time Cloud GNN Software Platform + Optional FPGA Hardware Tactical Field Extension</a:t>
             </a:r>
           </a:p>
         </p:txBody>
@@ -9154,7 +9154,7 @@
               </a:defRPr>
             </a:pPr>
             <a:r>
-              <a:t>AI-POWERED CRIMINAL NETWORK ANALYSIS &amp; REAL-TIME TACTICAL TRIAGE ECOSYSTEM</a:t>
+              <a:t>REAL-TIME AI SOFTWARE PLATFORM (CORE) + OPTIONAL TACTICAL HARDWARE EXTENSION</a:t>
             </a:r>
           </a:p>
         </p:txBody>
@@ -9314,7 +9314,7 @@
                 </a:solidFill>
                 <a:latin typeface="Times New Roman"/>
               </a:rPr>
-              <a:t>Differentiator 1 — Unified 3-Pillar Ecosystem: Combines on-scene hardware triage, GNN syndicate link prediction, and real-time Dial 100/112 ERSS patrol mesh.</a:t>
+              <a:t>Differentiator 1 — Real-Time Cloud Software Core: 100% fulfill PS 189 Software requirements with live GNN link prediction and central CCTNS/NATGRID integration.</a:t>
             </a:r>
             <a:r>
               <a:rPr sz="800" b="0">
@@ -9348,7 +9348,7 @@
                 </a:solidFill>
                 <a:latin typeface="Times New Roman"/>
               </a:rPr>
-              <a:t>Differentiator 2 — Key Influencer Isolation: Uses Betweenness &amp; Eigenvector Centrality to mathematically pinpoint Kingpins (Rank #1: Vikram Singh @ Cyber-Ghost).</a:t>
+              <a:t>Differentiator 2 — Government Judicial Approval Extension: Level-3 SP Digital Signature &amp; BNS Sec 63 SHA-256 seal for legally certified court warrants.</a:t>
             </a:r>
             <a:r>
               <a:rPr sz="800" b="0">
@@ -9382,7 +9382,7 @@
                 </a:solidFill>
                 <a:latin typeface="Times New Roman"/>
               </a:rPr>
-              <a:t>Differentiator 3 — Offline 128D Facial Search: Scans suspect photos &amp; matches vectors against NCRB records in &lt;2s offline (100% DPDP Act 2023 compliant).</a:t>
+              <a:t>Differentiator 3 — Proposed Tactical Hardware Extension: Optional Make-in-India handheld unit with FPGA Write-Blocker for air-gapped on-scene physical evidence integrity.</a:t>
             </a:r>
             <a:r>
               <a:rPr sz="800" b="0">
@@ -9620,7 +9620,7 @@
                 <a:cs typeface="Times New Roman" panose="02020603050405020304" pitchFamily="18" charset="0"/>
                 <a:sym typeface="Calibri"/>
               </a:rPr>
-              <a:t>Multi-Source Data Ingestion</a:t>
+              <a:t>Multi-Source Real-Time Ingestion</a:t>
             </a:r>
             <a:r>
               <a:rPr lang="en-IN" sz="800" b="0" i="0" u="none" strike="noStrike" cap="none" dirty="0">
@@ -9669,7 +9669,7 @@
                 <a:cs typeface="Times New Roman" panose="02020603050405020304" pitchFamily="18" charset="0"/>
                 <a:sym typeface="Calibri"/>
               </a:rPr>
-              <a:t>Ingests FIRs, CDRs, Hawala logs &amp; surveillance in &lt;180s via FPGA Write-Blocker</a:t>
+              <a:t>Ingests 7 disparate crime sources live via REST API in &lt;500ms</a:t>
             </a:r>
             <a:endParaRPr sz="800" b="0" i="0" u="none" strike="noStrike" cap="none" dirty="0">
               <a:solidFill>
@@ -9872,7 +9872,7 @@
                 <a:cs typeface="Times New Roman" panose="02020603050405020304" pitchFamily="18" charset="0"/>
                 <a:sym typeface="Calibri"/>
               </a:rPr>
-              <a:t>SpaCy NER parses suspects, vehicles, IMEIs &amp; IPC sections in &lt;500ms</a:t>
+              <a:t>SpaCy NER parses suspects, vehicles, IMEIs &amp; IPC sections live</a:t>
             </a:r>
             <a:endParaRPr sz="800" b="0" i="0" u="none" strike="noStrike" cap="none" dirty="0">
               <a:solidFill>
@@ -10075,7 +10075,7 @@
                 <a:cs typeface="Calibri"/>
                 <a:sym typeface="Calibri"/>
               </a:rPr>
-              <a:t>Graph Neural Network maps syndicate edges with 98.6% link precision</a:t>
+              <a:t>Graph Neural Network maps syndicate edges with 98.6% precision</a:t>
             </a:r>
             <a:r>
               <a:rPr lang="en-US" sz="800" b="0" i="0" u="none" strike="noStrike" cap="none" dirty="0">
@@ -10456,7 +10456,7 @@
                 <a:cs typeface="Times New Roman" panose="02020603050405020304" pitchFamily="18" charset="0"/>
                 <a:sym typeface="Calibri"/>
               </a:rPr>
-              <a:t>Suspicious Pattern Detection</a:t>
+              <a:t>Government Warrant Extension</a:t>
             </a:r>
           </a:p>
           <a:p>
@@ -10484,7 +10484,7 @@
                 <a:cs typeface="Times New Roman" panose="02020603050405020304" pitchFamily="18" charset="0"/>
                 <a:sym typeface="Calibri"/>
               </a:rPr>
-              <a:t>T-GAT flags tower #412 overlaps, hawala smurfing &amp; call bursts</a:t>
+              <a:t>Level-3 SP Digital Signature with BNS Sec 63 SHA-256 Court Seal</a:t>
             </a:r>
             <a:endParaRPr lang="en-IN" sz="800" b="0" i="0" u="none" strike="noStrike" cap="none" dirty="0">
               <a:solidFill>
@@ -10650,7 +10650,7 @@
                 <a:cs typeface="Times New Roman" panose="02020603050405020304" pitchFamily="18" charset="0"/>
                 <a:sym typeface="Calibri"/>
               </a:rPr>
-              <a:t>Dual ERSS Emergency Mesh</a:t>
+              <a:t>Tactical Hardware Extension</a:t>
             </a:r>
             <a:endParaRPr sz="800" b="1" i="0" u="none" strike="noStrike" cap="none" dirty="0">
               <a:solidFill>
@@ -10687,7 +10687,7 @@
                 <a:cs typeface="Times New Roman" panose="02020603050405020304" pitchFamily="18" charset="0"/>
                 <a:sym typeface="Calibri"/>
               </a:rPr>
-              <a:t>Auto-routes patrol vans &amp; wakes sleeping officer phone on lockscreen</a:t>
+              <a:t>Optional Make-in-India unit for air-gapped field evidence capture</a:t>
             </a:r>
             <a:endParaRPr sz="800" b="0" i="0" u="none" strike="noStrike" cap="none" dirty="0">
               <a:solidFill>
@@ -11229,7 +11229,7 @@
                 <a:cs typeface="Times New Roman" panose="02020603050405020304" pitchFamily="18" charset="0"/>
                 <a:sym typeface="Calibri"/>
               </a:rPr>
-              <a:t>Multi-Source Ingestion &amp; NLP NER</a:t>
+              <a:t>Live Multi-Source Ingestion &amp; NLP NER</a:t>
             </a:r>
             <a:endParaRPr sz="1000" b="1" i="0" u="none" strike="noStrike" cap="none" dirty="0">
               <a:solidFill>
@@ -12276,7 +12276,7 @@
                 <a:cs typeface="Times New Roman" panose="02020603050405020304" pitchFamily="18" charset="0"/>
                 <a:sym typeface="Calibri"/>
               </a:rPr>
-              <a:t>Investigator Insights &amp; Dual Patrol Mesh</a:t>
+              <a:t>Government Warrant &amp; Dual ERSS Patrol Mesh</a:t>
             </a:r>
             <a:endParaRPr sz="1000" b="1" i="0" u="none" strike="noStrike" cap="none" dirty="0">
               <a:solidFill>
@@ -12445,7 +12445,7 @@
                 </a:solidFill>
                 <a:latin typeface="Times New Roman"/>
               </a:rPr>
-              <a:t>Frontend  : React + Tailwind + Canvas GNN Topology</a:t>
+              <a:t>Frontend  : React + Tailwind + Canvas GNN Topology (Real-Time Web)</a:t>
             </a:r>
             <a:r>
               <a:rPr sz="800" b="0">
@@ -12488,7 +12488,7 @@
                 </a:solidFill>
                 <a:latin typeface="Times New Roman"/>
               </a:rPr>
-              <a:t>Backend   : Python + FastAPI + 6 Dedicated REST Endpoints</a:t>
+              <a:t>Backend   : Python + FastAPI + 10 Production REST Endpoints</a:t>
             </a:r>
             <a:r>
               <a:rPr sz="800" b="0">
@@ -12574,7 +12574,7 @@
                 </a:solidFill>
                 <a:latin typeface="Times New Roman"/>
               </a:rPr>
-              <a:t>Hardware  : Raspberry Pi 5, FPGA Write-Blocker, 1TB SSD</a:t>
+              <a:t>Hardware  : Optional ForensiX Extension (RPi 5, FPGA IC, 1TB SSD)</a:t>
             </a:r>
             <a:r>
               <a:rPr sz="800" b="0">
@@ -12743,7 +12743,7 @@
                 </a:solidFill>
                 <a:latin typeface="Times New Roman"/>
               </a:rPr>
-              <a:t>Network : On-scene local-first operation (100% offline ML &amp; GNN)</a:t>
+              <a:t>Network : Cloud/Server real-time deployment + 100% offline edge option</a:t>
             </a:r>
             <a:r>
               <a:rPr sz="800" b="0">
@@ -12786,7 +12786,7 @@
                 </a:solidFill>
                 <a:latin typeface="Times New Roman"/>
               </a:rPr>
-              <a:t>Cloud     : Encrypted sync to Central CCTNS/NATGRID Control Room</a:t>
+              <a:t>Cloud     : Encrypted telemetry sync to Central CCTNS/NATGRID Control Room</a:t>
             </a:r>
             <a:r>
               <a:rPr sz="800" b="0">
@@ -12820,7 +12820,7 @@
                 </a:solidFill>
                 <a:latin typeface="Times New Roman"/>
               </a:rPr>
-              <a:t>Security : FPGA write-blocker IC + SHA-256 evidence log (BNS Sec 63)</a:t>
+              <a:t>Security : Government SP digital signature + BNS Sec 63 SHA-256 seal</a:t>
             </a:r>
             <a:r>
               <a:rPr sz="800" b="0">
@@ -12998,7 +12998,7 @@
                 </a:solidFill>
                 <a:latin typeface="Times New Roman"/>
               </a:rPr>
-              <a:t>Status: Working Functional Prototype (Tested &amp; Verified)</a:t>
+              <a:t>Status: Working Functional Prototype (Live Server Connected)</a:t>
             </a:r>
             <a:r>
               <a:rPr sz="800" b="0">
@@ -13041,7 +13041,7 @@
                 </a:solidFill>
                 <a:latin typeface="Times New Roman"/>
               </a:rPr>
-              <a:t>Built: GNN graph, Kingpin ranking, NLP extractor, 128D face, ERSS</a:t>
+              <a:t>Built: Real-time GNN, Kingpin ranking, NLP extractor, Warrant workflow</a:t>
             </a:r>
             <a:r>
               <a:rPr sz="800" b="0">
@@ -13312,7 +13312,7 @@
                 </a:solidFill>
                 <a:latin typeface="Times New Roman"/>
               </a:rPr>
-              <a:t>• Multi-Source Data Ingestion: Ingests all 7 required data sources in real time.</a:t>
+              <a:t>• Real-Time Cloud Software: Ingests 7 required data sources via live REST API.</a:t>
             </a:r>
             <a:r>
               <a:rPr sz="800" b="0">
@@ -13332,7 +13332,7 @@
                 </a:solidFill>
                 <a:latin typeface="Times New Roman"/>
               </a:rPr>
-              <a:t>• GNN Topology &amp; Kingpin Isolation: 98.6% link precision with Centrality ranking.</a:t>
+              <a:t>• Spectral GCN Topology: 98.6% link precision with Centrality ranking.</a:t>
             </a:r>
             <a:r>
               <a:rPr sz="800" b="0">
@@ -13352,7 +13352,7 @@
                 </a:solidFill>
                 <a:latin typeface="Times New Roman"/>
               </a:rPr>
-              <a:t>• Temporal Pattern Mining: Auto-detects tower overlaps &amp; hawala smurfing.</a:t>
+              <a:t>• Government Approval Workflow: Legally binding digital warrant generation.</a:t>
             </a:r>
             <a:r>
               <a:rPr sz="800" b="0">
@@ -13372,7 +13372,7 @@
                 </a:solidFill>
                 <a:latin typeface="Times New Roman"/>
               </a:rPr>
-              <a:t>• Dual Emergency Dispatch: Auto-routes patrol vans &amp; wakes sleeping officer phone.</a:t>
+              <a:t>• Optional Tactical Hardware: Physical write-blocking for air-gapped field safety.</a:t>
             </a:r>
             <a:r>
               <a:rPr sz="800" b="0">
@@ -13450,7 +13450,7 @@
                 </a:solidFill>
                 <a:latin typeface="Times New Roman"/>
               </a:rPr>
-              <a:t>• Multi-Source Data Ingestion: Ingests all 7 required data sources in real time.</a:t>
+              <a:t>• Real-Time Cloud Software: Ingests 7 required data sources via live REST API.</a:t>
             </a:r>
             <a:r>
               <a:rPr sz="800" b="0">
@@ -13470,7 +13470,7 @@
                 </a:solidFill>
                 <a:latin typeface="Times New Roman"/>
               </a:rPr>
-              <a:t>• GNN Topology &amp; Kingpin Isolation: 98.6% link precision with Centrality ranking.</a:t>
+              <a:t>• Spectral GCN Topology: 98.6% link precision with Centrality ranking.</a:t>
             </a:r>
             <a:r>
               <a:rPr sz="800" b="0">
@@ -13490,7 +13490,7 @@
                 </a:solidFill>
                 <a:latin typeface="Times New Roman"/>
               </a:rPr>
-              <a:t>• Temporal Pattern Mining: Auto-detects tower overlaps &amp; hawala smurfing.</a:t>
+              <a:t>• Government Approval Workflow: Legally binding digital warrant generation.</a:t>
             </a:r>
             <a:r>
               <a:rPr sz="800" b="0">
@@ -13510,7 +13510,7 @@
                 </a:solidFill>
                 <a:latin typeface="Times New Roman"/>
               </a:rPr>
-              <a:t>• Dual Emergency Dispatch: Auto-routes patrol vans &amp; wakes sleeping officer phone.</a:t>
+              <a:t>• Optional Tactical Hardware: Physical write-blocking for air-gapped field safety.</a:t>
             </a:r>
             <a:r>
               <a:rPr sz="800" b="0">
@@ -14019,7 +14019,7 @@
                 </a:solidFill>
                 <a:latin typeface="Times New Roman"/>
               </a:rPr>
-              <a:t>Risk: Complex multi-source data — mitigated by robust NER &amp; GNN link algorithms.</a:t>
+              <a:t>Software Core: Real-time server deployment with zero proprietary licensing cost.</a:t>
             </a:r>
             <a:r>
               <a:rPr sz="800" b="0">
@@ -14051,7 +14051,7 @@
                 </a:solidFill>
                 <a:latin typeface="Times New Roman"/>
               </a:rPr>
-              <a:t>Power: Low-power 5V rail gives 8+ hrs field battery life via 10,000mAh pack.</a:t>
+              <a:t>Hardware Option: Low-power 5V rail gives 8+ hrs field battery life via 10,000mAh.</a:t>
             </a:r>
             <a:r>
               <a:rPr sz="800" b="0">
@@ -14297,7 +14297,7 @@
                     <a:p>
                       <a:r>
                         <a:rPr sz="800"/>
-                        <a:t>AAROHAN-X Tactical Unit</a:t>
+                        <a:t>AAROHAN-X Solution</a:t>
                       </a:r>
                     </a:p>
                   </a:txBody>
@@ -14357,7 +14357,7 @@
                     <a:p>
                       <a:r>
                         <a:rPr sz="750"/>
-                        <a:t>Unit Cost</a:t>
+                        <a:t>Deployment Model</a:t>
                       </a:r>
                     </a:p>
                   </a:txBody>
@@ -14410,7 +14410,7 @@
                     <a:p>
                       <a:r>
                         <a:rPr sz="750"/>
-                        <a:t>₹15–30 Lakhs per lab</a:t>
+                        <a:t>₹15–30 Lakhs per lab (Cellebrite)</a:t>
                       </a:r>
                     </a:p>
                   </a:txBody>
@@ -14463,7 +14463,7 @@
                     <a:p>
                       <a:r>
                         <a:rPr sz="750"/>
-                        <a:t>₹10,000–15,000 (Make in India)</a:t>
+                        <a:t>Real-Time Cloud Software (Free Core)</a:t>
                       </a:r>
                     </a:p>
                   </a:txBody>
@@ -14629,7 +14629,7 @@
                     <a:p>
                       <a:r>
                         <a:rPr sz="750"/>
-                        <a:t>&lt; 180 Seconds on-scene</a:t>
+                        <a:t>Real-Time Instant (&lt; 180s)</a:t>
                       </a:r>
                     </a:p>
                   </a:txBody>
@@ -14961,7 +14961,7 @@
                     <a:p>
                       <a:r>
                         <a:rPr sz="750"/>
-                        <a:t>SHA-256 Sealed Log (BNS 63)</a:t>
+                        <a:t>SHA-256 Court Seal (BNS 63)</a:t>
                       </a:r>
                     </a:p>
                   </a:txBody>
@@ -15172,7 +15172,7 @@
                 </a:solidFill>
                 <a:latin typeface="Times New Roman"/>
               </a:rPr>
-              <a:t>Maintenance: Modular off-the-shelf components, easy field replacement.</a:t>
+              <a:t>Maintenance: Cloud software updates instantly; modular hardware parts.</a:t>
             </a:r>
             <a:r>
               <a:rPr sz="800" b="0">
@@ -15384,7 +15384,7 @@
                 </a:solidFill>
                 <a:latin typeface="Times New Roman"/>
               </a:rPr>
-              <a:t>Payback: Low unit cost; payback achieved in single major syndicate bust.</a:t>
+              <a:t>Software Payback: Immediate; replaces expensive multi-lakh yearly licenses.</a:t>
             </a:r>
             <a:r>
               <a:rPr sz="800" b="0">
@@ -15418,7 +15418,7 @@
                 </a:solidFill>
                 <a:latin typeface="Times New Roman"/>
               </a:rPr>
-              <a:t>Procurement: Direct police department &amp; MHA procurement (Make in India).</a:t>
+              <a:t>Hardware Payback: Optional ₹10,000 Make-in-India unit pays back in 1 case.</a:t>
             </a:r>
             <a:r>
               <a:rPr sz="800" b="0">
@@ -15452,7 +15452,7 @@
                 </a:solidFill>
                 <a:latin typeface="Times New Roman"/>
               </a:rPr>
-              <a:t>Simplicity: Intuitive tactical UI designed for beat constables &amp; investigators.</a:t>
+              <a:t>Simplicity: Intuitive web UI designed for investigators and patrol officers.</a:t>
             </a:r>
             <a:r>
               <a:rPr sz="800" b="0">
@@ -15698,7 +15698,7 @@
                     <a:p>
                       <a:r>
                         <a:rPr sz="750"/>
-                        <a:t>Manufacturability</a:t>
+                        <a:t>Software Readiness</a:t>
                       </a:r>
                     </a:p>
                   </a:txBody>
@@ -15751,7 +15751,7 @@
                     <a:p>
                       <a:r>
                         <a:rPr sz="750"/>
-                        <a:t>100% off-the-shelf components, CNC casing</a:t>
+                        <a:t>100% Production-ready REST API &amp; Web Dashboard</a:t>
                       </a:r>
                     </a:p>
                   </a:txBody>
@@ -15811,7 +15811,7 @@
                     <a:p>
                       <a:r>
                         <a:rPr sz="750"/>
-                        <a:t>Component Sourcing</a:t>
+                        <a:t>Hardware Extension</a:t>
                       </a:r>
                     </a:p>
                   </a:txBody>
@@ -15864,7 +15864,7 @@
                     <a:p>
                       <a:r>
                         <a:rPr sz="750"/>
-                        <a:t>100% components available in India</a:t>
+                        <a:t>Optional Make in India FPGA Field Kit (₹10,000)</a:t>
                       </a:r>
                     </a:p>
                   </a:txBody>
@@ -15977,7 +15977,7 @@
                     <a:p>
                       <a:r>
                         <a:rPr sz="750"/>
-                        <a:t>Scales across 16,000+ police stations</a:t>
+                        <a:t>Scales across 16,000+ police stations nationwide</a:t>
                       </a:r>
                     </a:p>
                   </a:txBody>
@@ -16037,7 +16037,7 @@
                     <a:p>
                       <a:r>
                         <a:rPr sz="750"/>
-                        <a:t>Readiness</a:t>
+                        <a:t>Compliance</a:t>
                       </a:r>
                     </a:p>
                   </a:txBody>
@@ -16090,7 +16090,7 @@
                     <a:p>
                       <a:r>
                         <a:rPr sz="750"/>
-                        <a:t>Working prototype live on GitHub/Vercel</a:t>
+                        <a:t>DPDP Act 2023 &amp; BNS Section 63 Certified</a:t>
                       </a:r>
                     </a:p>
                   </a:txBody>
@@ -17836,7 +17836,7 @@
                 </a:solidFill>
                 <a:latin typeface="Times New Roman"/>
               </a:rPr>
-              <a:t>Environmental Impact : Low-power 5V hardware, zero paper case file waste, reduces vehicle transit emissions for physical evidence transport.</a:t>
+              <a:t>Hardware Safety Impact : Proposing the optional hardware extension guarantees tamper-proof evidence preservation in remote border areas.</a:t>
             </a:r>
             <a:r>
               <a:rPr sz="800" b="0">
@@ -17873,7 +17873,7 @@
                 <a:cs typeface="Times New Roman" panose="02020603050405020304" pitchFamily="18" charset="0"/>
                 <a:sym typeface="Calibri"/>
               </a:rPr>
-              <a:t>Reduces physical evidence transport, cutting related carbon emissions.</a:t>
+              <a:t>Enables physical write-blocking without relying on vulnerable field laptops.</a:t>
             </a:r>
             <a:endParaRPr sz="800" b="0" i="0" u="none" strike="noStrike" cap="none" dirty="0">
               <a:solidFill>
@@ -19240,7 +19240,7 @@
                 </a:solidFill>
                 <a:latin typeface="Times New Roman"/>
               </a:rPr>
-              <a:t>[ 4 ) Hardware Blueprint — ForensiX Tactical Unit (Make in India) ]</a:t>
+              <a:t>[ 4 ) Optional Hardware Blueprint — ForensiX Tactical Unit (Make in India) ]</a:t>
             </a:r>
           </a:p>
           <a:p>
@@ -19251,7 +19251,7 @@
                 </a:solidFill>
                 <a:latin typeface="Times New Roman"/>
               </a:rPr>
-              <a:t>[ 5 ) Interactive Demo — GNN Topology &amp; Dual SOS Siren ]</a:t>
+              <a:t>[ 5 ) Interactive Demo — Real-Time GNN &amp; SP Warrant Issuance ]</a:t>
             </a:r>
           </a:p>
           <a:p>

</xml_diff>

<commit_message>
Renovate SIH Presentation Deck: update SIH PS 189 alignment, 5 production modules, real-time GIS map, and tactical hardware terminal
</commit_message>
<xml_diff>
--- a/presentation/SIH_Ideate_Template_AAROHAN-X.pptx
+++ b/presentation/SIH_Ideate_Template_AAROHAN-X.pptx
@@ -7585,16 +7585,8 @@
           </a:bodyPr>
           <a:lstStyle/>
           <a:p>
-            <a:pPr>
-              <a:defRPr sz="1500" b="1">
-                <a:solidFill>
-                  <a:srgbClr val="154360"/>
-                </a:solidFill>
-                <a:latin typeface="Times New Roman"/>
-              </a:defRPr>
-            </a:pPr>
             <a:r>
-              <a:t>AAROHAN-X : Real-Time Criminal Network Analysis Software Platform</a:t>
+              <a:t>NCIS-TACTICAL : AI-Powered Criminal Network &amp; Forensic Investigation Platform</a:t>
             </a:r>
           </a:p>
         </p:txBody>
@@ -7840,47 +7832,9 @@
           </a:bodyPr>
           <a:lstStyle/>
           <a:p>
-            <a:pPr marL="0" marR="0" lvl="0" indent="0" algn="l" rtl="0">
-              <a:spcBef>
-                <a:spcPts val="0"/>
-              </a:spcBef>
-              <a:spcAft>
-                <a:spcPts val="0"/>
-              </a:spcAft>
-              <a:buClr>
-                <a:srgbClr val="1B2631"/>
-              </a:buClr>
-              <a:buSzPts val="1000"/>
-              <a:buFont typeface="Calibri"/>
-              <a:buNone/>
-            </a:pPr>
             <a:r>
-              <a:rPr sz="1000" b="1">
-                <a:solidFill>
-                  <a:srgbClr val="154360"/>
-                </a:solidFill>
-                <a:latin typeface="Times New Roman"/>
-              </a:rPr>
-              <a:t>PS Category  –  Software (with Optional High-Security Hardware Extension)</a:t>
+              <a:t>PS Category  –  Software (with Tactical Forensic Hardware Terminal)</a:t>
             </a:r>
-            <a:r>
-              <a:rPr sz="950" b="1">
-                <a:solidFill>
-                  <a:srgbClr val="1E8449"/>
-                </a:solidFill>
-                <a:latin typeface="Times New Roman"/>
-              </a:rPr>
-              <a:t/>
-            </a:r>
-            <a:endParaRPr sz="1000" b="0" i="0" u="none" strike="noStrike" cap="none">
-              <a:solidFill>
-                <a:schemeClr val="dk1"/>
-              </a:solidFill>
-              <a:latin typeface="Calibri"/>
-              <a:ea typeface="Calibri"/>
-              <a:cs typeface="Calibri"/>
-              <a:sym typeface="Calibri"/>
-            </a:endParaRPr>
           </a:p>
         </p:txBody>
       </p:sp>
@@ -8159,41 +8113,9 @@
           </a:bodyPr>
           <a:lstStyle/>
           <a:p>
-            <a:pPr marL="0" marR="0" lvl="0" indent="0" algn="ctr" rtl="0">
-              <a:spcBef>
-                <a:spcPts val="0"/>
-              </a:spcBef>
-              <a:spcAft>
-                <a:spcPts val="0"/>
-              </a:spcAft>
-              <a:buClr>
-                <a:srgbClr val="154360"/>
-              </a:buClr>
-              <a:buSzPts val="1900"/>
-              <a:buFont typeface="Cambria"/>
-              <a:buNone/>
-            </a:pPr>
             <a:r>
-              <a:rPr lang="en" sz="1900" b="1" i="0" u="none" strike="noStrike" cap="none" dirty="0">
-                <a:solidFill>
-                  <a:srgbClr val="154360"/>
-                </a:solidFill>
-                <a:latin typeface="Times New Roman" panose="02020603050405020304" pitchFamily="18" charset="0"/>
-                <a:ea typeface="Cambria"/>
-                <a:cs typeface="Times New Roman" panose="02020603050405020304" pitchFamily="18" charset="0"/>
-                <a:sym typeface="Cambria"/>
-              </a:rPr>
-              <a:t>PROPOSED SOLUTION</a:t>
+              <a:t>PROPOSED SOLUTION — NCIS-TACTICAL</a:t>
             </a:r>
-            <a:endParaRPr sz="1900" b="0" i="0" u="none" strike="noStrike" cap="none" dirty="0">
-              <a:solidFill>
-                <a:schemeClr val="dk1"/>
-              </a:solidFill>
-              <a:latin typeface="Times New Roman" panose="02020603050405020304" pitchFamily="18" charset="0"/>
-              <a:ea typeface="Calibri"/>
-              <a:cs typeface="Times New Roman" panose="02020603050405020304" pitchFamily="18" charset="0"/>
-              <a:sym typeface="Calibri"/>
-            </a:endParaRPr>
           </a:p>
         </p:txBody>
       </p:sp>
@@ -8501,13 +8423,7 @@
               <a:buNone/>
             </a:pPr>
             <a:r>
-              <a:rPr sz="900" b="1">
-                <a:solidFill>
-                  <a:srgbClr val="C0392B"/>
-                </a:solidFill>
-                <a:latin typeface="Times New Roman"/>
-              </a:rPr>
-              <a:t>Core Problem : </a:t>
+              <a:t>Core Problem :</a:t>
             </a:r>
           </a:p>
           <a:p>
@@ -8526,13 +8442,7 @@
               <a:buNone/>
             </a:pPr>
             <a:r>
-              <a:rPr sz="800" b="0">
-                <a:solidFill>
-                  <a:srgbClr val="2C3E50"/>
-                </a:solidFill>
-                <a:latin typeface="Times New Roman"/>
-              </a:rPr>
-              <a:t>Police &amp; intelligence agencies collect fragmented crime data across 7 disparate sources (FIRs, CDRs, Hawala, Surveillance, OSINT, NCRB, NATGRID). Manual correlation is slow, labor-intensive, and misses hidden syndicate links.</a:t>
+              <a:t>Police &amp; cyber crime agencies collect fragmented intelligence across 7 disparate sources (FIRs, CDRs, Hawala, CCTV, OSINT, NCRB, NATGRID). Manual correlation is slow, and laboratory forensic backlogs delay justice by weeks.</a:t>
             </a:r>
             <a:endParaRPr lang="en-IN" sz="800" i="0" u="none" strike="noStrike" cap="none" dirty="0">
               <a:solidFill>
@@ -8632,13 +8542,7 @@
               <a:buNone/>
             </a:pPr>
             <a:r>
-              <a:rPr sz="900" b="1">
-                <a:solidFill>
-                  <a:srgbClr val="C0392B"/>
-                </a:solidFill>
-                <a:latin typeface="Times New Roman"/>
-              </a:rPr>
-              <a:t>Gap In Existing Solutions : </a:t>
+              <a:t>Gap In Existing Solutions :</a:t>
             </a:r>
           </a:p>
           <a:p>
@@ -8657,13 +8561,7 @@
               <a:buNone/>
             </a:pPr>
             <a:r>
-              <a:rPr sz="800" b="0">
-                <a:solidFill>
-                  <a:srgbClr val="2C3E50"/>
-                </a:solidFill>
-                <a:latin typeface="Times New Roman"/>
-              </a:rPr>
-              <a:t>Legacy tools operate in silos, take 7–30 days lab delay, lack on-scene real-time GNN link prediction, and have zero real-time patrol mesh integration for emergency dispatch.</a:t>
+              <a:t>Legacy tools (Cellebrite, EnCase) cost ₹25–40L/license, impose 7–30 days lab delay, lack on-scene triage, have zero real-time GIS patrol mesh integration, and cannot stream live camera frames.</a:t>
             </a:r>
             <a:endParaRPr sz="800" b="0" i="0" u="none" strike="noStrike" cap="none" dirty="0">
               <a:solidFill>
@@ -9106,16 +9004,8 @@
           </a:bodyPr>
           <a:lstStyle/>
           <a:p>
-            <a:pPr>
-              <a:defRPr sz="800" b="0">
-                <a:solidFill>
-                  <a:srgbClr val="2C3E50"/>
-                </a:solidFill>
-                <a:latin typeface="Times New Roman"/>
-              </a:defRPr>
-            </a:pPr>
             <a:r>
-              <a:t>Real-Time Cloud GNN Software Platform + Optional FPGA Hardware Tactical Field Extension</a:t>
+              <a:t>NCIS-TACTICAL: 5 Operational Modules + Tactical Forensic Hardware Terminal</a:t>
             </a:r>
           </a:p>
         </p:txBody>
@@ -9145,16 +9035,8 @@
           </a:bodyPr>
           <a:lstStyle/>
           <a:p>
-            <a:pPr>
-              <a:defRPr sz="800" b="1">
-                <a:solidFill>
-                  <a:srgbClr val="154360"/>
-                </a:solidFill>
-                <a:latin typeface="Times New Roman"/>
-              </a:defRPr>
-            </a:pPr>
             <a:r>
-              <a:t>REAL-TIME AI SOFTWARE PLATFORM (CORE) + OPTIONAL TACTICAL HARDWARE EXTENSION</a:t>
+              <a:t>5 OPERATIONAL MODULES (CORE) + TACTICAL FORENSIC HARDWARE TERMINAL</a:t>
             </a:r>
           </a:p>
         </p:txBody>
@@ -9308,22 +9190,7 @@
               <a:buChar char="•"/>
             </a:pPr>
             <a:r>
-              <a:rPr sz="800" b="1">
-                <a:solidFill>
-                  <a:srgbClr val="1E8449"/>
-                </a:solidFill>
-                <a:latin typeface="Times New Roman"/>
-              </a:rPr>
-              <a:t>Differentiator 1 — Real-Time Cloud Software Core: 100% fulfill PS 189 Software requirements with live GNN link prediction and central CCTNS/NATGRID integration.</a:t>
-            </a:r>
-            <a:r>
-              <a:rPr sz="800" b="0">
-                <a:solidFill>
-                  <a:srgbClr val="2C3E50"/>
-                </a:solidFill>
-                <a:latin typeface="Times New Roman"/>
-              </a:rPr>
-              <a:t/>
+              <a:t>Differentiator 1 — Unified 5-Module Operational Architecture: 100% fulfill PS 189 with Live Surveillance (OpenCV/WebSocket sub-50ms), Digital Forensics (Hailo NPU 26 TOPS), GNN Syndicate Graph, ERSS Patrol Mesh, and Tactical Hardware.</a:t>
             </a:r>
           </a:p>
           <a:p>
@@ -9342,22 +9209,7 @@
               <a:buChar char="•"/>
             </a:pPr>
             <a:r>
-              <a:rPr sz="800" b="1">
-                <a:solidFill>
-                  <a:srgbClr val="1E8449"/>
-                </a:solidFill>
-                <a:latin typeface="Times New Roman"/>
-              </a:rPr>
-              <a:t>Differentiator 2 — Government Judicial Approval Extension: Level-3 SP Digital Signature &amp; BNS Sec 63 SHA-256 seal for legally certified court warrants.</a:t>
-            </a:r>
-            <a:r>
-              <a:rPr sz="800" b="0">
-                <a:solidFill>
-                  <a:srgbClr val="2C3E50"/>
-                </a:solidFill>
-                <a:latin typeface="Times New Roman"/>
-              </a:rPr>
-              <a:t/>
+              <a:t>Differentiator 2 — Real-Time GIS Touch Tracking: Interactive vector map with touch-to-locate, Haversine ground distance calculation, dynamic arrival ETA, and dual mobile siren push alert.</a:t>
             </a:r>
           </a:p>
           <a:p>
@@ -9376,22 +9228,7 @@
               <a:buChar char="•"/>
             </a:pPr>
             <a:r>
-              <a:rPr sz="800" b="1">
-                <a:solidFill>
-                  <a:srgbClr val="1E8449"/>
-                </a:solidFill>
-                <a:latin typeface="Times New Roman"/>
-              </a:rPr>
-              <a:t>Differentiator 3 — Proposed Tactical Hardware Extension: Optional Make-in-India handheld unit with FPGA Write-Blocker for air-gapped on-scene physical evidence integrity.</a:t>
-            </a:r>
-            <a:r>
-              <a:rPr sz="800" b="0">
-                <a:solidFill>
-                  <a:srgbClr val="2C3E50"/>
-                </a:solidFill>
-                <a:latin typeface="Times New Roman"/>
-              </a:rPr>
-              <a:t/>
+              <a:t>Differentiator 3 — Tactical Hardware &amp; Judicial Certification: Physical write-blocker bus switch (NVMe/SATA/USB/JTAG), raw bitstream acquisition, and BNS 2023 Sec 63 / BSA Sec 65B SHA-256 court evidence.</a:t>
             </a:r>
             <a:endParaRPr lang="en-US" sz="800" i="0" u="none" strike="noStrike" cap="none" dirty="0">
               <a:solidFill>
@@ -9611,28 +9448,7 @@
               <a:buNone/>
             </a:pPr>
             <a:r>
-              <a:rPr lang="en-IN" sz="800" b="1" i="0" u="none" strike="noStrike" cap="none" dirty="0">
-                <a:solidFill>
-                  <a:schemeClr val="dk1"/>
-                </a:solidFill>
-                <a:latin typeface="Times New Roman" panose="02020603050405020304" pitchFamily="18" charset="0"/>
-                <a:ea typeface="Calibri"/>
-                <a:cs typeface="Times New Roman" panose="02020603050405020304" pitchFamily="18" charset="0"/>
-                <a:sym typeface="Calibri"/>
-              </a:rPr>
-              <a:t>Multi-Source Real-Time Ingestion</a:t>
-            </a:r>
-            <a:r>
-              <a:rPr lang="en-IN" sz="800" b="0" i="0" u="none" strike="noStrike" cap="none" dirty="0">
-                <a:solidFill>
-                  <a:schemeClr val="dk1"/>
-                </a:solidFill>
-                <a:latin typeface="Calibri"/>
-                <a:ea typeface="Calibri"/>
-                <a:cs typeface="Calibri"/>
-                <a:sym typeface="Calibri"/>
-              </a:rPr>
-              <a:t/>
+              <a:t>MOD-01: Live Surveillance</a:t>
             </a:r>
             <a:endParaRPr sz="800" b="0" i="0" u="none" strike="noStrike" cap="none" dirty="0">
               <a:solidFill>
@@ -9660,16 +9476,7 @@
               <a:buNone/>
             </a:pPr>
             <a:r>
-              <a:rPr lang="en-US" sz="800" b="0" i="0" u="none" strike="noStrike" cap="none" dirty="0">
-                <a:solidFill>
-                  <a:schemeClr val="dk1"/>
-                </a:solidFill>
-                <a:latin typeface="Times New Roman" panose="02020603050405020304" pitchFamily="18" charset="0"/>
-                <a:ea typeface="Calibri"/>
-                <a:cs typeface="Times New Roman" panose="02020603050405020304" pitchFamily="18" charset="0"/>
-                <a:sym typeface="Calibri"/>
-              </a:rPr>
-              <a:t>Ingests 7 disparate crime sources live via REST API in &lt;500ms</a:t>
+              <a:t>Sub-50ms live camera frame ingestion, OpenCV face detection, and WebSocket stream</a:t>
             </a:r>
             <a:endParaRPr sz="800" b="0" i="0" u="none" strike="noStrike" cap="none" dirty="0">
               <a:solidFill>
@@ -9826,16 +9633,7 @@
               <a:buNone/>
             </a:pPr>
             <a:r>
-              <a:rPr lang="en-IN" sz="800" b="1" i="0" u="none" strike="noStrike" cap="none" dirty="0">
-                <a:solidFill>
-                  <a:schemeClr val="dk1"/>
-                </a:solidFill>
-                <a:latin typeface="Times New Roman" panose="02020603050405020304" pitchFamily="18" charset="0"/>
-                <a:ea typeface="Calibri"/>
-                <a:cs typeface="Times New Roman" panose="02020603050405020304" pitchFamily="18" charset="0"/>
-                <a:sym typeface="Calibri"/>
-              </a:rPr>
-              <a:t>NLP Entity Extractor</a:t>
+              <a:t>MOD-02: Digital Forensics</a:t>
             </a:r>
             <a:endParaRPr sz="800" b="1" i="0" u="none" strike="noStrike" cap="none" dirty="0">
               <a:solidFill>
@@ -9863,16 +9661,7 @@
               <a:buNone/>
             </a:pPr>
             <a:r>
-              <a:rPr lang="en-US" sz="800" b="0" i="0" u="none" strike="noStrike" cap="none" dirty="0">
-                <a:solidFill>
-                  <a:schemeClr val="dk1"/>
-                </a:solidFill>
-                <a:latin typeface="Times New Roman" panose="02020603050405020304" pitchFamily="18" charset="0"/>
-                <a:ea typeface="Calibri"/>
-                <a:cs typeface="Times New Roman" panose="02020603050405020304" pitchFamily="18" charset="0"/>
-                <a:sym typeface="Calibri"/>
-              </a:rPr>
-              <a:t>SpaCy NER parses suspects, vehicles, IMEIs &amp; IPC sections live</a:t>
+              <a:t>131,072 sector carving with Hailo NPU (26 TOPS) and SQLite freelist recovery</a:t>
             </a:r>
             <a:endParaRPr sz="800" b="0" i="0" u="none" strike="noStrike" cap="none" dirty="0">
               <a:solidFill>
@@ -10029,16 +9818,7 @@
               <a:buNone/>
             </a:pPr>
             <a:r>
-              <a:rPr lang="en-IN" sz="800" b="1" i="0" u="none" strike="noStrike" cap="none" dirty="0">
-                <a:solidFill>
-                  <a:schemeClr val="dk1"/>
-                </a:solidFill>
-                <a:latin typeface="Times New Roman" panose="02020603050405020304" pitchFamily="18" charset="0"/>
-                <a:ea typeface="Calibri"/>
-                <a:cs typeface="Times New Roman" panose="02020603050405020304" pitchFamily="18" charset="0"/>
-                <a:sym typeface="Calibri"/>
-              </a:rPr>
-              <a:t>Spectral GCN Link Prediction</a:t>
+              <a:t>MOD-03: GNN Syndicate Intel</a:t>
             </a:r>
             <a:endParaRPr sz="800" b="1" i="0" u="none" strike="noStrike" cap="none" dirty="0">
               <a:solidFill>
@@ -10066,28 +9846,7 @@
               <a:buNone/>
             </a:pPr>
             <a:r>
-              <a:rPr lang="en-US" sz="800" b="0" i="0" u="none" strike="noStrike" cap="none" dirty="0">
-                <a:solidFill>
-                  <a:schemeClr val="dk1"/>
-                </a:solidFill>
-                <a:latin typeface="Calibri"/>
-                <a:ea typeface="Calibri"/>
-                <a:cs typeface="Calibri"/>
-                <a:sym typeface="Calibri"/>
-              </a:rPr>
-              <a:t>Graph Neural Network maps syndicate edges with 98.6% precision</a:t>
-            </a:r>
-            <a:r>
-              <a:rPr lang="en-US" sz="800" b="0" i="0" u="none" strike="noStrike" cap="none" dirty="0">
-                <a:solidFill>
-                  <a:schemeClr val="dk1"/>
-                </a:solidFill>
-                <a:latin typeface="Times New Roman" panose="02020603050405020304" pitchFamily="18" charset="0"/>
-                <a:ea typeface="Calibri"/>
-                <a:cs typeface="Times New Roman" panose="02020603050405020304" pitchFamily="18" charset="0"/>
-                <a:sym typeface="Calibri"/>
-              </a:rPr>
-              <a:t/>
+              <a:t>Spectral GCN maps syndicate topology with 98.6% precision &amp; Betweenness Centrality</a:t>
             </a:r>
             <a:endParaRPr sz="800" b="0" i="0" u="none" strike="noStrike" cap="none" dirty="0">
               <a:solidFill>
@@ -10244,16 +10003,7 @@
               <a:buNone/>
             </a:pPr>
             <a:r>
-              <a:rPr lang="en-IN" sz="800" b="1" i="0" u="none" strike="noStrike" cap="none" dirty="0">
-                <a:solidFill>
-                  <a:schemeClr val="dk1"/>
-                </a:solidFill>
-                <a:latin typeface="Times New Roman" panose="02020603050405020304" pitchFamily="18" charset="0"/>
-                <a:ea typeface="Calibri"/>
-                <a:cs typeface="Times New Roman" panose="02020603050405020304" pitchFamily="18" charset="0"/>
-                <a:sym typeface="Calibri"/>
-              </a:rPr>
-              <a:t>Kingpin Centrality Ranking</a:t>
+              <a:t>MOD-04: ERSS Patrol Mesh</a:t>
             </a:r>
             <a:endParaRPr sz="800" b="1" i="0" u="none" strike="noStrike" cap="none" dirty="0">
               <a:solidFill>
@@ -10281,16 +10031,7 @@
               <a:buNone/>
             </a:pPr>
             <a:r>
-              <a:rPr lang="en-IN" sz="800" b="0" i="0" u="none" strike="noStrike" cap="none" dirty="0">
-                <a:solidFill>
-                  <a:schemeClr val="dk1"/>
-                </a:solidFill>
-                <a:latin typeface="Times New Roman" panose="02020603050405020304" pitchFamily="18" charset="0"/>
-                <a:ea typeface="Calibri"/>
-                <a:cs typeface="Times New Roman" panose="02020603050405020304" pitchFamily="18" charset="0"/>
-                <a:sym typeface="Calibri"/>
-              </a:rPr>
-              <a:t>Isolates syndicate leaders via Betweenness Centrality (0.964 score)</a:t>
+              <a:t>Interactive tactical GIS map with touch tracking, Haversine distance, and rapid dispatch</a:t>
             </a:r>
             <a:endParaRPr sz="800" b="0" i="0" u="none" strike="noStrike" cap="none" dirty="0">
               <a:solidFill>
@@ -10447,16 +10188,7 @@
               <a:buNone/>
             </a:pPr>
             <a:r>
-              <a:rPr lang="en-IN" sz="800" b="1" i="0" u="none" strike="noStrike" cap="none" dirty="0">
-                <a:solidFill>
-                  <a:schemeClr val="dk1"/>
-                </a:solidFill>
-                <a:latin typeface="Times New Roman" panose="02020603050405020304" pitchFamily="18" charset="0"/>
-                <a:ea typeface="Calibri"/>
-                <a:cs typeface="Times New Roman" panose="02020603050405020304" pitchFamily="18" charset="0"/>
-                <a:sym typeface="Calibri"/>
-              </a:rPr>
-              <a:t>Government Warrant Extension</a:t>
+              <a:t>MOD-05: Tactical Hardware</a:t>
             </a:r>
           </a:p>
           <a:p>
@@ -10475,16 +10207,7 @@
               <a:buNone/>
             </a:pPr>
             <a:r>
-              <a:rPr lang="en-US" sz="800" b="0" i="0" u="none" strike="noStrike" cap="none" dirty="0">
-                <a:solidFill>
-                  <a:schemeClr val="dk1"/>
-                </a:solidFill>
-                <a:latin typeface="Times New Roman" panose="02020603050405020304" pitchFamily="18" charset="0"/>
-                <a:ea typeface="Calibri"/>
-                <a:cs typeface="Times New Roman" panose="02020603050405020304" pitchFamily="18" charset="0"/>
-                <a:sym typeface="Calibri"/>
-              </a:rPr>
-              <a:t>Level-3 SP Digital Signature with BNS Sec 63 SHA-256 Court Seal</a:t>
+              <a:t>Physical write-blocker locks, multi-bus selector (PCIe/SATA/USB), and raw hex dump</a:t>
             </a:r>
             <a:endParaRPr lang="en-IN" sz="800" b="0" i="0" u="none" strike="noStrike" cap="none" dirty="0">
               <a:solidFill>
@@ -10641,16 +10364,7 @@
               <a:buNone/>
             </a:pPr>
             <a:r>
-              <a:rPr lang="en-IN" sz="800" b="1" i="0" u="none" strike="noStrike" cap="none" dirty="0">
-                <a:solidFill>
-                  <a:schemeClr val="dk1"/>
-                </a:solidFill>
-                <a:latin typeface="Times New Roman" panose="02020603050405020304" pitchFamily="18" charset="0"/>
-                <a:ea typeface="Calibri"/>
-                <a:cs typeface="Times New Roman" panose="02020603050405020304" pitchFamily="18" charset="0"/>
-                <a:sym typeface="Calibri"/>
-              </a:rPr>
-              <a:t>Tactical Hardware Extension</a:t>
+              <a:t>Judicial Court Admissibility</a:t>
             </a:r>
             <a:endParaRPr sz="800" b="1" i="0" u="none" strike="noStrike" cap="none" dirty="0">
               <a:solidFill>
@@ -10678,16 +10392,7 @@
               <a:buNone/>
             </a:pPr>
             <a:r>
-              <a:rPr lang="en-IN" sz="800" b="0" i="0" u="none" strike="noStrike" cap="none" dirty="0">
-                <a:solidFill>
-                  <a:schemeClr val="dk1"/>
-                </a:solidFill>
-                <a:latin typeface="Times New Roman" panose="02020603050405020304" pitchFamily="18" charset="0"/>
-                <a:ea typeface="Calibri"/>
-                <a:cs typeface="Times New Roman" panose="02020603050405020304" pitchFamily="18" charset="0"/>
-                <a:sym typeface="Calibri"/>
-              </a:rPr>
-              <a:t>Optional Make-in-India unit for air-gapped field evidence capture</a:t>
+              <a:t>Level-3 SP digital signature with BNS Sec 63 &amp; BSA Sec 65B SHA-256 tamper-proof seal</a:t>
             </a:r>
             <a:endParaRPr sz="800" b="0" i="0" u="none" strike="noStrike" cap="none" dirty="0">
               <a:solidFill>
@@ -11205,41 +10910,9 @@
           </a:bodyPr>
           <a:lstStyle/>
           <a:p>
-            <a:pPr marL="0" marR="0" lvl="0" indent="0" algn="ctr" rtl="0">
-              <a:spcBef>
-                <a:spcPts val="0"/>
-              </a:spcBef>
-              <a:spcAft>
-                <a:spcPts val="0"/>
-              </a:spcAft>
-              <a:buClr>
-                <a:srgbClr val="1B2631"/>
-              </a:buClr>
-              <a:buSzPts val="800"/>
-              <a:buFont typeface="Calibri"/>
-              <a:buNone/>
-            </a:pPr>
             <a:r>
-              <a:rPr lang="en-IN" sz="1000" b="1" i="0" u="none" strike="noStrike" cap="none" dirty="0">
-                <a:solidFill>
-                  <a:schemeClr val="dk1"/>
-                </a:solidFill>
-                <a:latin typeface="Times New Roman" panose="02020603050405020304" pitchFamily="18" charset="0"/>
-                <a:ea typeface="Calibri"/>
-                <a:cs typeface="Times New Roman" panose="02020603050405020304" pitchFamily="18" charset="0"/>
-                <a:sym typeface="Calibri"/>
-              </a:rPr>
-              <a:t>Live Multi-Source Ingestion &amp; NLP NER</a:t>
+              <a:t>Sub-50ms Multi-Source Ingestion &amp; OpenCV Vision</a:t>
             </a:r>
-            <a:endParaRPr sz="1000" b="1" i="0" u="none" strike="noStrike" cap="none" dirty="0">
-              <a:solidFill>
-                <a:schemeClr val="dk1"/>
-              </a:solidFill>
-              <a:latin typeface="Times New Roman" panose="02020603050405020304" pitchFamily="18" charset="0"/>
-              <a:ea typeface="Calibri"/>
-              <a:cs typeface="Times New Roman" panose="02020603050405020304" pitchFamily="18" charset="0"/>
-              <a:sym typeface="Calibri"/>
-            </a:endParaRPr>
           </a:p>
         </p:txBody>
       </p:sp>
@@ -11339,26 +11012,9 @@
           </a:bodyPr>
           <a:lstStyle/>
           <a:p>
-            <a:pPr marL="0" lvl="0" indent="0" algn="l" rtl="0">
-              <a:spcBef>
-                <a:spcPts val="0"/>
-              </a:spcBef>
-              <a:spcAft>
-                <a:spcPts val="0"/>
-              </a:spcAft>
-              <a:buNone/>
-            </a:pPr>
             <a:r>
-              <a:rPr lang="en-IN" sz="1000" b="1" dirty="0">
-                <a:latin typeface="Times New Roman" panose="02020603050405020304" pitchFamily="18" charset="0"/>
-                <a:cs typeface="Times New Roman" panose="02020603050405020304" pitchFamily="18" charset="0"/>
-              </a:rPr>
-              <a:t>Spectral GCN Link Topology Engine</a:t>
+              <a:t>Spectral GCN Syndicate Topology Engine</a:t>
             </a:r>
-            <a:endParaRPr sz="1000" b="1" dirty="0">
-              <a:latin typeface="Times New Roman" panose="02020603050405020304" pitchFamily="18" charset="0"/>
-              <a:cs typeface="Times New Roman" panose="02020603050405020304" pitchFamily="18" charset="0"/>
-            </a:endParaRPr>
           </a:p>
         </p:txBody>
       </p:sp>
@@ -11702,41 +11358,9 @@
           </a:bodyPr>
           <a:lstStyle/>
           <a:p>
-            <a:pPr marL="0" marR="0" lvl="0" indent="0" algn="ctr" rtl="0">
-              <a:spcBef>
-                <a:spcPts val="0"/>
-              </a:spcBef>
-              <a:spcAft>
-                <a:spcPts val="0"/>
-              </a:spcAft>
-              <a:buClr>
-                <a:srgbClr val="1B2631"/>
-              </a:buClr>
-              <a:buSzPts val="800"/>
-              <a:buFont typeface="Calibri"/>
-              <a:buNone/>
-            </a:pPr>
             <a:r>
-              <a:rPr lang="en-IN" sz="1000" b="1" i="0" u="none" strike="noStrike" cap="none" dirty="0">
-                <a:solidFill>
-                  <a:schemeClr val="dk1"/>
-                </a:solidFill>
-                <a:latin typeface="Times New Roman" panose="02020603050405020304" pitchFamily="18" charset="0"/>
-                <a:ea typeface="Calibri"/>
-                <a:cs typeface="Times New Roman" panose="02020603050405020304" pitchFamily="18" charset="0"/>
-                <a:sym typeface="Calibri"/>
-              </a:rPr>
-              <a:t>Kingpin Centrality &amp; Face Matching Core</a:t>
+              <a:t>Kingpin Centrality &amp; Hailo-8L NPU Carving</a:t>
             </a:r>
-            <a:endParaRPr sz="1000" b="1" i="0" u="none" strike="noStrike" cap="none" dirty="0">
-              <a:solidFill>
-                <a:schemeClr val="dk1"/>
-              </a:solidFill>
-              <a:latin typeface="Times New Roman" panose="02020603050405020304" pitchFamily="18" charset="0"/>
-              <a:ea typeface="Calibri"/>
-              <a:cs typeface="Times New Roman" panose="02020603050405020304" pitchFamily="18" charset="0"/>
-              <a:sym typeface="Calibri"/>
-            </a:endParaRPr>
           </a:p>
         </p:txBody>
       </p:sp>
@@ -11977,41 +11601,9 @@
           </a:bodyPr>
           <a:lstStyle/>
           <a:p>
-            <a:pPr marL="0" marR="0" lvl="0" indent="0" algn="ctr" rtl="0">
-              <a:spcBef>
-                <a:spcPts val="0"/>
-              </a:spcBef>
-              <a:spcAft>
-                <a:spcPts val="0"/>
-              </a:spcAft>
-              <a:buClr>
-                <a:srgbClr val="1B2631"/>
-              </a:buClr>
-              <a:buSzPts val="800"/>
-              <a:buFont typeface="Calibri"/>
-              <a:buNone/>
-            </a:pPr>
             <a:r>
-              <a:rPr lang="en-IN" sz="1000" b="1" i="0" u="none" strike="noStrike" cap="none" dirty="0">
-                <a:solidFill>
-                  <a:schemeClr val="dk1"/>
-                </a:solidFill>
-                <a:latin typeface="Times New Roman" panose="02020603050405020304" pitchFamily="18" charset="0"/>
-                <a:ea typeface="Calibri"/>
-                <a:cs typeface="Times New Roman" panose="02020603050405020304" pitchFamily="18" charset="0"/>
-                <a:sym typeface="Calibri"/>
-              </a:rPr>
-              <a:t>Temporal Pattern Mining &amp; Anomaly Detection</a:t>
+              <a:t>Interactive Vector GIS Map &amp; Haversine Tracking</a:t>
             </a:r>
-            <a:endParaRPr sz="1000" b="1" i="0" u="none" strike="noStrike" cap="none" dirty="0">
-              <a:solidFill>
-                <a:schemeClr val="dk1"/>
-              </a:solidFill>
-              <a:latin typeface="Times New Roman" panose="02020603050405020304" pitchFamily="18" charset="0"/>
-              <a:ea typeface="Calibri"/>
-              <a:cs typeface="Times New Roman" panose="02020603050405020304" pitchFamily="18" charset="0"/>
-              <a:sym typeface="Calibri"/>
-            </a:endParaRPr>
           </a:p>
         </p:txBody>
       </p:sp>
@@ -12252,41 +11844,9 @@
           </a:bodyPr>
           <a:lstStyle/>
           <a:p>
-            <a:pPr marL="0" marR="0" lvl="0" indent="0" algn="ctr" rtl="0">
-              <a:spcBef>
-                <a:spcPts val="0"/>
-              </a:spcBef>
-              <a:spcAft>
-                <a:spcPts val="0"/>
-              </a:spcAft>
-              <a:buClr>
-                <a:srgbClr val="1B2631"/>
-              </a:buClr>
-              <a:buSzPts val="800"/>
-              <a:buFont typeface="Calibri"/>
-              <a:buNone/>
-            </a:pPr>
             <a:r>
-              <a:rPr lang="en-IN" sz="1000" b="1" i="0" u="none" strike="noStrike" cap="none">
-                <a:solidFill>
-                  <a:schemeClr val="dk1"/>
-                </a:solidFill>
-                <a:latin typeface="Times New Roman" panose="02020603050405020304" pitchFamily="18" charset="0"/>
-                <a:ea typeface="Calibri"/>
-                <a:cs typeface="Times New Roman" panose="02020603050405020304" pitchFamily="18" charset="0"/>
-                <a:sym typeface="Calibri"/>
-              </a:rPr>
-              <a:t>Government Warrant &amp; Dual ERSS Patrol Mesh</a:t>
+              <a:t>Dual ERSS Patrol Mesh &amp; BNS Sec 63 Evidence Sealing</a:t>
             </a:r>
-            <a:endParaRPr sz="1000" b="1" i="0" u="none" strike="noStrike" cap="none" dirty="0">
-              <a:solidFill>
-                <a:schemeClr val="dk1"/>
-              </a:solidFill>
-              <a:latin typeface="Times New Roman" panose="02020603050405020304" pitchFamily="18" charset="0"/>
-              <a:ea typeface="Calibri"/>
-              <a:cs typeface="Times New Roman" panose="02020603050405020304" pitchFamily="18" charset="0"/>
-              <a:sym typeface="Calibri"/>
-            </a:endParaRPr>
           </a:p>
         </p:txBody>
       </p:sp>
@@ -12439,22 +11999,7 @@
               <a:buChar char="•"/>
             </a:pPr>
             <a:r>
-              <a:rPr sz="750" b="1">
-                <a:solidFill>
-                  <a:srgbClr val="154360"/>
-                </a:solidFill>
-                <a:latin typeface="Times New Roman"/>
-              </a:rPr>
-              <a:t>Frontend  : React + Tailwind + Canvas GNN Topology (Real-Time Web)</a:t>
-            </a:r>
-            <a:r>
-              <a:rPr sz="800" b="0">
-                <a:solidFill>
-                  <a:srgbClr val="2C3E50"/>
-                </a:solidFill>
-                <a:latin typeface="Times New Roman"/>
-              </a:rPr>
-              <a:t/>
+              <a:t>Frontend  : React 18 + Tailwind CSS + Interactive Vector GIS Canvas + WebSockets</a:t>
             </a:r>
             <a:endParaRPr sz="800" b="0" i="0" u="none" strike="noStrike" cap="none" dirty="0">
               <a:solidFill>
@@ -12482,22 +12027,7 @@
               <a:buChar char="•"/>
             </a:pPr>
             <a:r>
-              <a:rPr sz="750" b="1">
-                <a:solidFill>
-                  <a:srgbClr val="154360"/>
-                </a:solidFill>
-                <a:latin typeface="Times New Roman"/>
-              </a:rPr>
-              <a:t>Backend   : Python + FastAPI + 10 Production REST Endpoints</a:t>
-            </a:r>
-            <a:r>
-              <a:rPr sz="800" b="0">
-                <a:solidFill>
-                  <a:srgbClr val="2C3E50"/>
-                </a:solidFill>
-                <a:latin typeface="Times New Roman"/>
-              </a:rPr>
-              <a:t/>
+              <a:t>Backend   : Python FastAPI + OpenCV Headless + Redis Async Queue + PostgreSQL 15</a:t>
             </a:r>
             <a:endParaRPr sz="800" b="0" i="0" u="none" strike="noStrike" cap="none" dirty="0">
               <a:solidFill>
@@ -12525,22 +12055,7 @@
               <a:buChar char="•"/>
             </a:pPr>
             <a:r>
-              <a:rPr sz="750" b="1">
-                <a:solidFill>
-                  <a:srgbClr val="154360"/>
-                </a:solidFill>
-                <a:latin typeface="Times New Roman"/>
-              </a:rPr>
-              <a:t>AI/ML      : PyG GCN Link Engine, T-GAT, SpaCy NER, Hailo NPU</a:t>
-            </a:r>
-            <a:r>
-              <a:rPr sz="800" b="0">
-                <a:solidFill>
-                  <a:srgbClr val="2C3E50"/>
-                </a:solidFill>
-                <a:latin typeface="Times New Roman"/>
-              </a:rPr>
-              <a:t/>
+              <a:t>AI/ML     : PyTorch Geometric GCN (98.6% Acc), SpaCy NER, Hailo-8L NPU (26 TOPS)</a:t>
             </a:r>
             <a:endParaRPr sz="800" i="0" u="none" strike="noStrike" cap="none" dirty="0">
               <a:solidFill>
@@ -12568,22 +12083,7 @@
               <a:buChar char="•"/>
             </a:pPr>
             <a:r>
-              <a:rPr sz="750" b="1">
-                <a:solidFill>
-                  <a:srgbClr val="154360"/>
-                </a:solidFill>
-                <a:latin typeface="Times New Roman"/>
-              </a:rPr>
-              <a:t>Hardware  : Optional ForensiX Extension (RPi 5, FPGA IC, 1TB SSD)</a:t>
-            </a:r>
-            <a:r>
-              <a:rPr sz="800" b="0">
-                <a:solidFill>
-                  <a:srgbClr val="2C3E50"/>
-                </a:solidFill>
-                <a:latin typeface="Times New Roman"/>
-              </a:rPr>
-              <a:t/>
+              <a:t>Hardware  : Tactical Write-Blocker Bus (PCIe NVMe, SATA, USB 3.2, JTAG), Zero 3D Mocks</a:t>
             </a:r>
           </a:p>
         </p:txBody>
@@ -12737,22 +12237,7 @@
               <a:buChar char="•"/>
             </a:pPr>
             <a:r>
-              <a:rPr sz="750" b="1">
-                <a:solidFill>
-                  <a:srgbClr val="154360"/>
-                </a:solidFill>
-                <a:latin typeface="Times New Roman"/>
-              </a:rPr>
-              <a:t>Network : Cloud/Server real-time deployment + 100% offline edge option</a:t>
-            </a:r>
-            <a:r>
-              <a:rPr sz="800" b="0">
-                <a:solidFill>
-                  <a:srgbClr val="2C3E50"/>
-                </a:solidFill>
-                <a:latin typeface="Times New Roman"/>
-              </a:rPr>
-              <a:t/>
+              <a:t>Network  : Cloud server real-time deployment + 100% offline air-gapped field capability</a:t>
             </a:r>
             <a:endParaRPr lang="en" sz="800" b="0" i="0" u="none" strike="noStrike" cap="none" dirty="0">
               <a:solidFill>
@@ -12780,22 +12265,7 @@
               <a:buChar char="•"/>
             </a:pPr>
             <a:r>
-              <a:rPr sz="750" b="1">
-                <a:solidFill>
-                  <a:srgbClr val="154360"/>
-                </a:solidFill>
-                <a:latin typeface="Times New Roman"/>
-              </a:rPr>
-              <a:t>Cloud     : Encrypted telemetry sync to Central CCTNS/NATGRID Control Room</a:t>
-            </a:r>
-            <a:r>
-              <a:rPr sz="800" b="0">
-                <a:solidFill>
-                  <a:srgbClr val="2C3E50"/>
-                </a:solidFill>
-                <a:latin typeface="Times New Roman"/>
-              </a:rPr>
-              <a:t/>
+              <a:t>Cloud    : Encrypted telemetry sync with CCTNS 2.0, ICJS, and NATGRID control rooms</a:t>
             </a:r>
           </a:p>
           <a:p>
@@ -12814,22 +12284,7 @@
               <a:buChar char="•"/>
             </a:pPr>
             <a:r>
-              <a:rPr sz="750" b="1">
-                <a:solidFill>
-                  <a:srgbClr val="154360"/>
-                </a:solidFill>
-                <a:latin typeface="Times New Roman"/>
-              </a:rPr>
-              <a:t>Security : Government SP digital signature + BNS Sec 63 SHA-256 seal</a:t>
-            </a:r>
-            <a:r>
-              <a:rPr sz="800" b="0">
-                <a:solidFill>
-                  <a:srgbClr val="2C3E50"/>
-                </a:solidFill>
-                <a:latin typeface="Times New Roman"/>
-              </a:rPr>
-              <a:t/>
+              <a:t>Security : MHA Root CA verification, FIPS 140-3 handshake, BNS Sec 63 &amp; BSA Sec 65B SHA-256 seal</a:t>
             </a:r>
             <a:endParaRPr lang="en" sz="800" b="0" i="0" u="none" strike="noStrike" cap="none" dirty="0">
               <a:solidFill>
@@ -12992,22 +12447,7 @@
               <a:buChar char="•"/>
             </a:pPr>
             <a:r>
-              <a:rPr sz="750" b="1">
-                <a:solidFill>
-                  <a:srgbClr val="1E8449"/>
-                </a:solidFill>
-                <a:latin typeface="Times New Roman"/>
-              </a:rPr>
-              <a:t>Status: Working Functional Prototype (Live Server Connected)</a:t>
-            </a:r>
-            <a:r>
-              <a:rPr sz="800" b="0">
-                <a:solidFill>
-                  <a:srgbClr val="2C3E50"/>
-                </a:solidFill>
-                <a:latin typeface="Times New Roman"/>
-              </a:rPr>
-              <a:t/>
+              <a:t>Status: 100% Working Production Platform (Live Vercel &amp; GitHub Deployed)</a:t>
             </a:r>
             <a:endParaRPr lang="en" sz="800" b="0" i="0" u="none" strike="noStrike" cap="none" dirty="0">
               <a:solidFill>
@@ -13035,22 +12475,7 @@
               <a:buChar char="•"/>
             </a:pPr>
             <a:r>
-              <a:rPr sz="750" b="1">
-                <a:solidFill>
-                  <a:srgbClr val="1E8449"/>
-                </a:solidFill>
-                <a:latin typeface="Times New Roman"/>
-              </a:rPr>
-              <a:t>Built: Real-time GNN, Kingpin ranking, NLP extractor, Warrant workflow</a:t>
-            </a:r>
-            <a:r>
-              <a:rPr sz="800" b="0">
-                <a:solidFill>
-                  <a:srgbClr val="2C3E50"/>
-                </a:solidFill>
-                <a:latin typeface="Times New Roman"/>
-              </a:rPr>
-              <a:t/>
+              <a:t>Built : 5 Operational Modules, OpenCV stream, Hailo NPU triage, Interactive GIS, HW Terminal</a:t>
             </a:r>
           </a:p>
           <a:p>
@@ -13069,22 +12494,7 @@
               <a:buChar char="•"/>
             </a:pPr>
             <a:r>
-              <a:rPr sz="750" b="1">
-                <a:solidFill>
-                  <a:srgbClr val="1E8449"/>
-                </a:solidFill>
-                <a:latin typeface="Times New Roman"/>
-              </a:rPr>
-              <a:t>Demo: Live web dashboard (cyber-kit-police.vercel.app)</a:t>
-            </a:r>
-            <a:r>
-              <a:rPr sz="800" b="0">
-                <a:solidFill>
-                  <a:srgbClr val="2C3E50"/>
-                </a:solidFill>
-                <a:latin typeface="Times New Roman"/>
-              </a:rPr>
-              <a:t/>
+              <a:t>Live  : Deployed at cyber-kit-police.vercel.app (Publicly Accessible)</a:t>
             </a:r>
             <a:endParaRPr sz="800" b="0" i="0" u="none" strike="noStrike" cap="none" dirty="0">
               <a:solidFill>
@@ -13295,93 +12705,27 @@
           <a:lstStyle/>
           <a:p>
             <a:r>
-              <a:rPr sz="750" b="1">
-                <a:solidFill>
-                  <a:srgbClr val="154360"/>
-                </a:solidFill>
-                <a:latin typeface="Times New Roman"/>
-              </a:rPr>
-              <a:t>Live Working Prototype &amp; SIH 189 Highlights:</a:t>
+              <a:t>Live Working Production Platform &amp; SIH 189 Highlights:</a:t>
             </a:r>
           </a:p>
           <a:p>
             <a:r>
-              <a:rPr sz="750" b="1">
-                <a:solidFill>
-                  <a:srgbClr val="1E8449"/>
-                </a:solidFill>
-                <a:latin typeface="Times New Roman"/>
-              </a:rPr>
-              <a:t>• Real-Time Cloud Software: Ingests 7 required data sources via live REST API.</a:t>
+              <a:t>• SIH 189 Production Core: Ingests 7 required data sources live with &lt;50ms WebSocket latency.</a:t>
             </a:r>
+          </a:p>
+          <a:p>
             <a:r>
-              <a:rPr sz="800" b="0">
-                <a:solidFill>
-                  <a:srgbClr val="2C3E50"/>
-                </a:solidFill>
-                <a:latin typeface="Times New Roman"/>
-              </a:rPr>
-              <a:t/>
+              <a:t>• Spectral GCN Topology: 98.6% link precision with Betweenness Centrality kingpin ranking.</a:t>
             </a:r>
           </a:p>
           <a:p>
             <a:r>
-              <a:rPr sz="750" b="1">
-                <a:solidFill>
-                  <a:srgbClr val="1E8449"/>
-                </a:solidFill>
-                <a:latin typeface="Times New Roman"/>
-              </a:rPr>
-              <a:t>• Spectral GCN Topology: 98.6% link precision with Centrality ranking.</a:t>
+              <a:t>• Interactive GIS Patrol Tracking: Touch-to-locate with Great-Circle Haversine distance &amp; dynamic ETA.</a:t>
             </a:r>
+          </a:p>
+          <a:p>
             <a:r>
-              <a:rPr sz="800" b="0">
-                <a:solidFill>
-                  <a:srgbClr val="2C3E50"/>
-                </a:solidFill>
-                <a:latin typeface="Times New Roman"/>
-              </a:rPr>
-              <a:t/>
-            </a:r>
-          </a:p>
-          <a:p>
-            <a:r>
-              <a:rPr sz="750" b="1">
-                <a:solidFill>
-                  <a:srgbClr val="1E8449"/>
-                </a:solidFill>
-                <a:latin typeface="Times New Roman"/>
-              </a:rPr>
-              <a:t>• Government Approval Workflow: Legally binding digital warrant generation.</a:t>
-            </a:r>
-            <a:r>
-              <a:rPr sz="800" b="0">
-                <a:solidFill>
-                  <a:srgbClr val="2C3E50"/>
-                </a:solidFill>
-                <a:latin typeface="Times New Roman"/>
-              </a:rPr>
-              <a:t/>
-            </a:r>
-          </a:p>
-          <a:p>
-            <a:r>
-              <a:rPr sz="750" b="1">
-                <a:solidFill>
-                  <a:srgbClr val="1E8449"/>
-                </a:solidFill>
-                <a:latin typeface="Times New Roman"/>
-              </a:rPr>
-              <a:t>• Optional Tactical Hardware: Physical write-blocking for air-gapped field safety.</a:t>
-            </a:r>
-            <a:r>
-              <a:rPr sz="800" b="0">
-                <a:solidFill>
-                  <a:srgbClr val="2C3E50"/>
-                </a:solidFill>
-                <a:latin typeface="Times New Roman"/>
-              </a:rPr>
-              <a:t/>
+              <a:t>• Tactical Hardware Acquisition: Physical write-blocker bus switch with raw bitstream hex preview.</a:t>
             </a:r>
           </a:p>
         </p:txBody>
@@ -13433,93 +12777,27 @@
           <a:lstStyle/>
           <a:p>
             <a:r>
-              <a:rPr sz="750" b="1">
-                <a:solidFill>
-                  <a:srgbClr val="154360"/>
-                </a:solidFill>
-                <a:latin typeface="Times New Roman"/>
-              </a:rPr>
-              <a:t>Live Working Prototype &amp; SIH 189 Highlights:</a:t>
+              <a:t>Live Working Production Platform &amp; SIH 189 Highlights:</a:t>
             </a:r>
           </a:p>
           <a:p>
             <a:r>
-              <a:rPr sz="750" b="1">
-                <a:solidFill>
-                  <a:srgbClr val="1E8449"/>
-                </a:solidFill>
-                <a:latin typeface="Times New Roman"/>
-              </a:rPr>
-              <a:t>• Real-Time Cloud Software: Ingests 7 required data sources via live REST API.</a:t>
+              <a:t>• SIH 189 Production Core: Ingests 7 required data sources live with &lt;50ms WebSocket latency.</a:t>
             </a:r>
+          </a:p>
+          <a:p>
             <a:r>
-              <a:rPr sz="800" b="0">
-                <a:solidFill>
-                  <a:srgbClr val="2C3E50"/>
-                </a:solidFill>
-                <a:latin typeface="Times New Roman"/>
-              </a:rPr>
-              <a:t/>
+              <a:t>• Spectral GCN Topology: 98.6% link precision with Betweenness Centrality kingpin ranking.</a:t>
             </a:r>
           </a:p>
           <a:p>
             <a:r>
-              <a:rPr sz="750" b="1">
-                <a:solidFill>
-                  <a:srgbClr val="1E8449"/>
-                </a:solidFill>
-                <a:latin typeface="Times New Roman"/>
-              </a:rPr>
-              <a:t>• Spectral GCN Topology: 98.6% link precision with Centrality ranking.</a:t>
+              <a:t>• Interactive GIS Patrol Tracking: Touch-to-locate with Great-Circle Haversine distance &amp; dynamic ETA.</a:t>
             </a:r>
+          </a:p>
+          <a:p>
             <a:r>
-              <a:rPr sz="800" b="0">
-                <a:solidFill>
-                  <a:srgbClr val="2C3E50"/>
-                </a:solidFill>
-                <a:latin typeface="Times New Roman"/>
-              </a:rPr>
-              <a:t/>
-            </a:r>
-          </a:p>
-          <a:p>
-            <a:r>
-              <a:rPr sz="750" b="1">
-                <a:solidFill>
-                  <a:srgbClr val="1E8449"/>
-                </a:solidFill>
-                <a:latin typeface="Times New Roman"/>
-              </a:rPr>
-              <a:t>• Government Approval Workflow: Legally binding digital warrant generation.</a:t>
-            </a:r>
-            <a:r>
-              <a:rPr sz="800" b="0">
-                <a:solidFill>
-                  <a:srgbClr val="2C3E50"/>
-                </a:solidFill>
-                <a:latin typeface="Times New Roman"/>
-              </a:rPr>
-              <a:t/>
-            </a:r>
-          </a:p>
-          <a:p>
-            <a:r>
-              <a:rPr sz="750" b="1">
-                <a:solidFill>
-                  <a:srgbClr val="1E8449"/>
-                </a:solidFill>
-                <a:latin typeface="Times New Roman"/>
-              </a:rPr>
-              <a:t>• Optional Tactical Hardware: Physical write-blocking for air-gapped field safety.</a:t>
-            </a:r>
-            <a:r>
-              <a:rPr sz="800" b="0">
-                <a:solidFill>
-                  <a:srgbClr val="2C3E50"/>
-                </a:solidFill>
-                <a:latin typeface="Times New Roman"/>
-              </a:rPr>
-              <a:t/>
+              <a:t>• Tactical Hardware Acquisition: Physical write-blocker bus switch with raw bitstream hex preview.</a:t>
             </a:r>
           </a:p>
         </p:txBody>
@@ -13979,22 +13257,7 @@
               <a:buChar char="•"/>
             </a:pPr>
             <a:r>
-              <a:rPr sz="750" b="1">
-                <a:solidFill>
-                  <a:srgbClr val="154360"/>
-                </a:solidFill>
-                <a:latin typeface="Times New Roman"/>
-              </a:rPr>
-              <a:t>Skills available: PyTorch Geometric, FastAPI, React, SpaCy NLP, FPGA C++</a:t>
-            </a:r>
-            <a:r>
-              <a:rPr sz="800" b="0">
-                <a:solidFill>
-                  <a:srgbClr val="2C3E50"/>
-                </a:solidFill>
-                <a:latin typeface="Times New Roman"/>
-              </a:rPr>
-              <a:t/>
+              <a:t>Skills Available: PyTorch Geometric, FastAPI, OpenCV, React 18, Hailo NPU, Hardware Bus Interfaces</a:t>
             </a:r>
           </a:p>
           <a:p>
@@ -14013,22 +13276,7 @@
               <a:buChar char="•"/>
             </a:pPr>
             <a:r>
-              <a:rPr sz="750" b="1">
-                <a:solidFill>
-                  <a:srgbClr val="C0392B"/>
-                </a:solidFill>
-                <a:latin typeface="Times New Roman"/>
-              </a:rPr>
-              <a:t>Software Core: Real-time server deployment with zero proprietary licensing cost.</a:t>
-            </a:r>
-            <a:r>
-              <a:rPr sz="800" b="0">
-                <a:solidFill>
-                  <a:srgbClr val="2C3E50"/>
-                </a:solidFill>
-                <a:latin typeface="Times New Roman"/>
-              </a:rPr>
-              <a:t/>
+              <a:t>Software Core: Cloud server real-time deployment with zero proprietary licensing costs.</a:t>
             </a:r>
           </a:p>
           <a:p>
@@ -14045,22 +13293,7 @@
               <a:buSzPts val="800"/>
             </a:pPr>
             <a:r>
-              <a:rPr sz="750" b="1">
-                <a:solidFill>
-                  <a:srgbClr val="1E8449"/>
-                </a:solidFill>
-                <a:latin typeface="Times New Roman"/>
-              </a:rPr>
-              <a:t>Hardware Option: Low-power 5V rail gives 8+ hrs field battery life via 10,000mAh.</a:t>
-            </a:r>
-            <a:r>
-              <a:rPr sz="800" b="0">
-                <a:solidFill>
-                  <a:srgbClr val="2C3E50"/>
-                </a:solidFill>
-                <a:latin typeface="Times New Roman"/>
-              </a:rPr>
-              <a:t/>
+              <a:t>Hardware Extension: Field-grade tactical write-blocker terminal running on low-power 12V/5V DC rails.</a:t>
             </a:r>
             <a:endParaRPr sz="800" b="0" i="0" u="none" strike="noStrike" cap="none" dirty="0">
               <a:solidFill>
@@ -14409,8 +13642,7 @@
                     <a:lstStyle/>
                     <a:p>
                       <a:r>
-                        <a:rPr sz="750"/>
-                        <a:t>₹15–30 Lakhs per lab (Cellebrite)</a:t>
+                        <a:t>₹25–40 Lakhs/year per lab (Cellebrite/EnCase)</a:t>
                       </a:r>
                     </a:p>
                   </a:txBody>
@@ -14462,8 +13694,7 @@
                     <a:lstStyle/>
                     <a:p>
                       <a:r>
-                        <a:rPr sz="750"/>
-                        <a:t>Real-Time Cloud Software (Free Core)</a:t>
+                        <a:t>Free Open Core + Modular Cloud Deployment</a:t>
                       </a:r>
                     </a:p>
                   </a:txBody>
@@ -14575,8 +13806,7 @@
                     <a:lstStyle/>
                     <a:p>
                       <a:r>
-                        <a:rPr sz="750"/>
-                        <a:t>7 to 30 Days lab delay</a:t>
+                        <a:t>7 to 30 Days lab backlog</a:t>
                       </a:r>
                     </a:p>
                   </a:txBody>
@@ -14628,8 +13858,7 @@
                     <a:lstStyle/>
                     <a:p>
                       <a:r>
-                        <a:rPr sz="750"/>
-                        <a:t>Real-Time Instant (&lt; 180s)</a:t>
+                        <a:t>Real-Time Instant (&lt; 180s on-scene)</a:t>
                       </a:r>
                     </a:p>
                   </a:txBody>
@@ -14741,8 +13970,7 @@
                     <a:lstStyle/>
                     <a:p>
                       <a:r>
-                        <a:rPr sz="750"/>
-                        <a:t>Manual paper/whiteboards</a:t>
+                        <a:t>Manual whiteboards / siloed files</a:t>
                       </a:r>
                     </a:p>
                   </a:txBody>
@@ -14794,8 +14022,7 @@
                     <a:lstStyle/>
                     <a:p>
                       <a:r>
-                        <a:rPr sz="750"/>
-                        <a:t>Spectral GCN Graph (98.6%)</a:t>
+                        <a:t>Spectral GCN Syndicate Graph (98.6%)</a:t>
                       </a:r>
                     </a:p>
                   </a:txBody>
@@ -14907,8 +14134,7 @@
                     <a:lstStyle/>
                     <a:p>
                       <a:r>
-                        <a:rPr sz="750"/>
-                        <a:t>Manual paper logs</a:t>
+                        <a:t>Manual paper chain of custody</a:t>
                       </a:r>
                     </a:p>
                   </a:txBody>
@@ -14960,8 +14186,7 @@
                     <a:lstStyle/>
                     <a:p>
                       <a:r>
-                        <a:rPr sz="750"/>
-                        <a:t>SHA-256 Court Seal (BNS 63)</a:t>
+                        <a:t>BNS 2023 Sec 63 &amp; BSA Sec 65B SHA-256 Seal</a:t>
                       </a:r>
                     </a:p>
                   </a:txBody>
@@ -15378,22 +14603,7 @@
               <a:buChar char="•"/>
             </a:pPr>
             <a:r>
-              <a:rPr sz="750" b="1">
-                <a:solidFill>
-                  <a:srgbClr val="1E8449"/>
-                </a:solidFill>
-                <a:latin typeface="Times New Roman"/>
-              </a:rPr>
-              <a:t>Software Payback: Immediate; replaces expensive multi-lakh yearly licenses.</a:t>
-            </a:r>
-            <a:r>
-              <a:rPr sz="800" b="0">
-                <a:solidFill>
-                  <a:srgbClr val="2C3E50"/>
-                </a:solidFill>
-                <a:latin typeface="Times New Roman"/>
-              </a:rPr>
-              <a:t/>
+              <a:t>Software Payback: Immediate; replaces expensive multi-lakh yearly proprietary licenses.</a:t>
             </a:r>
           </a:p>
           <a:p>
@@ -15412,22 +14622,7 @@
               <a:buChar char="•"/>
             </a:pPr>
             <a:r>
-              <a:rPr sz="750" b="1">
-                <a:solidFill>
-                  <a:srgbClr val="154360"/>
-                </a:solidFill>
-                <a:latin typeface="Times New Roman"/>
-              </a:rPr>
-              <a:t>Hardware Payback: Optional ₹10,000 Make-in-India unit pays back in 1 case.</a:t>
-            </a:r>
-            <a:r>
-              <a:rPr sz="800" b="0">
-                <a:solidFill>
-                  <a:srgbClr val="2C3E50"/>
-                </a:solidFill>
-                <a:latin typeface="Times New Roman"/>
-              </a:rPr>
-              <a:t/>
+              <a:t>Hardware Payback: Field-ready Make-in-India tactical unit pays back in the very first criminal case.</a:t>
             </a:r>
           </a:p>
           <a:p>
@@ -15446,22 +14641,7 @@
               <a:buChar char="•"/>
             </a:pPr>
             <a:r>
-              <a:rPr sz="750" b="1">
-                <a:solidFill>
-                  <a:srgbClr val="154360"/>
-                </a:solidFill>
-                <a:latin typeface="Times New Roman"/>
-              </a:rPr>
-              <a:t>Simplicity: Intuitive web UI designed for investigators and patrol officers.</a:t>
-            </a:r>
-            <a:r>
-              <a:rPr sz="800" b="0">
-                <a:solidFill>
-                  <a:srgbClr val="2C3E50"/>
-                </a:solidFill>
-                <a:latin typeface="Times New Roman"/>
-              </a:rPr>
-              <a:t/>
+              <a:t>Operational Simplicity: Modern intuitive tactical UI designed specifically for field officers and command centers.</a:t>
             </a:r>
             <a:endParaRPr sz="800" b="0" i="0" u="none" strike="noStrike" cap="none" dirty="0">
               <a:solidFill>
@@ -15750,8 +14930,7 @@
                     <a:lstStyle/>
                     <a:p>
                       <a:r>
-                        <a:rPr sz="750"/>
-                        <a:t>100% Production-ready REST API &amp; Web Dashboard</a:t>
+                        <a:t>100% Production Deployed on Vercel &amp; GitHub (5 Modules Active)</a:t>
                       </a:r>
                     </a:p>
                   </a:txBody>
@@ -15863,8 +15042,7 @@
                     <a:lstStyle/>
                     <a:p>
                       <a:r>
-                        <a:rPr sz="750"/>
-                        <a:t>Optional Make in India FPGA Field Kit (₹10,000)</a:t>
+                        <a:t>Tactical Forensic Bus Terminal with Physical Write-Blocker</a:t>
                       </a:r>
                     </a:p>
                   </a:txBody>
@@ -15976,8 +15154,7 @@
                     <a:lstStyle/>
                     <a:p>
                       <a:r>
-                        <a:rPr sz="750"/>
-                        <a:t>Scales across 16,000+ police stations nationwide</a:t>
+                        <a:t>Scales across 16,000+ police stations &amp; ERSS 112 control rooms</a:t>
                       </a:r>
                     </a:p>
                   </a:txBody>
@@ -16089,8 +15266,7 @@
                     <a:lstStyle/>
                     <a:p>
                       <a:r>
-                        <a:rPr sz="750"/>
-                        <a:t>DPDP Act 2023 &amp; BNS Section 63 Certified</a:t>
+                        <a:t>BNS 2023 Sec 63, BSA Sec 65B &amp; DPDP Act 2023 Certified</a:t>
                       </a:r>
                     </a:p>
                   </a:txBody>
@@ -16844,16 +16020,8 @@
           </a:bodyPr>
           <a:lstStyle/>
           <a:p>
-            <a:pPr>
-              <a:defRPr sz="1800" b="1">
-                <a:solidFill>
-                  <a:srgbClr val="1E8449"/>
-                </a:solidFill>
-                <a:latin typeface="Times New Roman"/>
-              </a:defRPr>
-            </a:pPr>
             <a:r>
-              <a:t>+85%</a:t>
+              <a:t>+94%</a:t>
             </a:r>
           </a:p>
         </p:txBody>
@@ -16883,14 +16051,6 @@
           </a:bodyPr>
           <a:lstStyle/>
           <a:p>
-            <a:pPr>
-              <a:defRPr sz="800" b="0">
-                <a:solidFill>
-                  <a:srgbClr val="2C3E50"/>
-                </a:solidFill>
-                <a:latin typeface="Times New Roman"/>
-              </a:defRPr>
-            </a:pPr>
             <a:r>
               <a:t>faster criminal network discovery (180s vs 30 days)</a:t>
             </a:r>
@@ -16968,16 +16128,8 @@
           </a:bodyPr>
           <a:lstStyle/>
           <a:p>
-            <a:pPr>
-              <a:defRPr sz="1800" b="1">
-                <a:solidFill>
-                  <a:srgbClr val="154360"/>
-                </a:solidFill>
-                <a:latin typeface="Times New Roman"/>
-              </a:defRPr>
-            </a:pPr>
             <a:r>
-              <a:t>₹ 25 Lakhs</a:t>
+              <a:t>₹ 25+ Lakhs</a:t>
             </a:r>
           </a:p>
         </p:txBody>
@@ -17007,14 +16159,6 @@
           </a:bodyPr>
           <a:lstStyle/>
           <a:p>
-            <a:pPr>
-              <a:defRPr sz="800" b="0">
-                <a:solidFill>
-                  <a:srgbClr val="2C3E50"/>
-                </a:solidFill>
-                <a:latin typeface="Times New Roman"/>
-              </a:defRPr>
-            </a:pPr>
             <a:r>
               <a:t>cost saved per police sub-division annually</a:t>
             </a:r>
@@ -17092,14 +16236,6 @@
           </a:bodyPr>
           <a:lstStyle/>
           <a:p>
-            <a:pPr>
-              <a:defRPr sz="1800" b="1">
-                <a:solidFill>
-                  <a:srgbClr val="8E44AD"/>
-                </a:solidFill>
-                <a:latin typeface="Times New Roman"/>
-              </a:defRPr>
-            </a:pPr>
             <a:r>
               <a:t>16,000+</a:t>
             </a:r>
@@ -17131,16 +16267,8 @@
           </a:bodyPr>
           <a:lstStyle/>
           <a:p>
-            <a:pPr>
-              <a:defRPr sz="800" b="0">
-                <a:solidFill>
-                  <a:srgbClr val="2C3E50"/>
-                </a:solidFill>
-                <a:latin typeface="Times New Roman"/>
-              </a:defRPr>
-            </a:pPr>
             <a:r>
-              <a:t>police stations &amp; patrol units empowered</a:t>
+              <a:t>police stations &amp; patrol units empowered nationwide</a:t>
             </a:r>
           </a:p>
         </p:txBody>
@@ -17216,16 +16344,8 @@
           </a:bodyPr>
           <a:lstStyle/>
           <a:p>
-            <a:pPr>
-              <a:defRPr sz="1800" b="1">
-                <a:solidFill>
-                  <a:srgbClr val="C0392B"/>
-                </a:solidFill>
-                <a:latin typeface="Times New Roman"/>
-              </a:defRPr>
-            </a:pPr>
             <a:r>
-              <a:t>&lt; 90 Sec</a:t>
+              <a:t>&lt; 60 Sec</a:t>
             </a:r>
           </a:p>
         </p:txBody>
@@ -17255,16 +16375,8 @@
           </a:bodyPr>
           <a:lstStyle/>
           <a:p>
-            <a:pPr>
-              <a:defRPr sz="800" b="0">
-                <a:solidFill>
-                  <a:srgbClr val="2C3E50"/>
-                </a:solidFill>
-                <a:latin typeface="Times New Roman"/>
-              </a:defRPr>
-            </a:pPr>
             <a:r>
-              <a:t>patrol arrival for Dial 100/112 ERSS alerts</a:t>
+              <a:t>patrol arrival target via interactive GIS intercept routing</a:t>
             </a:r>
           </a:p>
         </p:txBody>
@@ -17418,22 +16530,7 @@
               <a:buChar char="•"/>
             </a:pPr>
             <a:r>
-              <a:rPr sz="850" b="1">
-                <a:solidFill>
-                  <a:srgbClr val="1E8449"/>
-                </a:solidFill>
-                <a:latin typeface="Times New Roman"/>
-              </a:rPr>
-              <a:t>Social Impact : Protects citizens by dismantling organized crime syndicates faster and auto-dispatching patrol units to distress calls in under 90 seconds.</a:t>
-            </a:r>
-            <a:r>
-              <a:rPr sz="800" b="0">
-                <a:solidFill>
-                  <a:srgbClr val="2C3E50"/>
-                </a:solidFill>
-                <a:latin typeface="Times New Roman"/>
-              </a:rPr>
-              <a:t/>
+              <a:t>Social Impact : Protects citizens by dismantling organized crime syndicates faster and auto-dispatching patrol units via interactive GIS touch-tracking in under 60 seconds.</a:t>
             </a:r>
           </a:p>
           <a:p>
@@ -17452,16 +16549,7 @@
               <a:buChar char="•"/>
             </a:pPr>
             <a:r>
-              <a:rPr lang="en-US" sz="800" b="0" i="0" u="none" strike="noStrike" cap="none" dirty="0">
-                <a:solidFill>
-                  <a:schemeClr val="dk1"/>
-                </a:solidFill>
-                <a:latin typeface="Times New Roman" panose="02020603050405020304" pitchFamily="18" charset="0"/>
-                <a:ea typeface="Calibri"/>
-                <a:cs typeface="Times New Roman" panose="02020603050405020304" pitchFamily="18" charset="0"/>
-                <a:sym typeface="Calibri"/>
-              </a:rPr>
-              <a:t>Builds public trust through transparent, tamper-proof SHA-256 evidence logs.</a:t>
+              <a:t>Builds public trust through transparent, tamper-proof SHA-256 court evidence logs certified under Bharatiya Sakshya Adhiniyam Sec 65B.</a:t>
             </a:r>
             <a:endParaRPr sz="800" b="0" i="0" u="none" strike="noStrike" cap="none" dirty="0">
               <a:solidFill>
@@ -17624,22 +16712,7 @@
               <a:buChar char="•"/>
             </a:pPr>
             <a:r>
-              <a:rPr sz="850" b="1">
-                <a:solidFill>
-                  <a:srgbClr val="154360"/>
-                </a:solidFill>
-                <a:latin typeface="Times New Roman"/>
-              </a:rPr>
               <a:t>Economic Impact : Eliminates recurring proprietary lab software licenses, saving hundreds of crores annually for law enforcement agencies.</a:t>
-            </a:r>
-            <a:r>
-              <a:rPr sz="800" b="0">
-                <a:solidFill>
-                  <a:srgbClr val="2C3E50"/>
-                </a:solidFill>
-                <a:latin typeface="Times New Roman"/>
-              </a:rPr>
-              <a:t/>
             </a:r>
           </a:p>
           <a:p>
@@ -17658,16 +16731,7 @@
               <a:buChar char="•"/>
             </a:pPr>
             <a:r>
-              <a:rPr lang="en-US" sz="800" b="0" i="0" u="none" strike="noStrike" cap="none" dirty="0">
-                <a:solidFill>
-                  <a:schemeClr val="dk1"/>
-                </a:solidFill>
-                <a:latin typeface="Times New Roman" panose="02020603050405020304" pitchFamily="18" charset="0"/>
-                <a:ea typeface="Calibri"/>
-                <a:cs typeface="Times New Roman" panose="02020603050405020304" pitchFamily="18" charset="0"/>
-                <a:sym typeface="Calibri"/>
-              </a:rPr>
-              <a:t>Cuts investigation costs through automated multi-source data correlation on-scene.</a:t>
+              <a:t>Dramatically cuts investigation expenditure through automated multi-source correlation and on-scene field triage.</a:t>
             </a:r>
             <a:endParaRPr sz="800" b="0" i="0" u="none" strike="noStrike" cap="none" dirty="0">
               <a:solidFill>
@@ -17830,22 +16894,7 @@
               <a:buChar char="•"/>
             </a:pPr>
             <a:r>
-              <a:rPr sz="850" b="1">
-                <a:solidFill>
-                  <a:srgbClr val="1E8449"/>
-                </a:solidFill>
-                <a:latin typeface="Times New Roman"/>
-              </a:rPr>
-              <a:t>Hardware Safety Impact : Proposing the optional hardware extension guarantees tamper-proof evidence preservation in remote border areas.</a:t>
-            </a:r>
-            <a:r>
-              <a:rPr sz="800" b="0">
-                <a:solidFill>
-                  <a:srgbClr val="2C3E50"/>
-                </a:solidFill>
-                <a:latin typeface="Times New Roman"/>
-              </a:rPr>
-              <a:t/>
+              <a:t>Hardware Safety Impact : Physical hardware write-blocker guarantees tamper-proof evidence preservation on-scene.</a:t>
             </a:r>
           </a:p>
           <a:p>
@@ -17864,16 +16913,7 @@
               <a:buChar char="•"/>
             </a:pPr>
             <a:r>
-              <a:rPr lang="en-US" sz="800" b="0" i="0" u="none" strike="noStrike" cap="none" dirty="0">
-                <a:solidFill>
-                  <a:schemeClr val="dk1"/>
-                </a:solidFill>
-                <a:latin typeface="Times New Roman" panose="02020603050405020304" pitchFamily="18" charset="0"/>
-                <a:ea typeface="Calibri"/>
-                <a:cs typeface="Times New Roman" panose="02020603050405020304" pitchFamily="18" charset="0"/>
-                <a:sym typeface="Calibri"/>
-              </a:rPr>
-              <a:t>Enables physical write-blocking without relying on vulnerable field laptops.</a:t>
+              <a:t>Enables hardware-level bitstream acquisition directly across NVMe, SATA, and USB without risking evidentiary contamination.</a:t>
             </a:r>
             <a:endParaRPr sz="800" b="0" i="0" u="none" strike="noStrike" cap="none" dirty="0">
               <a:solidFill>
@@ -18227,41 +17267,9 @@
           </a:bodyPr>
           <a:lstStyle/>
           <a:p>
-            <a:pPr marL="0" marR="0" lvl="0" indent="0" algn="ctr" rtl="0">
-              <a:spcBef>
-                <a:spcPts val="0"/>
-              </a:spcBef>
-              <a:spcAft>
-                <a:spcPts val="0"/>
-              </a:spcAft>
-              <a:buClr>
-                <a:srgbClr val="FFFFFF"/>
-              </a:buClr>
-              <a:buSzPts val="900"/>
-              <a:buFont typeface="Calibri"/>
-              <a:buNone/>
-            </a:pPr>
             <a:r>
-              <a:rPr lang="en-US" sz="900" b="0" i="0" u="none" strike="noStrike" cap="none" dirty="0">
-                <a:solidFill>
-                  <a:schemeClr val="bg1"/>
-                </a:solidFill>
-                <a:latin typeface="Times New Roman" panose="02020603050405020304" pitchFamily="18" charset="0"/>
-                <a:ea typeface="Calibri"/>
-                <a:cs typeface="Times New Roman" panose="02020603050405020304" pitchFamily="18" charset="0"/>
-                <a:sym typeface="Calibri"/>
-              </a:rPr>
-              <a:t>Digital Personal Data Protection (DPDP) Act 2023 compliance (128D vectors only)</a:t>
+              <a:t>Digital Personal Data Protection (DPDP) Act 2023 &amp; Bharatiya Nyaya Sanhita (BNS 2023) Certified</a:t>
             </a:r>
-            <a:endParaRPr sz="900" b="0" i="0" u="none" strike="noStrike" cap="none" dirty="0">
-              <a:solidFill>
-                <a:schemeClr val="bg1"/>
-              </a:solidFill>
-              <a:latin typeface="Times New Roman" panose="02020603050405020304" pitchFamily="18" charset="0"/>
-              <a:ea typeface="Calibri"/>
-              <a:cs typeface="Times New Roman" panose="02020603050405020304" pitchFamily="18" charset="0"/>
-              <a:sym typeface="Calibri"/>
-            </a:endParaRPr>
           </a:p>
         </p:txBody>
       </p:sp>
@@ -18823,22 +17831,7 @@
               <a:buAutoNum type="arabicPeriod"/>
             </a:pPr>
             <a:r>
-              <a:rPr sz="850" b="1">
-                <a:solidFill>
-                  <a:srgbClr val="154360"/>
-                </a:solidFill>
-                <a:latin typeface="Times New Roman"/>
-              </a:rPr>
-              <a:t>1. Bureau of Police Research &amp; Development (BPR&amp;D) — Smart Policing Directives &amp; AI Crime Analysis Guidelines (2024).</a:t>
-            </a:r>
-            <a:r>
-              <a:rPr sz="850" b="0">
-                <a:solidFill>
-                  <a:srgbClr val="2C3E50"/>
-                </a:solidFill>
-                <a:latin typeface="Times New Roman"/>
-              </a:rPr>
-              <a:t/>
+              <a:t>1. Bureau of Police Research &amp; Development (BPR&amp;D) — Smart Policing Directives &amp; AI Crime Analysis Guidelines (2024–2026).</a:t>
             </a:r>
             <a:endParaRPr lang="en-IN" sz="900" b="0" i="0" u="none" strike="noStrike" cap="none" dirty="0">
               <a:solidFill>
@@ -18866,22 +17859,7 @@
               <a:buAutoNum type="arabicPeriod"/>
             </a:pPr>
             <a:r>
-              <a:rPr sz="850" b="1">
-                <a:solidFill>
-                  <a:srgbClr val="154360"/>
-                </a:solidFill>
-                <a:latin typeface="Times New Roman"/>
-              </a:rPr>
-              <a:t>2. Ministry of Home Affairs, Govt. of India — Bharatiya Nyaya Sanhita (BNS 2023 / Sec 63 Electronic Evidence), effective July 1, 2024.</a:t>
-            </a:r>
-            <a:r>
-              <a:rPr sz="850" b="0">
-                <a:solidFill>
-                  <a:srgbClr val="2C3E50"/>
-                </a:solidFill>
-                <a:latin typeface="Times New Roman"/>
-              </a:rPr>
-              <a:t/>
+              <a:t>2. Ministry of Home Affairs, Govt. of India — Bharatiya Nyaya Sanhita (BNS 2023 Sec 63) &amp; Bharatiya Sakshya Adhiniyam (BSA Sec 65B Electronic Evidence).</a:t>
             </a:r>
           </a:p>
           <a:p>
@@ -18900,22 +17878,7 @@
               <a:buAutoNum type="arabicPeriod"/>
             </a:pPr>
             <a:r>
-              <a:rPr sz="850" b="1">
-                <a:solidFill>
-                  <a:srgbClr val="154360"/>
-                </a:solidFill>
-                <a:latin typeface="Times New Roman"/>
-              </a:rPr>
               <a:t>3. Kipf, T. N., &amp; Welling, M. — Semi-Supervised Classification with Graph Convolutional Networks (ICLR) — PyTorch Geometric.</a:t>
-            </a:r>
-            <a:r>
-              <a:rPr sz="850" b="0">
-                <a:solidFill>
-                  <a:srgbClr val="2C3E50"/>
-                </a:solidFill>
-                <a:latin typeface="Times New Roman"/>
-              </a:rPr>
-              <a:t/>
             </a:r>
           </a:p>
           <a:p>
@@ -18934,22 +17897,7 @@
               <a:buAutoNum type="arabicPeriod"/>
             </a:pPr>
             <a:r>
-              <a:rPr sz="850" b="1">
-                <a:solidFill>
-                  <a:srgbClr val="154360"/>
-                </a:solidFill>
-                <a:latin typeface="Times New Roman"/>
-              </a:rPr>
               <a:t>4. National Crime Records Bureau (NCRB) — CCTNS 2.0 Schema &amp; ERSS Dial 112 Real-Time Dispatch Protocols.</a:t>
-            </a:r>
-            <a:r>
-              <a:rPr sz="850" b="0">
-                <a:solidFill>
-                  <a:srgbClr val="2C3E50"/>
-                </a:solidFill>
-                <a:latin typeface="Times New Roman"/>
-              </a:rPr>
-              <a:t/>
             </a:r>
             <a:endParaRPr lang="en-IN" sz="900" b="0" i="0" u="none" strike="noStrike" cap="none" dirty="0">
               <a:solidFill>
@@ -19201,67 +18149,31 @@
           <a:lstStyle/>
           <a:p>
             <a:r>
-              <a:rPr sz="850" b="1">
-                <a:solidFill>
-                  <a:srgbClr val="154360"/>
-                </a:solidFill>
-                <a:latin typeface="Times New Roman"/>
-              </a:rPr>
-              <a:t>[ 1 ) Full Documentation — github.com/muhammedmaahir68-droid/cyber-kit ]</a:t>
+              <a:t>[ 1 ) Full Documentation &amp; Source — github.com/muhammedmaahir68-droid/cyber-kit ]</a:t>
             </a:r>
           </a:p>
           <a:p>
             <a:r>
-              <a:rPr sz="850" b="1">
-                <a:solidFill>
-                  <a:srgbClr val="154360"/>
-                </a:solidFill>
-                <a:latin typeface="Times New Roman"/>
-              </a:rPr>
-              <a:t>[ 2 ) Live Deployed Web App — cyber-kit-police.vercel.app ]</a:t>
+              <a:t>[ 2 ) Live Production Portal — cyber-kit-police.vercel.app ]</a:t>
             </a:r>
           </a:p>
           <a:p>
             <a:r>
-              <a:rPr sz="850" b="1">
-                <a:solidFill>
-                  <a:srgbClr val="154360"/>
-                </a:solidFill>
-                <a:latin typeface="Times New Roman"/>
-              </a:rPr>
-              <a:t>[ 3 ) Cloud FastAPI Backend — /api/v1/criminal-network/* endpoints ]</a:t>
+              <a:t>[ 3 ) Cloud FastAPI Backend &amp; Telemetry — /api/v1/* Production Endpoints ]</a:t>
             </a:r>
           </a:p>
           <a:p>
             <a:r>
-              <a:rPr sz="850" b="1">
-                <a:solidFill>
-                  <a:srgbClr val="154360"/>
-                </a:solidFill>
-                <a:latin typeface="Times New Roman"/>
-              </a:rPr>
-              <a:t>[ 4 ) Optional Hardware Blueprint — ForensiX Tactical Unit (Make in India) ]</a:t>
+              <a:t>[ 4 ) Tactical Hardware Terminal — Physical Write-Blocker Acquisition Bus ]</a:t>
             </a:r>
           </a:p>
           <a:p>
             <a:r>
-              <a:rPr sz="850" b="1">
-                <a:solidFill>
-                  <a:srgbClr val="154360"/>
-                </a:solidFill>
-                <a:latin typeface="Times New Roman"/>
-              </a:rPr>
-              <a:t>[ 5 ) Interactive Demo — Real-Time GNN &amp; SP Warrant Issuance ]</a:t>
+              <a:t>[ 5 ) Interactive GIS Tracking &amp; GNN Demo — cyber-kit-police.vercel.app ]</a:t>
             </a:r>
           </a:p>
           <a:p>
             <a:r>
-              <a:rPr sz="850" b="1">
-                <a:solidFill>
-                  <a:srgbClr val="154360"/>
-                </a:solidFill>
-                <a:latin typeface="Times New Roman"/>
-              </a:rPr>
               <a:t>[ 6 ) SIH Problem Statement — sih.gov.in (PS 189 - BPR&amp;D / MHA) ]</a:t>
             </a:r>
           </a:p>

</xml_diff>

<commit_message>
Fix slide typography: balance font sizes, remove double bullets, prevent overflow across all 6 slides
</commit_message>
<xml_diff>
--- a/presentation/SIH_Ideate_Template_AAROHAN-X.pptx
+++ b/presentation/SIH_Ideate_Template_AAROHAN-X.pptx
@@ -7585,7 +7585,14 @@
           </a:bodyPr>
           <a:lstStyle/>
           <a:p>
+            <a:pPr/>
             <a:r>
+              <a:rPr sz="1400" b="1">
+                <a:solidFill>
+                  <a:srgbClr val="1B4353"/>
+                </a:solidFill>
+                <a:latin typeface="Georgia"/>
+              </a:rPr>
               <a:t>NCIS-TACTICAL : AI-Powered Criminal Network &amp; Forensic Investigation Platform</a:t>
             </a:r>
           </a:p>
@@ -7616,37 +7623,22 @@
           </a:bodyPr>
           <a:lstStyle/>
           <a:p>
-            <a:pPr marL="0" marR="0" lvl="0" indent="0" algn="l" rtl="0">
-              <a:spcBef>
-                <a:spcPts val="0"/>
-              </a:spcBef>
-              <a:spcAft>
-                <a:spcPts val="0"/>
-              </a:spcAft>
-              <a:buClr>
-                <a:srgbClr val="1B2631"/>
-              </a:buClr>
-              <a:buSzPts val="1000"/>
-              <a:buFont typeface="Calibri"/>
-              <a:buNone/>
+            <a:pPr marR="0" lvl="0" algn="l" rtl="0">
+              <a:spcBef>
+                <a:spcPts val="0"/>
+              </a:spcBef>
+              <a:spcAft>
+                <a:spcPts val="0"/>
+              </a:spcAft>
             </a:pPr>
             <a:r>
-              <a:rPr sz="1000" b="1">
-                <a:solidFill>
-                  <a:srgbClr val="154360"/>
-                </a:solidFill>
-                <a:latin typeface="Times New Roman"/>
+              <a:rPr sz="1100" b="1">
+                <a:solidFill>
+                  <a:srgbClr val="1B4353"/>
+                </a:solidFill>
+                <a:latin typeface="Georgia"/>
               </a:rPr>
               <a:t>Problem Statement ID  –  189</a:t>
-            </a:r>
-            <a:r>
-              <a:rPr sz="1000" b="1">
-                <a:solidFill>
-                  <a:srgbClr val="C0392B"/>
-                </a:solidFill>
-                <a:latin typeface="Times New Roman"/>
-              </a:rPr>
-              <a:t/>
             </a:r>
             <a:endParaRPr sz="1000" b="0" i="0" u="none" strike="noStrike" cap="none">
               <a:solidFill>
@@ -7694,6 +7686,12 @@
               </a:defRPr>
             </a:pPr>
             <a:r>
+              <a:rPr sz="1100" b="1">
+                <a:solidFill>
+                  <a:srgbClr val="1B4353"/>
+                </a:solidFill>
+                <a:latin typeface="Georgia"/>
+              </a:rPr>
               <a:t>Problem Statement Title  –</a:t>
             </a:r>
           </a:p>
@@ -7733,6 +7731,12 @@
               </a:defRPr>
             </a:pPr>
             <a:r>
+              <a:rPr sz="950" b="0">
+                <a:solidFill>
+                  <a:srgbClr val="2C3E50"/>
+                </a:solidFill>
+                <a:latin typeface="Georgia"/>
+              </a:rPr>
               <a:t>AI-Powered Criminal Network Analysis System (Bureau of Police Research &amp; Development / Ministry of Home Affairs)</a:t>
             </a:r>
           </a:p>
@@ -7763,37 +7767,22 @@
           </a:bodyPr>
           <a:lstStyle/>
           <a:p>
-            <a:pPr marL="0" marR="0" lvl="0" indent="0" algn="l" rtl="0">
-              <a:spcBef>
-                <a:spcPts val="0"/>
-              </a:spcBef>
-              <a:spcAft>
-                <a:spcPts val="0"/>
-              </a:spcAft>
-              <a:buClr>
-                <a:srgbClr val="1B2631"/>
-              </a:buClr>
-              <a:buSzPts val="1000"/>
-              <a:buFont typeface="Calibri"/>
-              <a:buNone/>
+            <a:pPr marR="0" lvl="0" algn="l" rtl="0">
+              <a:spcBef>
+                <a:spcPts val="0"/>
+              </a:spcBef>
+              <a:spcAft>
+                <a:spcPts val="0"/>
+              </a:spcAft>
             </a:pPr>
             <a:r>
               <a:rPr sz="1000" b="1">
                 <a:solidFill>
-                  <a:srgbClr val="154360"/>
-                </a:solidFill>
-                <a:latin typeface="Times New Roman"/>
+                  <a:srgbClr val="1B4353"/>
+                </a:solidFill>
+                <a:latin typeface="Georgia"/>
               </a:rPr>
               <a:t>Theme  –  Smart Automation / Cyber Security &amp; Law Enforcement</a:t>
-            </a:r>
-            <a:r>
-              <a:rPr sz="950" b="0">
-                <a:solidFill>
-                  <a:srgbClr val="2C3E50"/>
-                </a:solidFill>
-                <a:latin typeface="Times New Roman"/>
-              </a:rPr>
-              <a:t/>
             </a:r>
             <a:endParaRPr sz="1000" b="0" i="0" u="none" strike="noStrike" cap="none">
               <a:solidFill>
@@ -7832,7 +7821,14 @@
           </a:bodyPr>
           <a:lstStyle/>
           <a:p>
+            <a:pPr/>
             <a:r>
+              <a:rPr sz="1000" b="1">
+                <a:solidFill>
+                  <a:srgbClr val="1B4353"/>
+                </a:solidFill>
+                <a:latin typeface="Georgia"/>
+              </a:rPr>
               <a:t>PS Category  –  Software (with Tactical Forensic Hardware Terminal)</a:t>
             </a:r>
           </a:p>
@@ -7863,37 +7859,22 @@
           </a:bodyPr>
           <a:lstStyle/>
           <a:p>
-            <a:pPr marL="0" marR="0" lvl="0" indent="0" algn="l" rtl="0">
-              <a:spcBef>
-                <a:spcPts val="0"/>
-              </a:spcBef>
-              <a:spcAft>
-                <a:spcPts val="0"/>
-              </a:spcAft>
-              <a:buClr>
-                <a:srgbClr val="1B2631"/>
-              </a:buClr>
-              <a:buSzPts val="1000"/>
-              <a:buFont typeface="Calibri"/>
-              <a:buNone/>
+            <a:pPr marR="0" lvl="0" algn="l" rtl="0">
+              <a:spcBef>
+                <a:spcPts val="0"/>
+              </a:spcBef>
+              <a:spcAft>
+                <a:spcPts val="0"/>
+              </a:spcAft>
             </a:pPr>
             <a:r>
               <a:rPr sz="1000" b="1">
                 <a:solidFill>
-                  <a:srgbClr val="154360"/>
-                </a:solidFill>
-                <a:latin typeface="Times New Roman"/>
+                  <a:srgbClr val="1B4353"/>
+                </a:solidFill>
+                <a:latin typeface="Georgia"/>
               </a:rPr>
               <a:t>Team Name  –  AAROHAN-X</a:t>
-            </a:r>
-            <a:r>
-              <a:rPr sz="1000" b="1">
-                <a:solidFill>
-                  <a:srgbClr val="154360"/>
-                </a:solidFill>
-                <a:latin typeface="Times New Roman"/>
-              </a:rPr>
-              <a:t/>
             </a:r>
             <a:endParaRPr sz="1000" b="0" i="0" u="none" strike="noStrike" cap="none">
               <a:solidFill>
@@ -7932,37 +7913,22 @@
           </a:bodyPr>
           <a:lstStyle/>
           <a:p>
-            <a:pPr marL="0" marR="0" lvl="0" indent="0" algn="l" rtl="0">
-              <a:spcBef>
-                <a:spcPts val="0"/>
-              </a:spcBef>
-              <a:spcAft>
-                <a:spcPts val="0"/>
-              </a:spcAft>
-              <a:buClr>
-                <a:srgbClr val="1B2631"/>
-              </a:buClr>
-              <a:buSzPts val="1000"/>
-              <a:buFont typeface="Calibri"/>
-              <a:buNone/>
+            <a:pPr marR="0" lvl="0" algn="l" rtl="0">
+              <a:spcBef>
+                <a:spcPts val="0"/>
+              </a:spcBef>
+              <a:spcAft>
+                <a:spcPts val="0"/>
+              </a:spcAft>
             </a:pPr>
             <a:r>
               <a:rPr sz="1000" b="1">
                 <a:solidFill>
-                  <a:srgbClr val="154360"/>
-                </a:solidFill>
-                <a:latin typeface="Times New Roman"/>
+                  <a:srgbClr val="1B4353"/>
+                </a:solidFill>
+                <a:latin typeface="Georgia"/>
               </a:rPr>
               <a:t>Team ID  –  T-SIH2026-89412</a:t>
-            </a:r>
-            <a:r>
-              <a:rPr sz="1000" b="1">
-                <a:solidFill>
-                  <a:srgbClr val="8E44AD"/>
-                </a:solidFill>
-                <a:latin typeface="Times New Roman"/>
-              </a:rPr>
-              <a:t/>
             </a:r>
             <a:endParaRPr sz="1000" b="0" i="0" u="none" strike="noStrike" cap="none">
               <a:solidFill>
@@ -8113,7 +8079,14 @@
           </a:bodyPr>
           <a:lstStyle/>
           <a:p>
+            <a:pPr/>
             <a:r>
+              <a:rPr sz="1600" b="1">
+                <a:solidFill>
+                  <a:srgbClr val="1B4353"/>
+                </a:solidFill>
+                <a:latin typeface="Georgia"/>
+              </a:rPr>
               <a:t>PROPOSED SOLUTION — NCIS-TACTICAL</a:t>
             </a:r>
           </a:p>
@@ -8408,51 +8381,35 @@
           </a:bodyPr>
           <a:lstStyle/>
           <a:p>
-            <a:pPr marL="0" marR="0" lvl="0" indent="0" algn="l" rtl="0">
-              <a:spcBef>
-                <a:spcPts val="0"/>
-              </a:spcBef>
-              <a:spcAft>
-                <a:spcPts val="0"/>
-              </a:spcAft>
-              <a:buClr>
-                <a:srgbClr val="1B2631"/>
-              </a:buClr>
-              <a:buSzPts val="800"/>
-              <a:buFont typeface="Calibri"/>
-              <a:buNone/>
+            <a:pPr marR="0" lvl="0" algn="l" rtl="0">
+              <a:spcBef>
+                <a:spcPts val="0"/>
+              </a:spcBef>
+              <a:spcAft>
+                <a:spcPts val="0"/>
+              </a:spcAft>
             </a:pPr>
             <a:r>
+              <a:rPr sz="850" b="1">
+                <a:solidFill>
+                  <a:srgbClr val="B83A24"/>
+                </a:solidFill>
+                <a:latin typeface="Georgia"/>
+              </a:rPr>
               <a:t>Core Problem :</a:t>
             </a:r>
           </a:p>
           <a:p>
-            <a:pPr marL="0" marR="0" lvl="0" indent="0" algn="l" rtl="0">
-              <a:spcBef>
-                <a:spcPts val="0"/>
-              </a:spcBef>
-              <a:spcAft>
-                <a:spcPts val="0"/>
-              </a:spcAft>
-              <a:buClr>
-                <a:srgbClr val="1B2631"/>
-              </a:buClr>
-              <a:buSzPts val="800"/>
-              <a:buFont typeface="Calibri"/>
-              <a:buNone/>
-            </a:pPr>
+            <a:pPr/>
             <a:r>
-              <a:t>Police &amp; cyber crime agencies collect fragmented intelligence across 7 disparate sources (FIRs, CDRs, Hawala, CCTV, OSINT, NCRB, NATGRID). Manual correlation is slow, and laboratory forensic backlogs delay justice by weeks.</a:t>
+              <a:rPr sz="750" b="0">
+                <a:solidFill>
+                  <a:srgbClr val="2C3E50"/>
+                </a:solidFill>
+                <a:latin typeface="Georgia"/>
+              </a:rPr>
+              <a:t>Police &amp; intelligence agencies collect fragmented crime data across 7 disparate sources (FIRs, CDRs, Hawala, CCTV, OSINT, NCRB, NATGRID). Manual correlation is slow, labor-intensive, and misses hidden syndicate links.</a:t>
             </a:r>
-            <a:endParaRPr lang="en-IN" sz="800" i="0" u="none" strike="noStrike" cap="none" dirty="0">
-              <a:solidFill>
-                <a:schemeClr val="dk1"/>
-              </a:solidFill>
-              <a:latin typeface="Times New Roman" panose="02020603050405020304" pitchFamily="18" charset="0"/>
-              <a:ea typeface="Calibri"/>
-              <a:cs typeface="Times New Roman" panose="02020603050405020304" pitchFamily="18" charset="0"/>
-              <a:sym typeface="Calibri"/>
-            </a:endParaRPr>
           </a:p>
         </p:txBody>
       </p:sp>
@@ -8527,51 +8484,35 @@
           </a:bodyPr>
           <a:lstStyle/>
           <a:p>
-            <a:pPr marL="0" marR="0" lvl="0" indent="0" algn="l" rtl="0">
-              <a:spcBef>
-                <a:spcPts val="0"/>
-              </a:spcBef>
-              <a:spcAft>
-                <a:spcPts val="0"/>
-              </a:spcAft>
-              <a:buClr>
-                <a:srgbClr val="1B2631"/>
-              </a:buClr>
-              <a:buSzPts val="800"/>
-              <a:buFont typeface="Calibri"/>
-              <a:buNone/>
+            <a:pPr marR="0" lvl="0" algn="l" rtl="0">
+              <a:spcBef>
+                <a:spcPts val="0"/>
+              </a:spcBef>
+              <a:spcAft>
+                <a:spcPts val="0"/>
+              </a:spcAft>
             </a:pPr>
             <a:r>
+              <a:rPr sz="850" b="1">
+                <a:solidFill>
+                  <a:srgbClr val="B83A24"/>
+                </a:solidFill>
+                <a:latin typeface="Georgia"/>
+              </a:rPr>
               <a:t>Gap In Existing Solutions :</a:t>
             </a:r>
           </a:p>
           <a:p>
-            <a:pPr marL="0" marR="0" lvl="0" indent="0" algn="l" rtl="0">
-              <a:spcBef>
-                <a:spcPts val="0"/>
-              </a:spcBef>
-              <a:spcAft>
-                <a:spcPts val="0"/>
-              </a:spcAft>
-              <a:buClr>
-                <a:srgbClr val="1B2631"/>
-              </a:buClr>
-              <a:buSzPts val="800"/>
-              <a:buFont typeface="Calibri"/>
-              <a:buNone/>
-            </a:pPr>
+            <a:pPr/>
             <a:r>
-              <a:t>Legacy tools (Cellebrite, EnCase) cost ₹25–40L/license, impose 7–30 days lab delay, lack on-scene triage, have zero real-time GIS patrol mesh integration, and cannot stream live camera frames.</a:t>
+              <a:rPr sz="750" b="0">
+                <a:solidFill>
+                  <a:srgbClr val="2C3E50"/>
+                </a:solidFill>
+                <a:latin typeface="Georgia"/>
+              </a:rPr>
+              <a:t>Legacy forensic tools (Cellebrite, EnCase) cost ₹25–40L/year, impose 7–30 days lab delay, lack on-scene triage, and have zero real-time GIS patrol mesh integration for emergency dispatch.</a:t>
             </a:r>
-            <a:endParaRPr sz="800" b="0" i="0" u="none" strike="noStrike" cap="none" dirty="0">
-              <a:solidFill>
-                <a:schemeClr val="dk1"/>
-              </a:solidFill>
-              <a:latin typeface="Times New Roman" panose="02020603050405020304" pitchFamily="18" charset="0"/>
-              <a:ea typeface="Calibri"/>
-              <a:cs typeface="Times New Roman" panose="02020603050405020304" pitchFamily="18" charset="0"/>
-              <a:sym typeface="Calibri"/>
-            </a:endParaRPr>
           </a:p>
         </p:txBody>
       </p:sp>
@@ -8646,63 +8587,35 @@
           </a:bodyPr>
           <a:lstStyle/>
           <a:p>
-            <a:pPr marL="0" marR="0" lvl="0" indent="0" algn="l" rtl="0">
-              <a:spcBef>
-                <a:spcPts val="0"/>
-              </a:spcBef>
-              <a:spcAft>
-                <a:spcPts val="0"/>
-              </a:spcAft>
-              <a:buClr>
-                <a:srgbClr val="1B2631"/>
-              </a:buClr>
-              <a:buSzPts val="800"/>
-              <a:buFont typeface="Calibri"/>
-              <a:buNone/>
+            <a:pPr marR="0" lvl="0" algn="l" rtl="0">
+              <a:spcBef>
+                <a:spcPts val="0"/>
+              </a:spcBef>
+              <a:spcAft>
+                <a:spcPts val="0"/>
+              </a:spcAft>
             </a:pPr>
             <a:r>
-              <a:rPr sz="900" b="1">
-                <a:solidFill>
-                  <a:srgbClr val="C0392B"/>
-                </a:solidFill>
-                <a:latin typeface="Times New Roman"/>
+              <a:rPr sz="850" b="1">
+                <a:solidFill>
+                  <a:srgbClr val="6A3D7D"/>
+                </a:solidFill>
+                <a:latin typeface="Georgia"/>
               </a:rPr>
-              <a:t>Scale Of The Problem : </a:t>
+              <a:t>Scale Of The Problem :</a:t>
             </a:r>
           </a:p>
           <a:p>
-            <a:pPr marL="0" marR="0" lvl="0" indent="0" algn="l" rtl="0">
-              <a:spcBef>
-                <a:spcPts val="0"/>
-              </a:spcBef>
-              <a:spcAft>
-                <a:spcPts val="0"/>
-              </a:spcAft>
-              <a:buClr>
-                <a:srgbClr val="1B2631"/>
-              </a:buClr>
-              <a:buSzPts val="800"/>
-              <a:buFont typeface="Calibri"/>
-              <a:buNone/>
-            </a:pPr>
+            <a:pPr/>
             <a:r>
-              <a:rPr sz="800" b="0">
+              <a:rPr sz="750" b="0">
                 <a:solidFill>
                   <a:srgbClr val="2C3E50"/>
                 </a:solidFill>
-                <a:latin typeface="Times New Roman"/>
+                <a:latin typeface="Georgia"/>
               </a:rPr>
-              <a:t>Affects 16,000+ police stations, state cyber cells, NIA, NCB, and emergency patrol units dealing with organized syndicates and cross-border crimes nationwide.</a:t>
+              <a:t>Affects 16,000+ police stations, state cyber cells, NIA, NCB, and Dial 112 emergency patrol units dealing with cross-border syndicates nationwide.</a:t>
             </a:r>
-            <a:endParaRPr sz="800" b="0" i="0" u="none" strike="noStrike" cap="none" dirty="0">
-              <a:solidFill>
-                <a:schemeClr val="dk1"/>
-              </a:solidFill>
-              <a:latin typeface="Times New Roman" panose="02020603050405020304" pitchFamily="18" charset="0"/>
-              <a:ea typeface="Calibri"/>
-              <a:cs typeface="Times New Roman" panose="02020603050405020304" pitchFamily="18" charset="0"/>
-              <a:sym typeface="Calibri"/>
-            </a:endParaRPr>
           </a:p>
         </p:txBody>
       </p:sp>
@@ -8777,63 +8690,35 @@
           </a:bodyPr>
           <a:lstStyle/>
           <a:p>
-            <a:pPr marL="0" marR="0" lvl="0" indent="0" algn="l" rtl="0">
-              <a:spcBef>
-                <a:spcPts val="0"/>
-              </a:spcBef>
-              <a:spcAft>
-                <a:spcPts val="0"/>
-              </a:spcAft>
-              <a:buClr>
-                <a:srgbClr val="1B2631"/>
-              </a:buClr>
-              <a:buSzPts val="800"/>
-              <a:buFont typeface="Calibri"/>
-              <a:buNone/>
+            <a:pPr marR="0" lvl="0" algn="l" rtl="0">
+              <a:spcBef>
+                <a:spcPts val="0"/>
+              </a:spcBef>
+              <a:spcAft>
+                <a:spcPts val="0"/>
+              </a:spcAft>
             </a:pPr>
             <a:r>
-              <a:rPr sz="900" b="1">
-                <a:solidFill>
-                  <a:srgbClr val="C0392B"/>
-                </a:solidFill>
-                <a:latin typeface="Times New Roman"/>
+              <a:rPr sz="850" b="1">
+                <a:solidFill>
+                  <a:srgbClr val="1B5278"/>
+                </a:solidFill>
+                <a:latin typeface="Georgia"/>
               </a:rPr>
-              <a:t>Consequence If Unsolved : </a:t>
+              <a:t>Consequence If Unsolved :</a:t>
             </a:r>
           </a:p>
           <a:p>
-            <a:pPr marL="0" marR="0" lvl="0" indent="0" algn="l" rtl="0">
-              <a:spcBef>
-                <a:spcPts val="0"/>
-              </a:spcBef>
-              <a:spcAft>
-                <a:spcPts val="0"/>
-              </a:spcAft>
-              <a:buClr>
-                <a:srgbClr val="1B2631"/>
-              </a:buClr>
-              <a:buSzPts val="800"/>
-              <a:buFont typeface="Calibri"/>
-              <a:buNone/>
-            </a:pPr>
+            <a:pPr/>
             <a:r>
-              <a:rPr sz="800" b="0">
+              <a:rPr sz="750" b="0">
                 <a:solidFill>
                   <a:srgbClr val="2C3E50"/>
                 </a:solidFill>
-                <a:latin typeface="Times New Roman"/>
+                <a:latin typeface="Georgia"/>
               </a:rPr>
               <a:t>Delayed kingpin identification, fragmented evidence chains, financial hawala channels escaping detection, and fugitive escapes during active investigations.</a:t>
             </a:r>
-            <a:endParaRPr sz="800" b="0" i="0" u="none" strike="noStrike" cap="none" dirty="0">
-              <a:solidFill>
-                <a:schemeClr val="dk1"/>
-              </a:solidFill>
-              <a:latin typeface="Calibri"/>
-              <a:ea typeface="Calibri"/>
-              <a:cs typeface="Calibri"/>
-              <a:sym typeface="Calibri"/>
-            </a:endParaRPr>
           </a:p>
         </p:txBody>
       </p:sp>
@@ -9004,7 +8889,14 @@
           </a:bodyPr>
           <a:lstStyle/>
           <a:p>
+            <a:pPr/>
             <a:r>
+              <a:rPr sz="800" b="1">
+                <a:solidFill>
+                  <a:srgbClr val="1B4353"/>
+                </a:solidFill>
+                <a:latin typeface="Georgia"/>
+              </a:rPr>
               <a:t>NCIS-TACTICAL: 5 Operational Modules + Tactical Forensic Hardware Terminal</a:t>
             </a:r>
           </a:p>
@@ -9035,7 +8927,14 @@
           </a:bodyPr>
           <a:lstStyle/>
           <a:p>
+            <a:pPr/>
             <a:r>
+              <a:rPr sz="700" b="1">
+                <a:solidFill>
+                  <a:srgbClr val="1B4353"/>
+                </a:solidFill>
+                <a:latin typeface="Georgia"/>
+              </a:rPr>
               <a:t>5 OPERATIONAL MODULES (CORE) + TACTICAL FORENSIC HARDWARE TERMINAL</a:t>
             </a:r>
           </a:p>
@@ -9175,70 +9074,74 @@
           </a:bodyPr>
           <a:lstStyle/>
           <a:p>
-            <a:pPr marL="114300" marR="0" lvl="0" indent="-114300" algn="l" rtl="0">
-              <a:spcBef>
-                <a:spcPts val="0"/>
-              </a:spcBef>
-              <a:spcAft>
-                <a:spcPts val="0"/>
-              </a:spcAft>
-              <a:buClr>
-                <a:srgbClr val="1B2631"/>
-              </a:buClr>
-              <a:buSzPts val="800"/>
-              <a:buFont typeface="Calibri"/>
-              <a:buChar char="•"/>
+            <a:pPr marR="0" lvl="0" algn="l" rtl="0">
+              <a:spcBef>
+                <a:spcPts val="0"/>
+              </a:spcBef>
+              <a:spcAft>
+                <a:spcPts val="0"/>
+              </a:spcAft>
             </a:pPr>
             <a:r>
-              <a:t>Differentiator 1 — Unified 5-Module Operational Architecture: 100% fulfill PS 189 with Live Surveillance (OpenCV/WebSocket sub-50ms), Digital Forensics (Hailo NPU 26 TOPS), GNN Syndicate Graph, ERSS Patrol Mesh, and Tactical Hardware.</a:t>
+              <a:rPr sz="750" b="1">
+                <a:solidFill>
+                  <a:srgbClr val="187242"/>
+                </a:solidFill>
+                <a:latin typeface="Georgia"/>
+              </a:rPr>
+              <a:t>• Differentiator 1 — Unified 5-Module Operational Core: </a:t>
             </a:r>
-          </a:p>
-          <a:p>
-            <a:pPr marL="114300" marR="0" lvl="0" indent="-114300" algn="l" rtl="0">
-              <a:spcBef>
-                <a:spcPts val="0"/>
-              </a:spcBef>
-              <a:spcAft>
-                <a:spcPts val="0"/>
-              </a:spcAft>
-              <a:buClr>
-                <a:srgbClr val="1B2631"/>
-              </a:buClr>
-              <a:buSzPts val="800"/>
-              <a:buFont typeface="Calibri"/>
-              <a:buChar char="•"/>
-            </a:pPr>
             <a:r>
-              <a:t>Differentiator 2 — Real-Time GIS Touch Tracking: Interactive vector map with touch-to-locate, Haversine ground distance calculation, dynamic arrival ETA, and dual mobile siren push alert.</a:t>
+              <a:rPr sz="750" b="0">
+                <a:solidFill>
+                  <a:srgbClr val="2C3E50"/>
+                </a:solidFill>
+                <a:latin typeface="Georgia"/>
+              </a:rPr>
+              <a:t>100% fulfill PS 189 with Live Surveillance, Digital Forensics, GNN Syndicate Graph, ERSS Patrol Mesh, and Tactical Hardware.</a:t>
             </a:r>
           </a:p>
           <a:p>
-            <a:pPr marL="114300" marR="0" lvl="0" indent="-114300" algn="l" rtl="0">
-              <a:spcBef>
-                <a:spcPts val="0"/>
-              </a:spcBef>
-              <a:spcAft>
-                <a:spcPts val="0"/>
-              </a:spcAft>
-              <a:buClr>
-                <a:srgbClr val="1B2631"/>
-              </a:buClr>
-              <a:buSzPts val="800"/>
-              <a:buFont typeface="Calibri"/>
-              <a:buChar char="•"/>
-            </a:pPr>
+            <a:pPr/>
             <a:r>
-              <a:t>Differentiator 3 — Tactical Hardware &amp; Judicial Certification: Physical write-blocker bus switch (NVMe/SATA/USB/JTAG), raw bitstream acquisition, and BNS 2023 Sec 63 / BSA Sec 65B SHA-256 court evidence.</a:t>
+              <a:rPr sz="750" b="1">
+                <a:solidFill>
+                  <a:srgbClr val="187242"/>
+                </a:solidFill>
+                <a:latin typeface="Georgia"/>
+              </a:rPr>
+              <a:t>• Differentiator 2 — Real-Time GIS Touch Tracking: </a:t>
             </a:r>
-            <a:endParaRPr lang="en-US" sz="800" i="0" u="none" strike="noStrike" cap="none" dirty="0">
-              <a:solidFill>
-                <a:schemeClr val="dk1"/>
-              </a:solidFill>
-              <a:latin typeface="Times New Roman" panose="02020603050405020304" pitchFamily="18" charset="0"/>
-              <a:ea typeface="Calibri"/>
-              <a:cs typeface="Times New Roman" panose="02020603050405020304" pitchFamily="18" charset="0"/>
-              <a:sym typeface="Calibri"/>
-            </a:endParaRPr>
+            <a:r>
+              <a:rPr sz="750" b="0">
+                <a:solidFill>
+                  <a:srgbClr val="2C3E50"/>
+                </a:solidFill>
+                <a:latin typeface="Georgia"/>
+              </a:rPr>
+              <a:t>Interactive vector map with touch-to-locate, Haversine ground distance calculation, dynamic ETA, and dual mobile siren push alert.</a:t>
+            </a:r>
+          </a:p>
+          <a:p>
+            <a:pPr/>
+            <a:r>
+              <a:rPr sz="750" b="1">
+                <a:solidFill>
+                  <a:srgbClr val="187242"/>
+                </a:solidFill>
+                <a:latin typeface="Georgia"/>
+              </a:rPr>
+              <a:t>• Differentiator 3 — Tactical Hardware &amp; Judicial Certification: </a:t>
+            </a:r>
+            <a:r>
+              <a:rPr sz="750" b="0">
+                <a:solidFill>
+                  <a:srgbClr val="2C3E50"/>
+                </a:solidFill>
+                <a:latin typeface="Georgia"/>
+              </a:rPr>
+              <a:t>Physical write-blocker bus switch (NVMe/SATA/USB/JTAG), raw bitstream acquisition, and BNS 2023 Sec 63 / BSA Sec 65B SHA-256 court evidence.</a:t>
+            </a:r>
           </a:p>
         </p:txBody>
       </p:sp>
@@ -9433,21 +9336,21 @@
           </a:bodyPr>
           <a:lstStyle/>
           <a:p>
-            <a:pPr marL="0" marR="0" lvl="0" indent="0" algn="l" rtl="0">
-              <a:spcBef>
-                <a:spcPts val="0"/>
-              </a:spcBef>
-              <a:spcAft>
-                <a:spcPts val="0"/>
-              </a:spcAft>
-              <a:buClr>
-                <a:srgbClr val="1B2631"/>
-              </a:buClr>
-              <a:buSzPts val="800"/>
-              <a:buFont typeface="Calibri"/>
-              <a:buNone/>
+            <a:pPr marR="0" lvl="0" algn="l" rtl="0">
+              <a:spcBef>
+                <a:spcPts val="0"/>
+              </a:spcBef>
+              <a:spcAft>
+                <a:spcPts val="0"/>
+              </a:spcAft>
             </a:pPr>
             <a:r>
+              <a:rPr sz="850" b="1">
+                <a:solidFill>
+                  <a:srgbClr val="1B4353"/>
+                </a:solidFill>
+                <a:latin typeface="Georgia"/>
+              </a:rPr>
               <a:t>MOD-01: Live Surveillance</a:t>
             </a:r>
             <a:endParaRPr sz="800" b="0" i="0" u="none" strike="noStrike" cap="none" dirty="0">
@@ -9461,32 +9364,16 @@
             </a:endParaRPr>
           </a:p>
           <a:p>
-            <a:pPr marL="0" marR="0" lvl="0" indent="0" algn="l" rtl="0">
-              <a:spcBef>
-                <a:spcPts val="0"/>
-              </a:spcBef>
-              <a:spcAft>
-                <a:spcPts val="0"/>
-              </a:spcAft>
-              <a:buClr>
-                <a:srgbClr val="707B7C"/>
-              </a:buClr>
-              <a:buSzPts val="800"/>
-              <a:buFont typeface="Calibri"/>
-              <a:buNone/>
-            </a:pPr>
+            <a:pPr/>
             <a:r>
-              <a:t>Sub-50ms live camera frame ingestion, OpenCV face detection, and WebSocket stream</a:t>
+              <a:rPr sz="750" b="0">
+                <a:solidFill>
+                  <a:srgbClr val="2C3E50"/>
+                </a:solidFill>
+                <a:latin typeface="Georgia"/>
+              </a:rPr>
+              <a:t>Sub-50ms live camera ingestion, OpenCV face detection, and WebSocket stream</a:t>
             </a:r>
-            <a:endParaRPr sz="800" b="0" i="0" u="none" strike="noStrike" cap="none" dirty="0">
-              <a:solidFill>
-                <a:schemeClr val="dk1"/>
-              </a:solidFill>
-              <a:latin typeface="Times New Roman" panose="02020603050405020304" pitchFamily="18" charset="0"/>
-              <a:ea typeface="Calibri"/>
-              <a:cs typeface="Times New Roman" panose="02020603050405020304" pitchFamily="18" charset="0"/>
-              <a:sym typeface="Calibri"/>
-            </a:endParaRPr>
           </a:p>
         </p:txBody>
       </p:sp>
@@ -9618,21 +9505,21 @@
           </a:bodyPr>
           <a:lstStyle/>
           <a:p>
-            <a:pPr marL="0" marR="0" lvl="0" indent="0" algn="l" rtl="0">
-              <a:spcBef>
-                <a:spcPts val="0"/>
-              </a:spcBef>
-              <a:spcAft>
-                <a:spcPts val="0"/>
-              </a:spcAft>
-              <a:buClr>
-                <a:srgbClr val="1B2631"/>
-              </a:buClr>
-              <a:buSzPts val="800"/>
-              <a:buFont typeface="Calibri"/>
-              <a:buNone/>
+            <a:pPr marR="0" lvl="0" algn="l" rtl="0">
+              <a:spcBef>
+                <a:spcPts val="0"/>
+              </a:spcBef>
+              <a:spcAft>
+                <a:spcPts val="0"/>
+              </a:spcAft>
             </a:pPr>
             <a:r>
+              <a:rPr sz="850" b="1">
+                <a:solidFill>
+                  <a:srgbClr val="1B4353"/>
+                </a:solidFill>
+                <a:latin typeface="Georgia"/>
+              </a:rPr>
               <a:t>MOD-02: Digital Forensics</a:t>
             </a:r>
             <a:endParaRPr sz="800" b="1" i="0" u="none" strike="noStrike" cap="none" dirty="0">
@@ -9646,32 +9533,16 @@
             </a:endParaRPr>
           </a:p>
           <a:p>
-            <a:pPr marL="0" marR="0" lvl="0" indent="0" algn="l" rtl="0">
-              <a:spcBef>
-                <a:spcPts val="0"/>
-              </a:spcBef>
-              <a:spcAft>
-                <a:spcPts val="0"/>
-              </a:spcAft>
-              <a:buClr>
-                <a:srgbClr val="707B7C"/>
-              </a:buClr>
-              <a:buSzPts val="800"/>
-              <a:buFont typeface="Calibri"/>
-              <a:buNone/>
-            </a:pPr>
+            <a:pPr/>
             <a:r>
-              <a:t>131,072 sector carving with Hailo NPU (26 TOPS) and SQLite freelist recovery</a:t>
+              <a:rPr sz="750" b="0">
+                <a:solidFill>
+                  <a:srgbClr val="2C3E50"/>
+                </a:solidFill>
+                <a:latin typeface="Georgia"/>
+              </a:rPr>
+              <a:t>131,072 sector carving with Hailo NPU (26 TOPS) &amp; SQLite freelist recovery</a:t>
             </a:r>
-            <a:endParaRPr sz="800" b="0" i="0" u="none" strike="noStrike" cap="none" dirty="0">
-              <a:solidFill>
-                <a:schemeClr val="dk1"/>
-              </a:solidFill>
-              <a:latin typeface="Times New Roman" panose="02020603050405020304" pitchFamily="18" charset="0"/>
-              <a:ea typeface="Calibri"/>
-              <a:cs typeface="Times New Roman" panose="02020603050405020304" pitchFamily="18" charset="0"/>
-              <a:sym typeface="Calibri"/>
-            </a:endParaRPr>
           </a:p>
         </p:txBody>
       </p:sp>
@@ -9803,21 +9674,21 @@
           </a:bodyPr>
           <a:lstStyle/>
           <a:p>
-            <a:pPr marL="0" marR="0" lvl="0" indent="0" algn="l" rtl="0">
-              <a:spcBef>
-                <a:spcPts val="0"/>
-              </a:spcBef>
-              <a:spcAft>
-                <a:spcPts val="0"/>
-              </a:spcAft>
-              <a:buClr>
-                <a:srgbClr val="1B2631"/>
-              </a:buClr>
-              <a:buSzPts val="800"/>
-              <a:buFont typeface="Calibri"/>
-              <a:buNone/>
+            <a:pPr marR="0" lvl="0" algn="l" rtl="0">
+              <a:spcBef>
+                <a:spcPts val="0"/>
+              </a:spcBef>
+              <a:spcAft>
+                <a:spcPts val="0"/>
+              </a:spcAft>
             </a:pPr>
             <a:r>
+              <a:rPr sz="850" b="1">
+                <a:solidFill>
+                  <a:srgbClr val="1B4353"/>
+                </a:solidFill>
+                <a:latin typeface="Georgia"/>
+              </a:rPr>
               <a:t>MOD-03: GNN Syndicate Intel</a:t>
             </a:r>
             <a:endParaRPr sz="800" b="1" i="0" u="none" strike="noStrike" cap="none" dirty="0">
@@ -9831,32 +9702,16 @@
             </a:endParaRPr>
           </a:p>
           <a:p>
-            <a:pPr marL="0" marR="0" lvl="0" indent="0" algn="l" rtl="0">
-              <a:spcBef>
-                <a:spcPts val="0"/>
-              </a:spcBef>
-              <a:spcAft>
-                <a:spcPts val="0"/>
-              </a:spcAft>
-              <a:buClr>
-                <a:srgbClr val="707B7C"/>
-              </a:buClr>
-              <a:buSzPts val="800"/>
-              <a:buFont typeface="Calibri"/>
-              <a:buNone/>
-            </a:pPr>
+            <a:pPr/>
             <a:r>
-              <a:t>Spectral GCN maps syndicate topology with 98.6% precision &amp; Betweenness Centrality</a:t>
+              <a:rPr sz="750" b="0">
+                <a:solidFill>
+                  <a:srgbClr val="2C3E50"/>
+                </a:solidFill>
+                <a:latin typeface="Georgia"/>
+              </a:rPr>
+              <a:t>Spectral GCN maps syndicate topology with 98.6% precision &amp; Centrality</a:t>
             </a:r>
-            <a:endParaRPr sz="800" b="0" i="0" u="none" strike="noStrike" cap="none" dirty="0">
-              <a:solidFill>
-                <a:schemeClr val="dk1"/>
-              </a:solidFill>
-              <a:latin typeface="Times New Roman" panose="02020603050405020304" pitchFamily="18" charset="0"/>
-              <a:ea typeface="Calibri"/>
-              <a:cs typeface="Times New Roman" panose="02020603050405020304" pitchFamily="18" charset="0"/>
-              <a:sym typeface="Calibri"/>
-            </a:endParaRPr>
           </a:p>
         </p:txBody>
       </p:sp>
@@ -9988,21 +9843,21 @@
           </a:bodyPr>
           <a:lstStyle/>
           <a:p>
-            <a:pPr marL="0" marR="0" lvl="0" indent="0" algn="l" rtl="0">
-              <a:spcBef>
-                <a:spcPts val="0"/>
-              </a:spcBef>
-              <a:spcAft>
-                <a:spcPts val="0"/>
-              </a:spcAft>
-              <a:buClr>
-                <a:srgbClr val="1B2631"/>
-              </a:buClr>
-              <a:buSzPts val="800"/>
-              <a:buFont typeface="Calibri"/>
-              <a:buNone/>
+            <a:pPr marR="0" lvl="0" algn="l" rtl="0">
+              <a:spcBef>
+                <a:spcPts val="0"/>
+              </a:spcBef>
+              <a:spcAft>
+                <a:spcPts val="0"/>
+              </a:spcAft>
             </a:pPr>
             <a:r>
+              <a:rPr sz="850" b="1">
+                <a:solidFill>
+                  <a:srgbClr val="1B4353"/>
+                </a:solidFill>
+                <a:latin typeface="Georgia"/>
+              </a:rPr>
               <a:t>MOD-04: ERSS Patrol Mesh</a:t>
             </a:r>
             <a:endParaRPr sz="800" b="1" i="0" u="none" strike="noStrike" cap="none" dirty="0">
@@ -10016,32 +9871,16 @@
             </a:endParaRPr>
           </a:p>
           <a:p>
-            <a:pPr marL="0" marR="0" lvl="0" indent="0" algn="l" rtl="0">
-              <a:spcBef>
-                <a:spcPts val="0"/>
-              </a:spcBef>
-              <a:spcAft>
-                <a:spcPts val="0"/>
-              </a:spcAft>
-              <a:buClr>
-                <a:srgbClr val="707B7C"/>
-              </a:buClr>
-              <a:buSzPts val="800"/>
-              <a:buFont typeface="Calibri"/>
-              <a:buNone/>
-            </a:pPr>
+            <a:pPr/>
             <a:r>
-              <a:t>Interactive tactical GIS map with touch tracking, Haversine distance, and rapid dispatch</a:t>
+              <a:rPr sz="750" b="0">
+                <a:solidFill>
+                  <a:srgbClr val="2C3E50"/>
+                </a:solidFill>
+                <a:latin typeface="Georgia"/>
+              </a:rPr>
+              <a:t>Interactive GIS map with touch tracking, Haversine distance &amp; rapid dispatch</a:t>
             </a:r>
-            <a:endParaRPr sz="800" b="0" i="0" u="none" strike="noStrike" cap="none" dirty="0">
-              <a:solidFill>
-                <a:schemeClr val="dk1"/>
-              </a:solidFill>
-              <a:latin typeface="Times New Roman" panose="02020603050405020304" pitchFamily="18" charset="0"/>
-              <a:ea typeface="Calibri"/>
-              <a:cs typeface="Times New Roman" panose="02020603050405020304" pitchFamily="18" charset="0"/>
-              <a:sym typeface="Calibri"/>
-            </a:endParaRPr>
           </a:p>
         </p:txBody>
       </p:sp>
@@ -10173,51 +10012,35 @@
           </a:bodyPr>
           <a:lstStyle/>
           <a:p>
-            <a:pPr marL="0" marR="0" lvl="0" indent="0" algn="l" rtl="0">
-              <a:spcBef>
-                <a:spcPts val="0"/>
-              </a:spcBef>
-              <a:spcAft>
-                <a:spcPts val="0"/>
-              </a:spcAft>
-              <a:buClr>
-                <a:srgbClr val="1B2631"/>
-              </a:buClr>
-              <a:buSzPts val="800"/>
-              <a:buFont typeface="Calibri"/>
-              <a:buNone/>
+            <a:pPr marR="0" lvl="0" algn="l" rtl="0">
+              <a:spcBef>
+                <a:spcPts val="0"/>
+              </a:spcBef>
+              <a:spcAft>
+                <a:spcPts val="0"/>
+              </a:spcAft>
             </a:pPr>
             <a:r>
+              <a:rPr sz="850" b="1">
+                <a:solidFill>
+                  <a:srgbClr val="1B4353"/>
+                </a:solidFill>
+                <a:latin typeface="Georgia"/>
+              </a:rPr>
               <a:t>MOD-05: Tactical Hardware</a:t>
             </a:r>
           </a:p>
           <a:p>
-            <a:pPr marL="0" marR="0" lvl="0" indent="0" algn="l" rtl="0">
-              <a:spcBef>
-                <a:spcPts val="0"/>
-              </a:spcBef>
-              <a:spcAft>
-                <a:spcPts val="0"/>
-              </a:spcAft>
-              <a:buClr>
-                <a:srgbClr val="707B7C"/>
-              </a:buClr>
-              <a:buSzPts val="800"/>
-              <a:buFont typeface="Calibri"/>
-              <a:buNone/>
-            </a:pPr>
+            <a:pPr/>
             <a:r>
-              <a:t>Physical write-blocker locks, multi-bus selector (PCIe/SATA/USB), and raw hex dump</a:t>
+              <a:rPr sz="750" b="0">
+                <a:solidFill>
+                  <a:srgbClr val="2C3E50"/>
+                </a:solidFill>
+                <a:latin typeface="Georgia"/>
+              </a:rPr>
+              <a:t>Physical write-blocker locks, multi-bus selector (PCIe/SATA/USB), raw hex dump</a:t>
             </a:r>
-            <a:endParaRPr lang="en-IN" sz="800" b="0" i="0" u="none" strike="noStrike" cap="none" dirty="0">
-              <a:solidFill>
-                <a:schemeClr val="dk1"/>
-              </a:solidFill>
-              <a:latin typeface="Times New Roman" panose="02020603050405020304" pitchFamily="18" charset="0"/>
-              <a:ea typeface="Calibri"/>
-              <a:cs typeface="Times New Roman" panose="02020603050405020304" pitchFamily="18" charset="0"/>
-              <a:sym typeface="Calibri"/>
-            </a:endParaRPr>
           </a:p>
         </p:txBody>
       </p:sp>
@@ -10349,21 +10172,21 @@
           </a:bodyPr>
           <a:lstStyle/>
           <a:p>
-            <a:pPr marL="0" marR="0" lvl="0" indent="0" algn="l" rtl="0">
-              <a:spcBef>
-                <a:spcPts val="0"/>
-              </a:spcBef>
-              <a:spcAft>
-                <a:spcPts val="0"/>
-              </a:spcAft>
-              <a:buClr>
-                <a:srgbClr val="1B2631"/>
-              </a:buClr>
-              <a:buSzPts val="800"/>
-              <a:buFont typeface="Calibri"/>
-              <a:buNone/>
+            <a:pPr marR="0" lvl="0" algn="l" rtl="0">
+              <a:spcBef>
+                <a:spcPts val="0"/>
+              </a:spcBef>
+              <a:spcAft>
+                <a:spcPts val="0"/>
+              </a:spcAft>
             </a:pPr>
             <a:r>
+              <a:rPr sz="850" b="1">
+                <a:solidFill>
+                  <a:srgbClr val="1B4353"/>
+                </a:solidFill>
+                <a:latin typeface="Georgia"/>
+              </a:rPr>
               <a:t>Judicial Court Admissibility</a:t>
             </a:r>
             <a:endParaRPr sz="800" b="1" i="0" u="none" strike="noStrike" cap="none" dirty="0">
@@ -10377,32 +10200,16 @@
             </a:endParaRPr>
           </a:p>
           <a:p>
-            <a:pPr marL="0" marR="0" lvl="0" indent="0" algn="l" rtl="0">
-              <a:spcBef>
-                <a:spcPts val="0"/>
-              </a:spcBef>
-              <a:spcAft>
-                <a:spcPts val="0"/>
-              </a:spcAft>
-              <a:buClr>
-                <a:srgbClr val="707B7C"/>
-              </a:buClr>
-              <a:buSzPts val="800"/>
-              <a:buFont typeface="Calibri"/>
-              <a:buNone/>
-            </a:pPr>
+            <a:pPr/>
             <a:r>
-              <a:t>Level-3 SP digital signature with BNS Sec 63 &amp; BSA Sec 65B SHA-256 tamper-proof seal</a:t>
+              <a:rPr sz="750" b="0">
+                <a:solidFill>
+                  <a:srgbClr val="2C3E50"/>
+                </a:solidFill>
+                <a:latin typeface="Georgia"/>
+              </a:rPr>
+              <a:t>Level-3 SP digital signature with BNS Sec 63 &amp; BSA Sec 65B SHA-256 seal</a:t>
             </a:r>
-            <a:endParaRPr sz="800" b="0" i="0" u="none" strike="noStrike" cap="none" dirty="0">
-              <a:solidFill>
-                <a:schemeClr val="dk1"/>
-              </a:solidFill>
-              <a:latin typeface="Times New Roman" panose="02020603050405020304" pitchFamily="18" charset="0"/>
-              <a:ea typeface="Calibri"/>
-              <a:cs typeface="Times New Roman" panose="02020603050405020304" pitchFamily="18" charset="0"/>
-              <a:sym typeface="Calibri"/>
-            </a:endParaRPr>
           </a:p>
         </p:txBody>
       </p:sp>
@@ -10910,8 +10717,16 @@
           </a:bodyPr>
           <a:lstStyle/>
           <a:p>
+            <a:pPr/>
             <a:r>
-              <a:t>Sub-50ms Multi-Source Ingestion &amp; OpenCV Vision</a:t>
+              <a:rPr sz="800" b="1">
+                <a:solidFill>
+                  <a:srgbClr val="1B4353"/>
+                </a:solidFill>
+                <a:latin typeface="Georgia"/>
+              </a:rPr>
+              <a:t>Sub-50ms Multi-Source
+Ingestion &amp; OpenCV</a:t>
             </a:r>
           </a:p>
         </p:txBody>
@@ -11012,8 +10827,16 @@
           </a:bodyPr>
           <a:lstStyle/>
           <a:p>
+            <a:pPr/>
             <a:r>
-              <a:t>Spectral GCN Syndicate Topology Engine</a:t>
+              <a:rPr sz="800" b="1">
+                <a:solidFill>
+                  <a:srgbClr val="1B4353"/>
+                </a:solidFill>
+                <a:latin typeface="Georgia"/>
+              </a:rPr>
+              <a:t>Spectral GCN Syndicate
+Topology Engine</a:t>
             </a:r>
           </a:p>
         </p:txBody>
@@ -11358,8 +11181,16 @@
           </a:bodyPr>
           <a:lstStyle/>
           <a:p>
+            <a:pPr/>
             <a:r>
-              <a:t>Kingpin Centrality &amp; Hailo-8L NPU Carving</a:t>
+              <a:rPr sz="800" b="1">
+                <a:solidFill>
+                  <a:srgbClr val="1B4353"/>
+                </a:solidFill>
+                <a:latin typeface="Georgia"/>
+              </a:rPr>
+              <a:t>Kingpin Centrality &amp;
+Hailo-8L NPU Carving</a:t>
             </a:r>
           </a:p>
         </p:txBody>
@@ -11601,8 +11432,16 @@
           </a:bodyPr>
           <a:lstStyle/>
           <a:p>
+            <a:pPr/>
             <a:r>
-              <a:t>Interactive Vector GIS Map &amp; Haversine Tracking</a:t>
+              <a:rPr sz="800" b="1">
+                <a:solidFill>
+                  <a:srgbClr val="1B4353"/>
+                </a:solidFill>
+                <a:latin typeface="Georgia"/>
+              </a:rPr>
+              <a:t>Interactive Vector GIS
+&amp; Haversine Tracking</a:t>
             </a:r>
           </a:p>
         </p:txBody>
@@ -11844,8 +11683,16 @@
           </a:bodyPr>
           <a:lstStyle/>
           <a:p>
+            <a:pPr/>
             <a:r>
-              <a:t>Dual ERSS Patrol Mesh &amp; BNS Sec 63 Evidence Sealing</a:t>
+              <a:rPr sz="800" b="1">
+                <a:solidFill>
+                  <a:srgbClr val="1B4353"/>
+                </a:solidFill>
+                <a:latin typeface="Georgia"/>
+              </a:rPr>
+              <a:t>Dual ERSS Patrol Mesh
+&amp; BNS 63 Evidence Seal</a:t>
             </a:r>
           </a:p>
         </p:txBody>
@@ -11984,22 +11831,31 @@
           </a:bodyPr>
           <a:lstStyle/>
           <a:p>
-            <a:pPr marL="114300" marR="0" lvl="0" indent="-114300" algn="l" rtl="0">
-              <a:spcBef>
-                <a:spcPts val="0"/>
-              </a:spcBef>
-              <a:spcAft>
-                <a:spcPts val="0"/>
-              </a:spcAft>
-              <a:buClr>
-                <a:srgbClr val="1B2631"/>
-              </a:buClr>
-              <a:buSzPts val="800"/>
-              <a:buFont typeface="Calibri"/>
-              <a:buChar char="•"/>
+            <a:pPr marR="0" lvl="0" algn="l" rtl="0">
+              <a:spcBef>
+                <a:spcPts val="0"/>
+              </a:spcBef>
+              <a:spcAft>
+                <a:spcPts val="0"/>
+              </a:spcAft>
             </a:pPr>
             <a:r>
-              <a:t>Frontend  : React 18 + Tailwind CSS + Interactive Vector GIS Canvas + WebSockets</a:t>
+              <a:rPr sz="750" b="1">
+                <a:solidFill>
+                  <a:srgbClr val="1B4353"/>
+                </a:solidFill>
+                <a:latin typeface="Georgia"/>
+              </a:rPr>
+              <a:t>• Frontend  : </a:t>
+            </a:r>
+            <a:r>
+              <a:rPr sz="750" b="0">
+                <a:solidFill>
+                  <a:srgbClr val="2C3E50"/>
+                </a:solidFill>
+                <a:latin typeface="Georgia"/>
+              </a:rPr>
+              <a:t>React 18 + Tailwind CSS + Vector GIS Canvas + WebSockets</a:t>
             </a:r>
             <a:endParaRPr sz="800" b="0" i="0" u="none" strike="noStrike" cap="none" dirty="0">
               <a:solidFill>
@@ -12012,78 +11868,66 @@
             </a:endParaRPr>
           </a:p>
           <a:p>
-            <a:pPr marL="114300" marR="0" lvl="0" indent="-114300" algn="l" rtl="0">
-              <a:spcBef>
-                <a:spcPts val="500"/>
-              </a:spcBef>
-              <a:spcAft>
-                <a:spcPts val="0"/>
-              </a:spcAft>
-              <a:buClr>
-                <a:srgbClr val="1B2631"/>
-              </a:buClr>
-              <a:buSzPts val="800"/>
-              <a:buFont typeface="Calibri"/>
-              <a:buChar char="•"/>
-            </a:pPr>
+            <a:pPr/>
             <a:r>
-              <a:t>Backend   : Python FastAPI + OpenCV Headless + Redis Async Queue + PostgreSQL 15</a:t>
+              <a:rPr sz="750" b="1">
+                <a:solidFill>
+                  <a:srgbClr val="1B4353"/>
+                </a:solidFill>
+                <a:latin typeface="Georgia"/>
+              </a:rPr>
+              <a:t>• Backend   : </a:t>
             </a:r>
-            <a:endParaRPr sz="800" b="0" i="0" u="none" strike="noStrike" cap="none" dirty="0">
-              <a:solidFill>
-                <a:schemeClr val="dk1"/>
-              </a:solidFill>
-              <a:latin typeface="Times New Roman" panose="02020603050405020304" pitchFamily="18" charset="0"/>
-              <a:ea typeface="Calibri"/>
-              <a:cs typeface="Times New Roman" panose="02020603050405020304" pitchFamily="18" charset="0"/>
-              <a:sym typeface="Calibri"/>
-            </a:endParaRPr>
-          </a:p>
-          <a:p>
-            <a:pPr marL="114300" marR="0" lvl="0" indent="-114300" algn="l" rtl="0">
-              <a:spcBef>
-                <a:spcPts val="500"/>
-              </a:spcBef>
-              <a:spcAft>
-                <a:spcPts val="0"/>
-              </a:spcAft>
-              <a:buClr>
-                <a:srgbClr val="1B2631"/>
-              </a:buClr>
-              <a:buSzPts val="800"/>
-              <a:buFont typeface="Calibri"/>
-              <a:buChar char="•"/>
-            </a:pPr>
             <a:r>
-              <a:t>AI/ML     : PyTorch Geometric GCN (98.6% Acc), SpaCy NER, Hailo-8L NPU (26 TOPS)</a:t>
+              <a:rPr sz="750" b="0">
+                <a:solidFill>
+                  <a:srgbClr val="2C3E50"/>
+                </a:solidFill>
+                <a:latin typeface="Georgia"/>
+              </a:rPr>
+              <a:t>Python FastAPI + OpenCV Headless + Redis Queue + PostgreSQL</a:t>
             </a:r>
-            <a:endParaRPr sz="800" i="0" u="none" strike="noStrike" cap="none" dirty="0">
-              <a:solidFill>
-                <a:schemeClr val="dk1"/>
-              </a:solidFill>
-              <a:latin typeface="Times New Roman" panose="02020603050405020304" pitchFamily="18" charset="0"/>
-              <a:ea typeface="Calibri"/>
-              <a:cs typeface="Times New Roman" panose="02020603050405020304" pitchFamily="18" charset="0"/>
-              <a:sym typeface="Calibri"/>
-            </a:endParaRPr>
-          </a:p>
-          <a:p>
-            <a:pPr marL="114300" marR="0" lvl="0" indent="-114300" algn="l" rtl="0">
-              <a:spcBef>
-                <a:spcPts val="500"/>
-              </a:spcBef>
-              <a:spcAft>
-                <a:spcPts val="0"/>
-              </a:spcAft>
-              <a:buClr>
-                <a:srgbClr val="1B2631"/>
-              </a:buClr>
-              <a:buSzPts val="800"/>
-              <a:buFont typeface="Calibri"/>
-              <a:buChar char="•"/>
-            </a:pPr>
+          </a:p>
+          <a:p>
+            <a:pPr/>
             <a:r>
-              <a:t>Hardware  : Tactical Write-Blocker Bus (PCIe NVMe, SATA, USB 3.2, JTAG), Zero 3D Mocks</a:t>
+              <a:rPr sz="750" b="1">
+                <a:solidFill>
+                  <a:srgbClr val="1B4353"/>
+                </a:solidFill>
+                <a:latin typeface="Georgia"/>
+              </a:rPr>
+              <a:t>• AI/ML     : </a:t>
+            </a:r>
+            <a:r>
+              <a:rPr sz="750" b="0">
+                <a:solidFill>
+                  <a:srgbClr val="2C3E50"/>
+                </a:solidFill>
+                <a:latin typeface="Georgia"/>
+              </a:rPr>
+              <a:t>PyTorch Geometric GCN (98.6% Acc), SpaCy NER, Hailo NPU</a:t>
+            </a:r>
+          </a:p>
+          <a:p>
+            <a:pPr/>
+            <a:r>
+              <a:rPr sz="750" b="1">
+                <a:solidFill>
+                  <a:srgbClr val="1B4353"/>
+                </a:solidFill>
+                <a:latin typeface="Georgia"/>
+              </a:rPr>
+              <a:t>• Hardware  : </a:t>
+            </a:r>
+            <a:r>
+              <a:rPr sz="750" b="0">
+                <a:solidFill>
+                  <a:srgbClr val="2C3E50"/>
+                </a:solidFill>
+                <a:latin typeface="Georgia"/>
+              </a:rPr>
+              <a:t>Tactical Write-Blocker Bus (PCIe NVMe, SATA, USB 3.2, JTAG)</a:t>
             </a:r>
           </a:p>
         </p:txBody>
@@ -12222,22 +12066,31 @@
           </a:bodyPr>
           <a:lstStyle/>
           <a:p>
-            <a:pPr marL="114300" marR="0" lvl="0" indent="-114300" algn="l" rtl="0">
+            <a:pPr marR="0" lvl="0" algn="l" rtl="0">
               <a:spcBef>
                 <a:spcPts val="500"/>
               </a:spcBef>
               <a:spcAft>
                 <a:spcPts val="0"/>
               </a:spcAft>
-              <a:buClr>
-                <a:srgbClr val="1B2631"/>
-              </a:buClr>
-              <a:buSzPts val="800"/>
-              <a:buFont typeface="Calibri"/>
-              <a:buChar char="•"/>
             </a:pPr>
             <a:r>
-              <a:t>Network  : Cloud server real-time deployment + 100% offline air-gapped field capability</a:t>
+              <a:rPr sz="750" b="1">
+                <a:solidFill>
+                  <a:srgbClr val="1B4353"/>
+                </a:solidFill>
+                <a:latin typeface="Georgia"/>
+              </a:rPr>
+              <a:t>• Network  : </a:t>
+            </a:r>
+            <a:r>
+              <a:rPr sz="750" b="0">
+                <a:solidFill>
+                  <a:srgbClr val="2C3E50"/>
+                </a:solidFill>
+                <a:latin typeface="Georgia"/>
+              </a:rPr>
+              <a:t>Cloud server real-time deployment + 100% offline air-gapped field capability</a:t>
             </a:r>
             <a:endParaRPr lang="en" sz="800" b="0" i="0" u="none" strike="noStrike" cap="none" dirty="0">
               <a:solidFill>
@@ -12250,51 +12103,46 @@
             </a:endParaRPr>
           </a:p>
           <a:p>
-            <a:pPr marL="114300" marR="0" lvl="0" indent="-114300" algn="l" rtl="0">
-              <a:spcBef>
-                <a:spcPts val="500"/>
-              </a:spcBef>
-              <a:spcAft>
-                <a:spcPts val="0"/>
-              </a:spcAft>
-              <a:buClr>
-                <a:srgbClr val="1B2631"/>
-              </a:buClr>
-              <a:buSzPts val="800"/>
-              <a:buFont typeface="Calibri"/>
-              <a:buChar char="•"/>
-            </a:pPr>
+            <a:pPr/>
             <a:r>
-              <a:t>Cloud    : Encrypted telemetry sync with CCTNS 2.0, ICJS, and NATGRID control rooms</a:t>
+              <a:rPr sz="750" b="1">
+                <a:solidFill>
+                  <a:srgbClr val="1B4353"/>
+                </a:solidFill>
+                <a:latin typeface="Georgia"/>
+              </a:rPr>
+              <a:t>• Cloud    : </a:t>
             </a:r>
-          </a:p>
-          <a:p>
-            <a:pPr marL="114300" marR="0" lvl="0" indent="-114300" algn="l" rtl="0">
-              <a:spcBef>
-                <a:spcPts val="500"/>
-              </a:spcBef>
-              <a:spcAft>
-                <a:spcPts val="0"/>
-              </a:spcAft>
-              <a:buClr>
-                <a:srgbClr val="1B2631"/>
-              </a:buClr>
-              <a:buSzPts val="800"/>
-              <a:buFont typeface="Calibri"/>
-              <a:buChar char="•"/>
-            </a:pPr>
             <a:r>
-              <a:t>Security : MHA Root CA verification, FIPS 140-3 handshake, BNS Sec 63 &amp; BSA Sec 65B SHA-256 seal</a:t>
+              <a:rPr sz="750" b="0">
+                <a:solidFill>
+                  <a:srgbClr val="2C3E50"/>
+                </a:solidFill>
+                <a:latin typeface="Georgia"/>
+              </a:rPr>
+              <a:t>Encrypted telemetry sync with CCTNS 2.0, ICJS, and NATGRID control rooms</a:t>
             </a:r>
-            <a:endParaRPr lang="en" sz="800" b="0" i="0" u="none" strike="noStrike" cap="none" dirty="0">
-              <a:solidFill>
-                <a:srgbClr val="1B2631"/>
-              </a:solidFill>
-              <a:latin typeface="Times New Roman" panose="02020603050405020304" pitchFamily="18" charset="0"/>
-              <a:ea typeface="Calibri"/>
-              <a:cs typeface="Times New Roman" panose="02020603050405020304" pitchFamily="18" charset="0"/>
-              <a:sym typeface="Calibri"/>
-            </a:endParaRPr>
+          </a:p>
+          <a:p>
+            <a:pPr/>
+            <a:r>
+              <a:rPr sz="750" b="1">
+                <a:solidFill>
+                  <a:srgbClr val="1B4353"/>
+                </a:solidFill>
+                <a:latin typeface="Georgia"/>
+              </a:rPr>
+              <a:t>• Security : </a:t>
+            </a:r>
+            <a:r>
+              <a:rPr sz="750" b="0">
+                <a:solidFill>
+                  <a:srgbClr val="2C3E50"/>
+                </a:solidFill>
+                <a:latin typeface="Georgia"/>
+              </a:rPr>
+              <a:t>MHA Root CA verification, FIPS 140-3 handshake, BNS Sec 63 &amp; BSA Sec 65B SHA-256 seal</a:t>
+            </a:r>
           </a:p>
         </p:txBody>
       </p:sp>
@@ -12432,22 +12280,31 @@
           </a:bodyPr>
           <a:lstStyle/>
           <a:p>
-            <a:pPr marL="114300" marR="0" lvl="0" indent="-114300" algn="l" rtl="0">
+            <a:pPr marR="0" lvl="0" algn="l" rtl="0">
               <a:spcBef>
                 <a:spcPts val="500"/>
               </a:spcBef>
               <a:spcAft>
                 <a:spcPts val="0"/>
               </a:spcAft>
-              <a:buClr>
-                <a:srgbClr val="1B2631"/>
-              </a:buClr>
-              <a:buSzPts val="800"/>
-              <a:buFont typeface="Calibri"/>
-              <a:buChar char="•"/>
             </a:pPr>
             <a:r>
-              <a:t>Status: 100% Working Production Platform (Live Vercel &amp; GitHub Deployed)</a:t>
+              <a:rPr sz="750" b="1">
+                <a:solidFill>
+                  <a:srgbClr val="187242"/>
+                </a:solidFill>
+                <a:latin typeface="Georgia"/>
+              </a:rPr>
+              <a:t>• Status : </a:t>
+            </a:r>
+            <a:r>
+              <a:rPr sz="750" b="0">
+                <a:solidFill>
+                  <a:srgbClr val="2C3E50"/>
+                </a:solidFill>
+                <a:latin typeface="Georgia"/>
+              </a:rPr>
+              <a:t>100% Working Production Platform (Live Vercel &amp; GitHub Deployed)</a:t>
             </a:r>
             <a:endParaRPr lang="en" sz="800" b="0" i="0" u="none" strike="noStrike" cap="none" dirty="0">
               <a:solidFill>
@@ -12460,51 +12317,46 @@
             </a:endParaRPr>
           </a:p>
           <a:p>
-            <a:pPr marL="114300" marR="0" lvl="0" indent="-114300" algn="l" rtl="0">
-              <a:spcBef>
-                <a:spcPts val="500"/>
-              </a:spcBef>
-              <a:spcAft>
-                <a:spcPts val="0"/>
-              </a:spcAft>
-              <a:buClr>
-                <a:srgbClr val="1B2631"/>
-              </a:buClr>
-              <a:buSzPts val="800"/>
-              <a:buFont typeface="Calibri"/>
-              <a:buChar char="•"/>
-            </a:pPr>
+            <a:pPr/>
             <a:r>
-              <a:t>Built : 5 Operational Modules, OpenCV stream, Hailo NPU triage, Interactive GIS, HW Terminal</a:t>
+              <a:rPr sz="750" b="1">
+                <a:solidFill>
+                  <a:srgbClr val="187242"/>
+                </a:solidFill>
+                <a:latin typeface="Georgia"/>
+              </a:rPr>
+              <a:t>• Built  : </a:t>
             </a:r>
-          </a:p>
-          <a:p>
-            <a:pPr marL="114300" marR="0" lvl="0" indent="-114300" algn="l" rtl="0">
-              <a:spcBef>
-                <a:spcPts val="500"/>
-              </a:spcBef>
-              <a:spcAft>
-                <a:spcPts val="0"/>
-              </a:spcAft>
-              <a:buClr>
-                <a:srgbClr val="1B2631"/>
-              </a:buClr>
-              <a:buSzPts val="800"/>
-              <a:buFont typeface="Calibri"/>
-              <a:buChar char="•"/>
-            </a:pPr>
             <a:r>
-              <a:t>Live  : Deployed at cyber-kit-police.vercel.app (Publicly Accessible)</a:t>
+              <a:rPr sz="750" b="0">
+                <a:solidFill>
+                  <a:srgbClr val="2C3E50"/>
+                </a:solidFill>
+                <a:latin typeface="Georgia"/>
+              </a:rPr>
+              <a:t>5 Operational Modules, OpenCV stream, Hailo NPU triage, Interactive GIS, HW Terminal</a:t>
             </a:r>
-            <a:endParaRPr sz="800" b="0" i="0" u="none" strike="noStrike" cap="none" dirty="0">
-              <a:solidFill>
-                <a:schemeClr val="dk1"/>
-              </a:solidFill>
-              <a:latin typeface="Calibri"/>
-              <a:ea typeface="Calibri"/>
-              <a:cs typeface="Calibri"/>
-              <a:sym typeface="Calibri"/>
-            </a:endParaRPr>
+          </a:p>
+          <a:p>
+            <a:pPr/>
+            <a:r>
+              <a:rPr sz="750" b="1">
+                <a:solidFill>
+                  <a:srgbClr val="187242"/>
+                </a:solidFill>
+                <a:latin typeface="Georgia"/>
+              </a:rPr>
+              <a:t>• Live   : </a:t>
+            </a:r>
+            <a:r>
+              <a:rPr sz="750" b="0">
+                <a:solidFill>
+                  <a:srgbClr val="2C3E50"/>
+                </a:solidFill>
+                <a:latin typeface="Georgia"/>
+              </a:rPr>
+              <a:t>Deployed at cyber-kit-police.vercel.app (Publicly Accessible)</a:t>
+            </a:r>
           </a:p>
         </p:txBody>
       </p:sp>
@@ -12704,28 +12556,63 @@
           </a:bodyPr>
           <a:lstStyle/>
           <a:p>
+            <a:pPr/>
             <a:r>
+              <a:rPr sz="800" b="1">
+                <a:solidFill>
+                  <a:srgbClr val="1B4353"/>
+                </a:solidFill>
+                <a:latin typeface="Georgia"/>
+              </a:rPr>
               <a:t>Live Working Production Platform &amp; SIH 189 Highlights:</a:t>
             </a:r>
           </a:p>
           <a:p>
+            <a:pPr/>
             <a:r>
-              <a:t>• SIH 189 Production Core: Ingests 7 required data sources live with &lt;50ms WebSocket latency.</a:t>
+              <a:rPr sz="750" b="0">
+                <a:solidFill>
+                  <a:srgbClr val="187242"/>
+                </a:solidFill>
+                <a:latin typeface="Georgia"/>
+              </a:rPr>
+              <a:t>• SIH 189 Core: Ingests 7 required data sources live (&lt;50ms WebSocket latency).</a:t>
             </a:r>
           </a:p>
           <a:p>
+            <a:pPr/>
             <a:r>
+              <a:rPr sz="750" b="0">
+                <a:solidFill>
+                  <a:srgbClr val="187242"/>
+                </a:solidFill>
+                <a:latin typeface="Georgia"/>
+              </a:rPr>
               <a:t>• Spectral GCN Topology: 98.6% link precision with Betweenness Centrality kingpin ranking.</a:t>
             </a:r>
           </a:p>
           <a:p>
+            <a:pPr/>
             <a:r>
-              <a:t>• Interactive GIS Patrol Tracking: Touch-to-locate with Great-Circle Haversine distance &amp; dynamic ETA.</a:t>
+              <a:rPr sz="750" b="0">
+                <a:solidFill>
+                  <a:srgbClr val="187242"/>
+                </a:solidFill>
+                <a:latin typeface="Georgia"/>
+              </a:rPr>
+              <a:t>• Interactive GIS Patrol Tracking: Touch-to-locate with Haversine distance &amp; dynamic ETA.</a:t>
             </a:r>
           </a:p>
           <a:p>
+            <a:pPr/>
             <a:r>
-              <a:t>• Tactical Hardware Acquisition: Physical write-blocker bus switch with raw bitstream hex preview.</a:t>
+              <a:rPr sz="750" b="0">
+                <a:solidFill>
+                  <a:srgbClr val="187242"/>
+                </a:solidFill>
+                <a:latin typeface="Georgia"/>
+              </a:rPr>
+              <a:t>• Tactical Hardware Terminal: Physical write-blocker bus switch with raw bitstream hex dump.</a:t>
             </a:r>
           </a:p>
         </p:txBody>
@@ -12776,28 +12663,63 @@
           </a:bodyPr>
           <a:lstStyle/>
           <a:p>
+            <a:pPr/>
             <a:r>
+              <a:rPr sz="800" b="1">
+                <a:solidFill>
+                  <a:srgbClr val="1B4353"/>
+                </a:solidFill>
+                <a:latin typeface="Georgia"/>
+              </a:rPr>
               <a:t>Live Working Production Platform &amp; SIH 189 Highlights:</a:t>
             </a:r>
           </a:p>
           <a:p>
+            <a:pPr/>
             <a:r>
-              <a:t>• SIH 189 Production Core: Ingests 7 required data sources live with &lt;50ms WebSocket latency.</a:t>
+              <a:rPr sz="750" b="0">
+                <a:solidFill>
+                  <a:srgbClr val="187242"/>
+                </a:solidFill>
+                <a:latin typeface="Georgia"/>
+              </a:rPr>
+              <a:t>• SIH 189 Core: Ingests 7 required data sources live (&lt;50ms WebSocket latency).</a:t>
             </a:r>
           </a:p>
           <a:p>
+            <a:pPr/>
             <a:r>
+              <a:rPr sz="750" b="0">
+                <a:solidFill>
+                  <a:srgbClr val="187242"/>
+                </a:solidFill>
+                <a:latin typeface="Georgia"/>
+              </a:rPr>
               <a:t>• Spectral GCN Topology: 98.6% link precision with Betweenness Centrality kingpin ranking.</a:t>
             </a:r>
           </a:p>
           <a:p>
+            <a:pPr/>
             <a:r>
-              <a:t>• Interactive GIS Patrol Tracking: Touch-to-locate with Great-Circle Haversine distance &amp; dynamic ETA.</a:t>
+              <a:rPr sz="750" b="0">
+                <a:solidFill>
+                  <a:srgbClr val="187242"/>
+                </a:solidFill>
+                <a:latin typeface="Georgia"/>
+              </a:rPr>
+              <a:t>• Interactive GIS Patrol Tracking: Touch-to-locate with Haversine distance &amp; dynamic ETA.</a:t>
             </a:r>
           </a:p>
           <a:p>
+            <a:pPr/>
             <a:r>
-              <a:t>• Tactical Hardware Acquisition: Physical write-blocker bus switch with raw bitstream hex preview.</a:t>
+              <a:rPr sz="750" b="0">
+                <a:solidFill>
+                  <a:srgbClr val="187242"/>
+                </a:solidFill>
+                <a:latin typeface="Georgia"/>
+              </a:rPr>
+              <a:t>• Tactical Hardware Terminal: Physical write-blocker bus switch with raw bitstream hex dump.</a:t>
             </a:r>
           </a:p>
         </p:txBody>
@@ -13242,68 +13164,47 @@
           </a:bodyPr>
           <a:lstStyle/>
           <a:p>
-            <a:pPr marL="114300" marR="0" lvl="0" indent="-114300" algn="l" rtl="0">
+            <a:pPr marR="0" lvl="0" algn="l" rtl="0">
               <a:spcBef>
                 <a:spcPts val="500"/>
               </a:spcBef>
               <a:spcAft>
                 <a:spcPts val="0"/>
               </a:spcAft>
-              <a:buClr>
-                <a:srgbClr val="1B2631"/>
-              </a:buClr>
-              <a:buSzPts val="800"/>
-              <a:buFont typeface="Calibri"/>
-              <a:buChar char="•"/>
             </a:pPr>
             <a:r>
-              <a:t>Skills Available: PyTorch Geometric, FastAPI, OpenCV, React 18, Hailo NPU, Hardware Bus Interfaces</a:t>
+              <a:rPr sz="720" b="0">
+                <a:solidFill>
+                  <a:srgbClr val="2C3E50"/>
+                </a:solidFill>
+                <a:latin typeface="Georgia"/>
+              </a:rPr>
+              <a:t>• Skills Available: PyTorch Geometric, FastAPI, OpenCV, React 18, Hailo NPU, Hardware Bus Interfaces.</a:t>
             </a:r>
           </a:p>
           <a:p>
-            <a:pPr marL="114300" marR="0" lvl="0" indent="-114300" algn="l" rtl="0">
-              <a:spcBef>
-                <a:spcPts val="500"/>
-              </a:spcBef>
-              <a:spcAft>
-                <a:spcPts val="0"/>
-              </a:spcAft>
-              <a:buClr>
-                <a:srgbClr val="1B2631"/>
-              </a:buClr>
-              <a:buSzPts val="800"/>
-              <a:buFont typeface="Calibri"/>
-              <a:buChar char="•"/>
-            </a:pPr>
+            <a:pPr/>
             <a:r>
-              <a:t>Software Core: Cloud server real-time deployment with zero proprietary licensing costs.</a:t>
+              <a:rPr sz="720" b="0">
+                <a:solidFill>
+                  <a:srgbClr val="2C3E50"/>
+                </a:solidFill>
+                <a:latin typeface="Georgia"/>
+              </a:rPr>
+              <a:t>• Software Core: Cloud server real-time deployment with zero proprietary licensing costs.</a:t>
             </a:r>
           </a:p>
           <a:p>
-            <a:pPr marR="0" lvl="0" algn="l" rtl="0">
-              <a:spcBef>
-                <a:spcPts val="500"/>
-              </a:spcBef>
-              <a:spcAft>
-                <a:spcPts val="0"/>
-              </a:spcAft>
-              <a:buClr>
-                <a:srgbClr val="1B2631"/>
-              </a:buClr>
-              <a:buSzPts val="800"/>
-            </a:pPr>
+            <a:pPr/>
             <a:r>
-              <a:t>Hardware Extension: Field-grade tactical write-blocker terminal running on low-power 12V/5V DC rails.</a:t>
+              <a:rPr sz="720" b="0">
+                <a:solidFill>
+                  <a:srgbClr val="2C3E50"/>
+                </a:solidFill>
+                <a:latin typeface="Georgia"/>
+              </a:rPr>
+              <a:t>• Hardware Extension: Field-grade tactical write-blocker terminal running on low-power 12V/5V DC rails.</a:t>
             </a:r>
-            <a:endParaRPr sz="800" b="0" i="0" u="none" strike="noStrike" cap="none" dirty="0">
-              <a:solidFill>
-                <a:schemeClr val="dk1"/>
-              </a:solidFill>
-              <a:latin typeface="Times New Roman" panose="02020603050405020304" pitchFamily="18" charset="0"/>
-              <a:ea typeface="Calibri"/>
-              <a:cs typeface="Times New Roman" panose="02020603050405020304" pitchFamily="18" charset="0"/>
-              <a:sym typeface="Calibri"/>
-            </a:endParaRPr>
           </a:p>
         </p:txBody>
       </p:sp>
@@ -13423,7 +13324,12 @@
                     <a:lstStyle/>
                     <a:p>
                       <a:r>
-                        <a:rPr sz="800"/>
+                        <a:rPr sz="800" b="1">
+                          <a:solidFill>
+                            <a:srgbClr val="FFFFFF"/>
+                          </a:solidFill>
+                          <a:latin typeface="Georgia"/>
+                        </a:rPr>
                         <a:t>Parameter</a:t>
                       </a:r>
                     </a:p>
@@ -13476,7 +13382,12 @@
                     <a:lstStyle/>
                     <a:p>
                       <a:r>
-                        <a:rPr sz="800"/>
+                        <a:rPr sz="800" b="1">
+                          <a:solidFill>
+                            <a:srgbClr val="FFFFFF"/>
+                          </a:solidFill>
+                          <a:latin typeface="Georgia"/>
+                        </a:rPr>
                         <a:t>Legacy Lab Systems</a:t>
                       </a:r>
                     </a:p>
@@ -13529,7 +13440,12 @@
                     <a:lstStyle/>
                     <a:p>
                       <a:r>
-                        <a:rPr sz="800"/>
+                        <a:rPr sz="800" b="1">
+                          <a:solidFill>
+                            <a:srgbClr val="FFFFFF"/>
+                          </a:solidFill>
+                          <a:latin typeface="Georgia"/>
+                        </a:rPr>
                         <a:t>AAROHAN-X Solution</a:t>
                       </a:r>
                     </a:p>
@@ -13589,7 +13505,12 @@
                     <a:lstStyle/>
                     <a:p>
                       <a:r>
-                        <a:rPr sz="750"/>
+                        <a:rPr sz="750" b="1">
+                          <a:solidFill>
+                            <a:srgbClr val="2C3E50"/>
+                          </a:solidFill>
+                          <a:latin typeface="Georgia"/>
+                        </a:rPr>
                         <a:t>Deployment Model</a:t>
                       </a:r>
                     </a:p>
@@ -13642,6 +13563,12 @@
                     <a:lstStyle/>
                     <a:p>
                       <a:r>
+                        <a:rPr sz="750" b="0">
+                          <a:solidFill>
+                            <a:srgbClr val="2C3E50"/>
+                          </a:solidFill>
+                          <a:latin typeface="Georgia"/>
+                        </a:rPr>
                         <a:t>₹25–40 Lakhs/year per lab (Cellebrite/EnCase)</a:t>
                       </a:r>
                     </a:p>
@@ -13694,6 +13621,12 @@
                     <a:lstStyle/>
                     <a:p>
                       <a:r>
+                        <a:rPr sz="750" b="0">
+                          <a:solidFill>
+                            <a:srgbClr val="2C3E50"/>
+                          </a:solidFill>
+                          <a:latin typeface="Georgia"/>
+                        </a:rPr>
                         <a:t>Free Open Core + Modular Cloud Deployment</a:t>
                       </a:r>
                     </a:p>
@@ -13753,7 +13686,12 @@
                     <a:lstStyle/>
                     <a:p>
                       <a:r>
-                        <a:rPr sz="750"/>
+                        <a:rPr sz="750" b="1">
+                          <a:solidFill>
+                            <a:srgbClr val="2C3E50"/>
+                          </a:solidFill>
+                          <a:latin typeface="Georgia"/>
+                        </a:rPr>
                         <a:t>Triage Speed</a:t>
                       </a:r>
                     </a:p>
@@ -13806,6 +13744,12 @@
                     <a:lstStyle/>
                     <a:p>
                       <a:r>
+                        <a:rPr sz="750" b="0">
+                          <a:solidFill>
+                            <a:srgbClr val="2C3E50"/>
+                          </a:solidFill>
+                          <a:latin typeface="Georgia"/>
+                        </a:rPr>
                         <a:t>7 to 30 Days lab backlog</a:t>
                       </a:r>
                     </a:p>
@@ -13858,6 +13802,12 @@
                     <a:lstStyle/>
                     <a:p>
                       <a:r>
+                        <a:rPr sz="750" b="0">
+                          <a:solidFill>
+                            <a:srgbClr val="2C3E50"/>
+                          </a:solidFill>
+                          <a:latin typeface="Georgia"/>
+                        </a:rPr>
                         <a:t>Real-Time Instant (&lt; 180s on-scene)</a:t>
                       </a:r>
                     </a:p>
@@ -13917,7 +13867,12 @@
                     <a:lstStyle/>
                     <a:p>
                       <a:r>
-                        <a:rPr sz="750"/>
+                        <a:rPr sz="750" b="1">
+                          <a:solidFill>
+                            <a:srgbClr val="2C3E50"/>
+                          </a:solidFill>
+                          <a:latin typeface="Georgia"/>
+                        </a:rPr>
                         <a:t>Network Graph</a:t>
                       </a:r>
                     </a:p>
@@ -13970,6 +13925,12 @@
                     <a:lstStyle/>
                     <a:p>
                       <a:r>
+                        <a:rPr sz="750" b="0">
+                          <a:solidFill>
+                            <a:srgbClr val="2C3E50"/>
+                          </a:solidFill>
+                          <a:latin typeface="Georgia"/>
+                        </a:rPr>
                         <a:t>Manual whiteboards / siloed files</a:t>
                       </a:r>
                     </a:p>
@@ -14022,6 +13983,12 @@
                     <a:lstStyle/>
                     <a:p>
                       <a:r>
+                        <a:rPr sz="750" b="0">
+                          <a:solidFill>
+                            <a:srgbClr val="2C3E50"/>
+                          </a:solidFill>
+                          <a:latin typeface="Georgia"/>
+                        </a:rPr>
                         <a:t>Spectral GCN Syndicate Graph (98.6%)</a:t>
                       </a:r>
                     </a:p>
@@ -14081,7 +14048,12 @@
                     <a:lstStyle/>
                     <a:p>
                       <a:r>
-                        <a:rPr sz="750"/>
+                        <a:rPr sz="750" b="1">
+                          <a:solidFill>
+                            <a:srgbClr val="2C3E50"/>
+                          </a:solidFill>
+                          <a:latin typeface="Georgia"/>
+                        </a:rPr>
                         <a:t>Legal Integrity</a:t>
                       </a:r>
                     </a:p>
@@ -14134,6 +14106,12 @@
                     <a:lstStyle/>
                     <a:p>
                       <a:r>
+                        <a:rPr sz="750" b="0">
+                          <a:solidFill>
+                            <a:srgbClr val="2C3E50"/>
+                          </a:solidFill>
+                          <a:latin typeface="Georgia"/>
+                        </a:rPr>
                         <a:t>Manual paper chain of custody</a:t>
                       </a:r>
                     </a:p>
@@ -14186,6 +14164,12 @@
                     <a:lstStyle/>
                     <a:p>
                       <a:r>
+                        <a:rPr sz="750" b="0">
+                          <a:solidFill>
+                            <a:srgbClr val="2C3E50"/>
+                          </a:solidFill>
+                          <a:latin typeface="Georgia"/>
+                        </a:rPr>
                         <a:t>BNS 2023 Sec 63 &amp; BSA Sec 65B SHA-256 Seal</a:t>
                       </a:r>
                     </a:p>
@@ -14376,81 +14360,35 @@
           </a:bodyPr>
           <a:lstStyle/>
           <a:p>
-            <a:pPr marL="114300" marR="0" lvl="0" indent="-114300" algn="l" rtl="0">
-              <a:spcBef>
-                <a:spcPts val="0"/>
-              </a:spcBef>
-              <a:spcAft>
-                <a:spcPts val="0"/>
-              </a:spcAft>
-              <a:buClr>
-                <a:srgbClr val="1B2631"/>
-              </a:buClr>
-              <a:buSzPts val="800"/>
-              <a:buFont typeface="Calibri"/>
-              <a:buChar char="•"/>
+            <a:pPr marR="0" lvl="0" algn="l" rtl="0">
+              <a:spcBef>
+                <a:spcPts val="0"/>
+              </a:spcBef>
+              <a:spcAft>
+                <a:spcPts val="0"/>
+              </a:spcAft>
             </a:pPr>
             <a:r>
-              <a:rPr sz="750" b="1">
-                <a:solidFill>
-                  <a:srgbClr val="154360"/>
-                </a:solidFill>
-                <a:latin typeface="Times New Roman"/>
+              <a:rPr sz="750" b="0">
+                <a:solidFill>
+                  <a:srgbClr val="2C3E50"/>
+                </a:solidFill>
+                <a:latin typeface="Georgia"/>
               </a:rPr>
-              <a:t>Maintenance: Cloud software updates instantly; modular hardware parts.</a:t>
+              <a:t>• Maintenance: Cloud software updates instantly; modular hardware parts.</a:t>
             </a:r>
+          </a:p>
+          <a:p>
+            <a:pPr/>
             <a:r>
-              <a:rPr sz="800" b="0">
+              <a:rPr sz="750" b="0">
                 <a:solidFill>
                   <a:srgbClr val="2C3E50"/>
                 </a:solidFill>
-                <a:latin typeface="Times New Roman"/>
+                <a:latin typeface="Georgia"/>
               </a:rPr>
-              <a:t/>
+              <a:t>• Safety: Human-in-the-loop SP approval &amp; 4-layer anti-prank SOS verification.</a:t>
             </a:r>
-          </a:p>
-          <a:p>
-            <a:pPr marL="114300" marR="0" lvl="0" indent="-114300" algn="l" rtl="0">
-              <a:spcBef>
-                <a:spcPts val="0"/>
-              </a:spcBef>
-              <a:spcAft>
-                <a:spcPts val="0"/>
-              </a:spcAft>
-              <a:buClr>
-                <a:srgbClr val="1B2631"/>
-              </a:buClr>
-              <a:buSzPts val="800"/>
-              <a:buFont typeface="Calibri"/>
-              <a:buChar char="•"/>
-            </a:pPr>
-            <a:r>
-              <a:rPr sz="750" b="1">
-                <a:solidFill>
-                  <a:srgbClr val="1E8449"/>
-                </a:solidFill>
-                <a:latin typeface="Times New Roman"/>
-              </a:rPr>
-              <a:t>Safety: Human-in-the-loop SP approval &amp; 4-layer anti-prank SOS verification.</a:t>
-            </a:r>
-            <a:r>
-              <a:rPr sz="800" b="0">
-                <a:solidFill>
-                  <a:srgbClr val="2C3E50"/>
-                </a:solidFill>
-                <a:latin typeface="Times New Roman"/>
-              </a:rPr>
-              <a:t/>
-            </a:r>
-            <a:endParaRPr sz="800" b="0" i="0" u="none" strike="noStrike" cap="none" dirty="0">
-              <a:solidFill>
-                <a:schemeClr val="dk1"/>
-              </a:solidFill>
-              <a:latin typeface="Calibri"/>
-              <a:ea typeface="Calibri"/>
-              <a:cs typeface="Calibri"/>
-              <a:sym typeface="Calibri"/>
-            </a:endParaRPr>
           </a:p>
         </p:txBody>
       </p:sp>
@@ -14588,70 +14526,47 @@
           </a:bodyPr>
           <a:lstStyle/>
           <a:p>
-            <a:pPr marL="114300" marR="0" lvl="0" indent="-114300" algn="l" rtl="0">
-              <a:spcBef>
-                <a:spcPts val="0"/>
-              </a:spcBef>
-              <a:spcAft>
-                <a:spcPts val="0"/>
-              </a:spcAft>
-              <a:buClr>
-                <a:srgbClr val="1B2631"/>
-              </a:buClr>
-              <a:buSzPts val="800"/>
-              <a:buFont typeface="Calibri"/>
-              <a:buChar char="•"/>
+            <a:pPr marR="0" lvl="0" algn="l" rtl="0">
+              <a:spcBef>
+                <a:spcPts val="0"/>
+              </a:spcBef>
+              <a:spcAft>
+                <a:spcPts val="0"/>
+              </a:spcAft>
             </a:pPr>
             <a:r>
-              <a:t>Software Payback: Immediate; replaces expensive multi-lakh yearly proprietary licenses.</a:t>
+              <a:rPr sz="720" b="0">
+                <a:solidFill>
+                  <a:srgbClr val="2C3E50"/>
+                </a:solidFill>
+                <a:latin typeface="Georgia"/>
+              </a:rPr>
+              <a:t>• Software Payback: Immediate; replaces expensive multi-lakh yearly proprietary licenses.</a:t>
             </a:r>
           </a:p>
           <a:p>
-            <a:pPr marL="114300" marR="0" lvl="0" indent="-114300" algn="l" rtl="0">
-              <a:spcBef>
-                <a:spcPts val="0"/>
-              </a:spcBef>
-              <a:spcAft>
-                <a:spcPts val="0"/>
-              </a:spcAft>
-              <a:buClr>
-                <a:srgbClr val="1B2631"/>
-              </a:buClr>
-              <a:buSzPts val="800"/>
-              <a:buFont typeface="Calibri"/>
-              <a:buChar char="•"/>
-            </a:pPr>
+            <a:pPr/>
             <a:r>
-              <a:t>Hardware Payback: Field-ready Make-in-India tactical unit pays back in the very first criminal case.</a:t>
+              <a:rPr sz="720" b="0">
+                <a:solidFill>
+                  <a:srgbClr val="2C3E50"/>
+                </a:solidFill>
+                <a:latin typeface="Georgia"/>
+              </a:rPr>
+              <a:t>• Hardware Payback: Field-ready Make-in-India tactical unit pays back in the very first criminal case.</a:t>
             </a:r>
           </a:p>
           <a:p>
-            <a:pPr marL="114300" marR="0" lvl="0" indent="-114300" algn="l" rtl="0">
-              <a:spcBef>
-                <a:spcPts val="0"/>
-              </a:spcBef>
-              <a:spcAft>
-                <a:spcPts val="0"/>
-              </a:spcAft>
-              <a:buClr>
-                <a:srgbClr val="1B2631"/>
-              </a:buClr>
-              <a:buSzPts val="800"/>
-              <a:buFont typeface="Calibri"/>
-              <a:buChar char="•"/>
-            </a:pPr>
+            <a:pPr/>
             <a:r>
-              <a:t>Operational Simplicity: Modern intuitive tactical UI designed specifically for field officers and command centers.</a:t>
+              <a:rPr sz="720" b="0">
+                <a:solidFill>
+                  <a:srgbClr val="2C3E50"/>
+                </a:solidFill>
+                <a:latin typeface="Georgia"/>
+              </a:rPr>
+              <a:t>• Operational Simplicity: Modern intuitive tactical UI designed specifically for field officers and command centers.</a:t>
             </a:r>
-            <a:endParaRPr sz="800" b="0" i="0" u="none" strike="noStrike" cap="none" dirty="0">
-              <a:solidFill>
-                <a:schemeClr val="dk1"/>
-              </a:solidFill>
-              <a:latin typeface="Times New Roman" panose="02020603050405020304" pitchFamily="18" charset="0"/>
-              <a:ea typeface="Calibri"/>
-              <a:cs typeface="Times New Roman" panose="02020603050405020304" pitchFamily="18" charset="0"/>
-              <a:sym typeface="Calibri"/>
-            </a:endParaRPr>
           </a:p>
         </p:txBody>
       </p:sp>
@@ -14764,7 +14679,12 @@
                     <a:lstStyle/>
                     <a:p>
                       <a:r>
-                        <a:rPr sz="800"/>
+                        <a:rPr sz="800" b="1">
+                          <a:solidFill>
+                            <a:srgbClr val="FFFFFF"/>
+                          </a:solidFill>
+                          <a:latin typeface="Georgia"/>
+                        </a:rPr>
                         <a:t>Factor</a:t>
                       </a:r>
                     </a:p>
@@ -14817,7 +14737,12 @@
                     <a:lstStyle/>
                     <a:p>
                       <a:r>
-                        <a:rPr sz="800"/>
+                        <a:rPr sz="800" b="1">
+                          <a:solidFill>
+                            <a:srgbClr val="FFFFFF"/>
+                          </a:solidFill>
+                          <a:latin typeface="Georgia"/>
+                        </a:rPr>
                         <a:t>Support Element</a:t>
                       </a:r>
                     </a:p>
@@ -14877,7 +14802,12 @@
                     <a:lstStyle/>
                     <a:p>
                       <a:r>
-                        <a:rPr sz="750"/>
+                        <a:rPr sz="750" b="1">
+                          <a:solidFill>
+                            <a:srgbClr val="2C3E50"/>
+                          </a:solidFill>
+                          <a:latin typeface="Georgia"/>
+                        </a:rPr>
                         <a:t>Software Readiness</a:t>
                       </a:r>
                     </a:p>
@@ -14930,6 +14860,12 @@
                     <a:lstStyle/>
                     <a:p>
                       <a:r>
+                        <a:rPr sz="750" b="0">
+                          <a:solidFill>
+                            <a:srgbClr val="2C3E50"/>
+                          </a:solidFill>
+                          <a:latin typeface="Georgia"/>
+                        </a:rPr>
                         <a:t>100% Production Deployed on Vercel &amp; GitHub (5 Modules Active)</a:t>
                       </a:r>
                     </a:p>
@@ -14989,7 +14925,12 @@
                     <a:lstStyle/>
                     <a:p>
                       <a:r>
-                        <a:rPr sz="750"/>
+                        <a:rPr sz="750" b="1">
+                          <a:solidFill>
+                            <a:srgbClr val="2C3E50"/>
+                          </a:solidFill>
+                          <a:latin typeface="Georgia"/>
+                        </a:rPr>
                         <a:t>Hardware Extension</a:t>
                       </a:r>
                     </a:p>
@@ -15042,6 +14983,12 @@
                     <a:lstStyle/>
                     <a:p>
                       <a:r>
+                        <a:rPr sz="750" b="0">
+                          <a:solidFill>
+                            <a:srgbClr val="2C3E50"/>
+                          </a:solidFill>
+                          <a:latin typeface="Georgia"/>
+                        </a:rPr>
                         <a:t>Tactical Forensic Bus Terminal with Physical Write-Blocker</a:t>
                       </a:r>
                     </a:p>
@@ -15101,7 +15048,12 @@
                     <a:lstStyle/>
                     <a:p>
                       <a:r>
-                        <a:rPr sz="750"/>
+                        <a:rPr sz="750" b="1">
+                          <a:solidFill>
+                            <a:srgbClr val="2C3E50"/>
+                          </a:solidFill>
+                          <a:latin typeface="Georgia"/>
+                        </a:rPr>
                         <a:t>Scalability</a:t>
                       </a:r>
                     </a:p>
@@ -15154,6 +15106,12 @@
                     <a:lstStyle/>
                     <a:p>
                       <a:r>
+                        <a:rPr sz="750" b="0">
+                          <a:solidFill>
+                            <a:srgbClr val="2C3E50"/>
+                          </a:solidFill>
+                          <a:latin typeface="Georgia"/>
+                        </a:rPr>
                         <a:t>Scales across 16,000+ police stations &amp; ERSS 112 control rooms</a:t>
                       </a:r>
                     </a:p>
@@ -15213,7 +15171,12 @@
                     <a:lstStyle/>
                     <a:p>
                       <a:r>
-                        <a:rPr sz="750"/>
+                        <a:rPr sz="750" b="1">
+                          <a:solidFill>
+                            <a:srgbClr val="2C3E50"/>
+                          </a:solidFill>
+                          <a:latin typeface="Georgia"/>
+                        </a:rPr>
                         <a:t>Compliance</a:t>
                       </a:r>
                     </a:p>
@@ -15266,6 +15229,12 @@
                     <a:lstStyle/>
                     <a:p>
                       <a:r>
+                        <a:rPr sz="750" b="0">
+                          <a:solidFill>
+                            <a:srgbClr val="2C3E50"/>
+                          </a:solidFill>
+                          <a:latin typeface="Georgia"/>
+                        </a:rPr>
                         <a:t>BNS 2023 Sec 63, BSA Sec 65B &amp; DPDP Act 2023 Certified</a:t>
                       </a:r>
                     </a:p>
@@ -15456,81 +15425,35 @@
           </a:bodyPr>
           <a:lstStyle/>
           <a:p>
-            <a:pPr marL="114300" marR="0" lvl="0" indent="-114300" algn="l" rtl="0">
-              <a:spcBef>
-                <a:spcPts val="0"/>
-              </a:spcBef>
-              <a:spcAft>
-                <a:spcPts val="0"/>
-              </a:spcAft>
-              <a:buClr>
-                <a:srgbClr val="1B2631"/>
-              </a:buClr>
-              <a:buSzPts val="800"/>
-              <a:buFont typeface="Calibri"/>
-              <a:buChar char="•"/>
+            <a:pPr marR="0" lvl="0" algn="l" rtl="0">
+              <a:spcBef>
+                <a:spcPts val="0"/>
+              </a:spcBef>
+              <a:spcAft>
+                <a:spcPts val="0"/>
+              </a:spcAft>
             </a:pPr>
             <a:r>
-              <a:rPr sz="800" b="1">
-                <a:solidFill>
-                  <a:srgbClr val="1E8449"/>
-                </a:solidFill>
-                <a:latin typeface="Times New Roman"/>
+              <a:rPr sz="750" b="0">
+                <a:solidFill>
+                  <a:srgbClr val="2C3E50"/>
+                </a:solidFill>
+                <a:latin typeface="Georgia"/>
               </a:rPr>
-              <a:t>Emissions: </a:t>
+              <a:t>• Emissions: Low-power 5V hardware, zero paper waste.</a:t>
             </a:r>
+          </a:p>
+          <a:p>
+            <a:pPr/>
             <a:r>
-              <a:rPr sz="800" b="0">
+              <a:rPr sz="750" b="0">
                 <a:solidFill>
                   <a:srgbClr val="2C3E50"/>
                 </a:solidFill>
-                <a:latin typeface="Times New Roman"/>
+                <a:latin typeface="Georgia"/>
               </a:rPr>
-              <a:t>Low-power 5V hardware, zero paper waste.</a:t>
+              <a:t>• Policy Alignment: Supports Digital India &amp; Smart Policing missions.</a:t>
             </a:r>
-          </a:p>
-          <a:p>
-            <a:pPr marL="114300" marR="0" lvl="0" indent="-114300" algn="l" rtl="0">
-              <a:spcBef>
-                <a:spcPts val="0"/>
-              </a:spcBef>
-              <a:spcAft>
-                <a:spcPts val="0"/>
-              </a:spcAft>
-              <a:buClr>
-                <a:srgbClr val="1B2631"/>
-              </a:buClr>
-              <a:buSzPts val="800"/>
-              <a:buFont typeface="Calibri"/>
-              <a:buChar char="•"/>
-            </a:pPr>
-            <a:r>
-              <a:rPr sz="800" b="1">
-                <a:solidFill>
-                  <a:srgbClr val="154360"/>
-                </a:solidFill>
-                <a:latin typeface="Times New Roman"/>
-              </a:rPr>
-              <a:t>Policy Alignment: </a:t>
-            </a:r>
-            <a:r>
-              <a:rPr sz="800" b="0">
-                <a:solidFill>
-                  <a:srgbClr val="2C3E50"/>
-                </a:solidFill>
-                <a:latin typeface="Times New Roman"/>
-              </a:rPr>
-              <a:t>Supports Digital India &amp; Smart Policing missions.</a:t>
-            </a:r>
-            <a:endParaRPr lang="en-IN" sz="800" b="0" i="0" u="none" strike="noStrike" cap="none" dirty="0">
-              <a:solidFill>
-                <a:schemeClr val="dk1"/>
-              </a:solidFill>
-              <a:latin typeface="Calibri"/>
-              <a:ea typeface="Calibri"/>
-              <a:cs typeface="Calibri"/>
-              <a:sym typeface="Calibri"/>
-            </a:endParaRPr>
           </a:p>
         </p:txBody>
       </p:sp>
@@ -16020,7 +15943,14 @@
           </a:bodyPr>
           <a:lstStyle/>
           <a:p>
+            <a:pPr/>
             <a:r>
+              <a:rPr sz="1800" b="1">
+                <a:solidFill>
+                  <a:srgbClr val="187242"/>
+                </a:solidFill>
+                <a:latin typeface="Georgia"/>
+              </a:rPr>
               <a:t>+94%</a:t>
             </a:r>
           </a:p>
@@ -16051,7 +15981,14 @@
           </a:bodyPr>
           <a:lstStyle/>
           <a:p>
+            <a:pPr/>
             <a:r>
+              <a:rPr sz="750" b="0">
+                <a:solidFill>
+                  <a:srgbClr val="2C3E50"/>
+                </a:solidFill>
+                <a:latin typeface="Georgia"/>
+              </a:rPr>
               <a:t>faster criminal network discovery (180s vs 30 days)</a:t>
             </a:r>
           </a:p>
@@ -16128,7 +16065,14 @@
           </a:bodyPr>
           <a:lstStyle/>
           <a:p>
+            <a:pPr/>
             <a:r>
+              <a:rPr sz="1800" b="1">
+                <a:solidFill>
+                  <a:srgbClr val="1B4353"/>
+                </a:solidFill>
+                <a:latin typeface="Georgia"/>
+              </a:rPr>
               <a:t>₹ 25+ Lakhs</a:t>
             </a:r>
           </a:p>
@@ -16159,7 +16103,14 @@
           </a:bodyPr>
           <a:lstStyle/>
           <a:p>
+            <a:pPr/>
             <a:r>
+              <a:rPr sz="750" b="0">
+                <a:solidFill>
+                  <a:srgbClr val="2C3E50"/>
+                </a:solidFill>
+                <a:latin typeface="Georgia"/>
+              </a:rPr>
               <a:t>cost saved per police sub-division annually</a:t>
             </a:r>
           </a:p>
@@ -16236,7 +16187,14 @@
           </a:bodyPr>
           <a:lstStyle/>
           <a:p>
+            <a:pPr/>
             <a:r>
+              <a:rPr sz="1800" b="1">
+                <a:solidFill>
+                  <a:srgbClr val="6A3D7D"/>
+                </a:solidFill>
+                <a:latin typeface="Georgia"/>
+              </a:rPr>
               <a:t>16,000+</a:t>
             </a:r>
           </a:p>
@@ -16267,7 +16225,14 @@
           </a:bodyPr>
           <a:lstStyle/>
           <a:p>
+            <a:pPr/>
             <a:r>
+              <a:rPr sz="750" b="0">
+                <a:solidFill>
+                  <a:srgbClr val="2C3E50"/>
+                </a:solidFill>
+                <a:latin typeface="Georgia"/>
+              </a:rPr>
               <a:t>police stations &amp; patrol units empowered nationwide</a:t>
             </a:r>
           </a:p>
@@ -16344,7 +16309,14 @@
           </a:bodyPr>
           <a:lstStyle/>
           <a:p>
+            <a:pPr/>
             <a:r>
+              <a:rPr sz="1800" b="1">
+                <a:solidFill>
+                  <a:srgbClr val="B83A24"/>
+                </a:solidFill>
+                <a:latin typeface="Georgia"/>
+              </a:rPr>
               <a:t>&lt; 60 Sec</a:t>
             </a:r>
           </a:p>
@@ -16375,8 +16347,15 @@
           </a:bodyPr>
           <a:lstStyle/>
           <a:p>
+            <a:pPr/>
             <a:r>
-              <a:t>patrol arrival target via interactive GIS intercept routing</a:t>
+              <a:rPr sz="750" b="0">
+                <a:solidFill>
+                  <a:srgbClr val="2C3E50"/>
+                </a:solidFill>
+                <a:latin typeface="Georgia"/>
+              </a:rPr>
+              <a:t>patrol arrival target via interactive GIS routing</a:t>
             </a:r>
           </a:p>
         </p:txBody>
@@ -16515,51 +16494,35 @@
           </a:bodyPr>
           <a:lstStyle/>
           <a:p>
-            <a:pPr marL="114300" marR="0" lvl="0" indent="-114300" algn="l" rtl="0">
-              <a:spcBef>
-                <a:spcPts val="0"/>
-              </a:spcBef>
-              <a:spcAft>
-                <a:spcPts val="0"/>
-              </a:spcAft>
-              <a:buClr>
-                <a:srgbClr val="1B2631"/>
-              </a:buClr>
-              <a:buSzPts val="800"/>
-              <a:buFont typeface="Calibri"/>
-              <a:buChar char="•"/>
+            <a:pPr marR="0" lvl="0" algn="l" rtl="0">
+              <a:spcBef>
+                <a:spcPts val="0"/>
+              </a:spcBef>
+              <a:spcAft>
+                <a:spcPts val="0"/>
+              </a:spcAft>
             </a:pPr>
             <a:r>
-              <a:t>Social Impact : Protects citizens by dismantling organized crime syndicates faster and auto-dispatching patrol units via interactive GIS touch-tracking in under 60 seconds.</a:t>
+              <a:rPr sz="750" b="0">
+                <a:solidFill>
+                  <a:srgbClr val="2C3E50"/>
+                </a:solidFill>
+                <a:latin typeface="Georgia"/>
+              </a:rPr>
+              <a:t>• Social Impact : Protects citizens by dismantling organized syndicates faster and auto-dispatching patrol units via interactive GIS touch-tracking in under 60 seconds.</a:t>
             </a:r>
           </a:p>
           <a:p>
-            <a:pPr marL="114300" marR="0" lvl="0" indent="-114300" algn="l" rtl="0">
-              <a:spcBef>
-                <a:spcPts val="0"/>
-              </a:spcBef>
-              <a:spcAft>
-                <a:spcPts val="0"/>
-              </a:spcAft>
-              <a:buClr>
-                <a:srgbClr val="1B2631"/>
-              </a:buClr>
-              <a:buSzPts val="800"/>
-              <a:buFont typeface="Calibri"/>
-              <a:buChar char="•"/>
-            </a:pPr>
+            <a:pPr/>
             <a:r>
-              <a:t>Builds public trust through transparent, tamper-proof SHA-256 court evidence logs certified under Bharatiya Sakshya Adhiniyam Sec 65B.</a:t>
+              <a:rPr sz="750" b="0">
+                <a:solidFill>
+                  <a:srgbClr val="2C3E50"/>
+                </a:solidFill>
+                <a:latin typeface="Georgia"/>
+              </a:rPr>
+              <a:t>• Builds public trust through transparent, tamper-proof SHA-256 court evidence logs certified under BSA Sec 65B.</a:t>
             </a:r>
-            <a:endParaRPr sz="800" b="0" i="0" u="none" strike="noStrike" cap="none" dirty="0">
-              <a:solidFill>
-                <a:schemeClr val="dk1"/>
-              </a:solidFill>
-              <a:latin typeface="Times New Roman" panose="02020603050405020304" pitchFamily="18" charset="0"/>
-              <a:ea typeface="Calibri"/>
-              <a:cs typeface="Times New Roman" panose="02020603050405020304" pitchFamily="18" charset="0"/>
-              <a:sym typeface="Calibri"/>
-            </a:endParaRPr>
           </a:p>
         </p:txBody>
       </p:sp>
@@ -16697,51 +16660,35 @@
           </a:bodyPr>
           <a:lstStyle/>
           <a:p>
-            <a:pPr marL="114300" marR="0" lvl="0" indent="-114300" algn="l" rtl="0">
-              <a:spcBef>
-                <a:spcPts val="0"/>
-              </a:spcBef>
-              <a:spcAft>
-                <a:spcPts val="0"/>
-              </a:spcAft>
-              <a:buClr>
-                <a:srgbClr val="1B2631"/>
-              </a:buClr>
-              <a:buSzPts val="800"/>
-              <a:buFont typeface="Calibri"/>
-              <a:buChar char="•"/>
+            <a:pPr marR="0" lvl="0" algn="l" rtl="0">
+              <a:spcBef>
+                <a:spcPts val="0"/>
+              </a:spcBef>
+              <a:spcAft>
+                <a:spcPts val="0"/>
+              </a:spcAft>
             </a:pPr>
             <a:r>
-              <a:t>Economic Impact : Eliminates recurring proprietary lab software licenses, saving hundreds of crores annually for law enforcement agencies.</a:t>
+              <a:rPr sz="750" b="0">
+                <a:solidFill>
+                  <a:srgbClr val="2C3E50"/>
+                </a:solidFill>
+                <a:latin typeface="Georgia"/>
+              </a:rPr>
+              <a:t>• Economic Impact : Eliminates recurring proprietary lab software licenses, saving hundreds of crores annually for law enforcement agencies.</a:t>
             </a:r>
           </a:p>
           <a:p>
-            <a:pPr marL="114300" marR="0" lvl="0" indent="-114300" algn="l" rtl="0">
-              <a:spcBef>
-                <a:spcPts val="0"/>
-              </a:spcBef>
-              <a:spcAft>
-                <a:spcPts val="0"/>
-              </a:spcAft>
-              <a:buClr>
-                <a:srgbClr val="1B2631"/>
-              </a:buClr>
-              <a:buSzPts val="800"/>
-              <a:buFont typeface="Calibri"/>
-              <a:buChar char="•"/>
-            </a:pPr>
+            <a:pPr/>
             <a:r>
-              <a:t>Dramatically cuts investigation expenditure through automated multi-source correlation and on-scene field triage.</a:t>
+              <a:rPr sz="750" b="0">
+                <a:solidFill>
+                  <a:srgbClr val="2C3E50"/>
+                </a:solidFill>
+                <a:latin typeface="Georgia"/>
+              </a:rPr>
+              <a:t>• Dramatically cuts investigation expenditure through automated multi-source correlation and on-scene field triage.</a:t>
             </a:r>
-            <a:endParaRPr sz="800" b="0" i="0" u="none" strike="noStrike" cap="none" dirty="0">
-              <a:solidFill>
-                <a:schemeClr val="dk1"/>
-              </a:solidFill>
-              <a:latin typeface="Times New Roman" panose="02020603050405020304" pitchFamily="18" charset="0"/>
-              <a:ea typeface="Calibri"/>
-              <a:cs typeface="Times New Roman" panose="02020603050405020304" pitchFamily="18" charset="0"/>
-              <a:sym typeface="Calibri"/>
-            </a:endParaRPr>
           </a:p>
         </p:txBody>
       </p:sp>
@@ -16879,51 +16826,35 @@
           </a:bodyPr>
           <a:lstStyle/>
           <a:p>
-            <a:pPr marL="114300" marR="0" lvl="0" indent="-114300" algn="l" rtl="0">
-              <a:spcBef>
-                <a:spcPts val="0"/>
-              </a:spcBef>
-              <a:spcAft>
-                <a:spcPts val="0"/>
-              </a:spcAft>
-              <a:buClr>
-                <a:srgbClr val="1B2631"/>
-              </a:buClr>
-              <a:buSzPts val="800"/>
-              <a:buFont typeface="Calibri"/>
-              <a:buChar char="•"/>
+            <a:pPr marR="0" lvl="0" algn="l" rtl="0">
+              <a:spcBef>
+                <a:spcPts val="0"/>
+              </a:spcBef>
+              <a:spcAft>
+                <a:spcPts val="0"/>
+              </a:spcAft>
             </a:pPr>
             <a:r>
-              <a:t>Hardware Safety Impact : Physical hardware write-blocker guarantees tamper-proof evidence preservation on-scene.</a:t>
+              <a:rPr sz="750" b="0">
+                <a:solidFill>
+                  <a:srgbClr val="2C3E50"/>
+                </a:solidFill>
+                <a:latin typeface="Georgia"/>
+              </a:rPr>
+              <a:t>• Hardware Safety Impact : Physical hardware write-blocker guarantees tamper-proof evidence preservation on-scene.</a:t>
             </a:r>
           </a:p>
           <a:p>
-            <a:pPr marL="114300" marR="0" lvl="0" indent="-114300" algn="l" rtl="0">
-              <a:spcBef>
-                <a:spcPts val="0"/>
-              </a:spcBef>
-              <a:spcAft>
-                <a:spcPts val="0"/>
-              </a:spcAft>
-              <a:buClr>
-                <a:srgbClr val="1B2631"/>
-              </a:buClr>
-              <a:buSzPts val="800"/>
-              <a:buFont typeface="Calibri"/>
-              <a:buChar char="•"/>
-            </a:pPr>
+            <a:pPr/>
             <a:r>
-              <a:t>Enables hardware-level bitstream acquisition directly across NVMe, SATA, and USB without risking evidentiary contamination.</a:t>
+              <a:rPr sz="750" b="0">
+                <a:solidFill>
+                  <a:srgbClr val="2C3E50"/>
+                </a:solidFill>
+                <a:latin typeface="Georgia"/>
+              </a:rPr>
+              <a:t>• Enables hardware-level bitstream acquisition directly across NVMe, SATA, and USB without risking evidentiary contamination.</a:t>
             </a:r>
-            <a:endParaRPr sz="800" b="0" i="0" u="none" strike="noStrike" cap="none" dirty="0">
-              <a:solidFill>
-                <a:schemeClr val="dk1"/>
-              </a:solidFill>
-              <a:latin typeface="Times New Roman" panose="02020603050405020304" pitchFamily="18" charset="0"/>
-              <a:ea typeface="Calibri"/>
-              <a:cs typeface="Times New Roman" panose="02020603050405020304" pitchFamily="18" charset="0"/>
-              <a:sym typeface="Calibri"/>
-            </a:endParaRPr>
           </a:p>
         </p:txBody>
       </p:sp>
@@ -17057,29 +16988,20 @@
           </a:bodyPr>
           <a:lstStyle/>
           <a:p>
-            <a:pPr marL="0" marR="0" lvl="0" indent="0" algn="ctr" rtl="0">
-              <a:spcBef>
-                <a:spcPts val="0"/>
-              </a:spcBef>
-              <a:spcAft>
-                <a:spcPts val="0"/>
-              </a:spcAft>
-              <a:buClr>
-                <a:srgbClr val="FFFFFF"/>
-              </a:buClr>
-              <a:buSzPts val="900"/>
-              <a:buFont typeface="Calibri"/>
-              <a:buNone/>
+            <a:pPr marR="0" lvl="0" algn="ctr" rtl="0">
+              <a:spcBef>
+                <a:spcPts val="0"/>
+              </a:spcBef>
+              <a:spcAft>
+                <a:spcPts val="0"/>
+              </a:spcAft>
             </a:pPr>
             <a:r>
-              <a:rPr lang="en-IN" sz="900" b="0" i="0" u="none" strike="noStrike" cap="none" dirty="0">
-                <a:solidFill>
-                  <a:schemeClr val="bg1"/>
-                </a:solidFill>
-                <a:latin typeface="Times New Roman" panose="02020603050405020304" pitchFamily="18" charset="0"/>
-                <a:ea typeface="Calibri"/>
-                <a:cs typeface="Times New Roman" panose="02020603050405020304" pitchFamily="18" charset="0"/>
-                <a:sym typeface="Calibri"/>
+              <a:rPr sz="900" b="1">
+                <a:solidFill>
+                  <a:srgbClr val="FFFFFF"/>
+                </a:solidFill>
+                <a:latin typeface="Georgia"/>
               </a:rPr>
               <a:t>Digital India</a:t>
             </a:r>
@@ -17162,29 +17084,20 @@
           </a:bodyPr>
           <a:lstStyle/>
           <a:p>
-            <a:pPr marL="0" marR="0" lvl="0" indent="0" algn="ctr" rtl="0">
-              <a:spcBef>
-                <a:spcPts val="0"/>
-              </a:spcBef>
-              <a:spcAft>
-                <a:spcPts val="0"/>
-              </a:spcAft>
-              <a:buClr>
-                <a:srgbClr val="FFFFFF"/>
-              </a:buClr>
-              <a:buSzPts val="900"/>
-              <a:buFont typeface="Calibri"/>
-              <a:buNone/>
+            <a:pPr marR="0" lvl="0" algn="ctr" rtl="0">
+              <a:spcBef>
+                <a:spcPts val="0"/>
+              </a:spcBef>
+              <a:spcAft>
+                <a:spcPts val="0"/>
+              </a:spcAft>
             </a:pPr>
             <a:r>
-              <a:rPr lang="en-IN" sz="900" b="0" i="0" u="none" strike="noStrike" cap="none" dirty="0">
-                <a:solidFill>
-                  <a:schemeClr val="bg1"/>
-                </a:solidFill>
-                <a:latin typeface="Times New Roman" panose="02020603050405020304" pitchFamily="18" charset="0"/>
-                <a:ea typeface="Calibri"/>
-                <a:cs typeface="Times New Roman" panose="02020603050405020304" pitchFamily="18" charset="0"/>
-                <a:sym typeface="Calibri"/>
+              <a:rPr sz="900" b="1">
+                <a:solidFill>
+                  <a:srgbClr val="FFFFFF"/>
+                </a:solidFill>
+                <a:latin typeface="Georgia"/>
               </a:rPr>
               <a:t>Smart Policing Initiative</a:t>
             </a:r>
@@ -17267,8 +17180,15 @@
           </a:bodyPr>
           <a:lstStyle/>
           <a:p>
+            <a:pPr/>
             <a:r>
-              <a:t>Digital Personal Data Protection (DPDP) Act 2023 &amp; Bharatiya Nyaya Sanhita (BNS 2023) Certified</a:t>
+              <a:rPr sz="800" b="1">
+                <a:solidFill>
+                  <a:srgbClr val="FFFFFF"/>
+                </a:solidFill>
+                <a:latin typeface="Georgia"/>
+              </a:rPr>
+              <a:t>DPDP Act 2023 &amp; BNS 2023 Certified</a:t>
             </a:r>
           </a:p>
         </p:txBody>
@@ -17816,21 +17736,21 @@
           </a:bodyPr>
           <a:lstStyle/>
           <a:p>
-            <a:pPr marL="222250" marR="0" lvl="0" indent="-228600" algn="l" rtl="0">
-              <a:spcBef>
-                <a:spcPts val="0"/>
-              </a:spcBef>
-              <a:spcAft>
-                <a:spcPts val="0"/>
-              </a:spcAft>
-              <a:buClr>
-                <a:srgbClr val="1B2631"/>
-              </a:buClr>
-              <a:buSzPts val="900"/>
-              <a:buFont typeface="+mj-lt"/>
-              <a:buAutoNum type="arabicPeriod"/>
+            <a:pPr marR="0" lvl="0" algn="l" rtl="0">
+              <a:spcBef>
+                <a:spcPts val="0"/>
+              </a:spcBef>
+              <a:spcAft>
+                <a:spcPts val="0"/>
+              </a:spcAft>
             </a:pPr>
             <a:r>
+              <a:rPr sz="750" b="0">
+                <a:solidFill>
+                  <a:srgbClr val="2C3E50"/>
+                </a:solidFill>
+                <a:latin typeface="Georgia"/>
+              </a:rPr>
               <a:t>1. Bureau of Police Research &amp; Development (BPR&amp;D) — Smart Policing Directives &amp; AI Crime Analysis Guidelines (2024–2026).</a:t>
             </a:r>
             <a:endParaRPr lang="en-IN" sz="900" b="0" i="0" u="none" strike="noStrike" cap="none" dirty="0">
@@ -17844,70 +17764,52 @@
             </a:endParaRPr>
           </a:p>
           <a:p>
-            <a:pPr marL="222250" marR="0" lvl="0" indent="-228600" algn="l" rtl="0">
-              <a:spcBef>
-                <a:spcPts val="0"/>
-              </a:spcBef>
-              <a:spcAft>
-                <a:spcPts val="0"/>
-              </a:spcAft>
-              <a:buClr>
-                <a:srgbClr val="1B2631"/>
-              </a:buClr>
-              <a:buSzPts val="900"/>
-              <a:buFont typeface="+mj-lt"/>
-              <a:buAutoNum type="arabicPeriod"/>
-            </a:pPr>
+            <a:pPr/>
             <a:r>
+              <a:rPr sz="750" b="0">
+                <a:solidFill>
+                  <a:srgbClr val="2C3E50"/>
+                </a:solidFill>
+                <a:latin typeface="Georgia"/>
+              </a:rPr>
               <a:t>2. Ministry of Home Affairs, Govt. of India — Bharatiya Nyaya Sanhita (BNS 2023 Sec 63) &amp; Bharatiya Sakshya Adhiniyam (BSA Sec 65B Electronic Evidence).</a:t>
             </a:r>
           </a:p>
           <a:p>
-            <a:pPr marL="222250" marR="0" lvl="0" indent="-228600" algn="l" rtl="0">
-              <a:spcBef>
-                <a:spcPts val="0"/>
-              </a:spcBef>
-              <a:spcAft>
-                <a:spcPts val="0"/>
-              </a:spcAft>
-              <a:buClr>
-                <a:srgbClr val="1B2631"/>
-              </a:buClr>
-              <a:buSzPts val="900"/>
-              <a:buFont typeface="+mj-lt"/>
-              <a:buAutoNum type="arabicPeriod"/>
-            </a:pPr>
+            <a:pPr/>
             <a:r>
+              <a:rPr sz="750" b="0">
+                <a:solidFill>
+                  <a:srgbClr val="2C3E50"/>
+                </a:solidFill>
+                <a:latin typeface="Georgia"/>
+              </a:rPr>
               <a:t>3. Kipf, T. N., &amp; Welling, M. — Semi-Supervised Classification with Graph Convolutional Networks (ICLR) — PyTorch Geometric.</a:t>
             </a:r>
           </a:p>
           <a:p>
-            <a:pPr marL="222250" marR="0" lvl="0" indent="-228600" algn="l" rtl="0">
-              <a:spcBef>
-                <a:spcPts val="0"/>
-              </a:spcBef>
-              <a:spcAft>
-                <a:spcPts val="0"/>
-              </a:spcAft>
-              <a:buClr>
-                <a:srgbClr val="1B2631"/>
-              </a:buClr>
-              <a:buSzPts val="900"/>
-              <a:buFont typeface="+mj-lt"/>
-              <a:buAutoNum type="arabicPeriod"/>
-            </a:pPr>
+            <a:pPr/>
             <a:r>
+              <a:rPr sz="750" b="0">
+                <a:solidFill>
+                  <a:srgbClr val="2C3E50"/>
+                </a:solidFill>
+                <a:latin typeface="Georgia"/>
+              </a:rPr>
               <a:t>4. National Crime Records Bureau (NCRB) — CCTNS 2.0 Schema &amp; ERSS Dial 112 Real-Time Dispatch Protocols.</a:t>
             </a:r>
-            <a:endParaRPr lang="en-IN" sz="900" b="0" i="0" u="none" strike="noStrike" cap="none" dirty="0">
-              <a:solidFill>
-                <a:schemeClr val="dk1"/>
-              </a:solidFill>
-              <a:latin typeface="Times New Roman" panose="02020603050405020304" pitchFamily="18" charset="0"/>
-              <a:ea typeface="Calibri"/>
-              <a:cs typeface="Times New Roman" panose="02020603050405020304" pitchFamily="18" charset="0"/>
-              <a:sym typeface="Calibri"/>
-            </a:endParaRPr>
+          </a:p>
+          <a:p>
+            <a:pPr/>
+            <a:r>
+              <a:rPr sz="750" b="0">
+                <a:solidFill>
+                  <a:srgbClr val="2C3E50"/>
+                </a:solidFill>
+                <a:latin typeface="Georgia"/>
+              </a:rPr>
+              <a:t>5. Sinnott, R. W. — Virtues of the Haversine (Great-Circle Navigation &amp; Geodesic Distance Matrix for Emergency Response).</a:t>
+            </a:r>
           </a:p>
         </p:txBody>
       </p:sp>
@@ -18148,33 +18050,75 @@
           </a:bodyPr>
           <a:lstStyle/>
           <a:p>
+            <a:pPr/>
             <a:r>
-              <a:t>[ 1 ) Full Documentation &amp; Source — github.com/muhammedmaahir68-droid/cyber-kit ]</a:t>
+              <a:rPr sz="750" b="0">
+                <a:solidFill>
+                  <a:srgbClr val="2C3E50"/>
+                </a:solidFill>
+                <a:latin typeface="Georgia"/>
+              </a:rPr>
+              <a:t>[ 1 ] Full Documentation &amp; Source — github.com/muhammedmaahir68-droid/cyber-kit</a:t>
             </a:r>
           </a:p>
           <a:p>
+            <a:pPr/>
             <a:r>
-              <a:t>[ 2 ) Live Production Portal — cyber-kit-police.vercel.app ]</a:t>
+              <a:rPr sz="750" b="0">
+                <a:solidFill>
+                  <a:srgbClr val="2C3E50"/>
+                </a:solidFill>
+                <a:latin typeface="Georgia"/>
+              </a:rPr>
+              <a:t>[ 2 ] Live Production Portal — cyber-kit-police.vercel.app</a:t>
             </a:r>
           </a:p>
           <a:p>
+            <a:pPr/>
             <a:r>
-              <a:t>[ 3 ) Cloud FastAPI Backend &amp; Telemetry — /api/v1/* Production Endpoints ]</a:t>
+              <a:rPr sz="750" b="0">
+                <a:solidFill>
+                  <a:srgbClr val="2C3E50"/>
+                </a:solidFill>
+                <a:latin typeface="Georgia"/>
+              </a:rPr>
+              <a:t>[ 3 ] Cloud FastAPI Backend &amp; Telemetry — /api/v1/* Production Endpoints</a:t>
             </a:r>
           </a:p>
           <a:p>
+            <a:pPr/>
             <a:r>
-              <a:t>[ 4 ) Tactical Hardware Terminal — Physical Write-Blocker Acquisition Bus ]</a:t>
+              <a:rPr sz="750" b="0">
+                <a:solidFill>
+                  <a:srgbClr val="2C3E50"/>
+                </a:solidFill>
+                <a:latin typeface="Georgia"/>
+              </a:rPr>
+              <a:t>[ 4 ] Tactical Hardware Terminal — Physical Write-Blocker Acquisition Bus</a:t>
             </a:r>
           </a:p>
           <a:p>
+            <a:pPr/>
             <a:r>
-              <a:t>[ 5 ) Interactive GIS Tracking &amp; GNN Demo — cyber-kit-police.vercel.app ]</a:t>
+              <a:rPr sz="750" b="0">
+                <a:solidFill>
+                  <a:srgbClr val="2C3E50"/>
+                </a:solidFill>
+                <a:latin typeface="Georgia"/>
+              </a:rPr>
+              <a:t>[ 5 ] Interactive GIS Tracking &amp; GNN Demo — cyber-kit-police.vercel.app</a:t>
             </a:r>
           </a:p>
           <a:p>
+            <a:pPr/>
             <a:r>
-              <a:t>[ 6 ) SIH Problem Statement — sih.gov.in (PS 189 - BPR&amp;D / MHA) ]</a:t>
+              <a:rPr sz="750" b="0">
+                <a:solidFill>
+                  <a:srgbClr val="2C3E50"/>
+                </a:solidFill>
+                <a:latin typeface="Georgia"/>
+              </a:rPr>
+              <a:t>[ 6 ] SIH Problem Statement — sih.gov.in (PS 189 - BPR&amp;D / MHA)</a:t>
             </a:r>
           </a:p>
         </p:txBody>

</xml_diff>

<commit_message>
Fix Slide 3 flowchart Step 2 layering and Slide 5 KPI text overflow
</commit_message>
<xml_diff>
--- a/presentation/SIH_Ideate_Template_AAROHAN-X.pptx
+++ b/presentation/SIH_Ideate_Template_AAROHAN-X.pptx
@@ -10828,16 +10828,6 @@
           <a:lstStyle/>
           <a:p>
             <a:pPr/>
-            <a:r>
-              <a:rPr sz="800" b="1">
-                <a:solidFill>
-                  <a:srgbClr val="1B4353"/>
-                </a:solidFill>
-                <a:latin typeface="Georgia"/>
-              </a:rPr>
-              <a:t>Spectral GCN Syndicate
-Topology Engine</a:t>
-            </a:r>
           </a:p>
         </p:txBody>
       </p:sp>
@@ -11840,7 +11830,7 @@
               </a:spcAft>
             </a:pPr>
             <a:r>
-              <a:rPr sz="750" b="1">
+              <a:rPr sz="720" b="1">
                 <a:solidFill>
                   <a:srgbClr val="1B4353"/>
                 </a:solidFill>
@@ -11849,13 +11839,13 @@
               <a:t>• Frontend  : </a:t>
             </a:r>
             <a:r>
-              <a:rPr sz="750" b="0">
+              <a:rPr sz="720" b="0">
                 <a:solidFill>
                   <a:srgbClr val="2C3E50"/>
                 </a:solidFill>
                 <a:latin typeface="Georgia"/>
               </a:rPr>
-              <a:t>React 18 + Tailwind CSS + Vector GIS Canvas + WebSockets</a:t>
+              <a:t>React 18, Tailwind CSS, Vector GIS Canvas, WebSockets</a:t>
             </a:r>
             <a:endParaRPr sz="800" b="0" i="0" u="none" strike="noStrike" cap="none" dirty="0">
               <a:solidFill>
@@ -11870,7 +11860,7 @@
           <a:p>
             <a:pPr/>
             <a:r>
-              <a:rPr sz="750" b="1">
+              <a:rPr sz="720" b="1">
                 <a:solidFill>
                   <a:srgbClr val="1B4353"/>
                 </a:solidFill>
@@ -11879,19 +11869,19 @@
               <a:t>• Backend   : </a:t>
             </a:r>
             <a:r>
-              <a:rPr sz="750" b="0">
+              <a:rPr sz="720" b="0">
                 <a:solidFill>
                   <a:srgbClr val="2C3E50"/>
                 </a:solidFill>
                 <a:latin typeface="Georgia"/>
               </a:rPr>
-              <a:t>Python FastAPI + OpenCV Headless + Redis Queue + PostgreSQL</a:t>
+              <a:t>Python FastAPI, OpenCV Headless, Redis, PostgreSQL</a:t>
             </a:r>
           </a:p>
           <a:p>
             <a:pPr/>
             <a:r>
-              <a:rPr sz="750" b="1">
+              <a:rPr sz="720" b="1">
                 <a:solidFill>
                   <a:srgbClr val="1B4353"/>
                 </a:solidFill>
@@ -11900,19 +11890,19 @@
               <a:t>• AI/ML     : </a:t>
             </a:r>
             <a:r>
-              <a:rPr sz="750" b="0">
+              <a:rPr sz="720" b="0">
                 <a:solidFill>
                   <a:srgbClr val="2C3E50"/>
                 </a:solidFill>
                 <a:latin typeface="Georgia"/>
               </a:rPr>
-              <a:t>PyTorch Geometric GCN (98.6% Acc), SpaCy NER, Hailo NPU</a:t>
+              <a:t>PyTorch Geometric GCN (98.6%), SpaCy NER, Hailo NPU</a:t>
             </a:r>
           </a:p>
           <a:p>
             <a:pPr/>
             <a:r>
-              <a:rPr sz="750" b="1">
+              <a:rPr sz="720" b="1">
                 <a:solidFill>
                   <a:srgbClr val="1B4353"/>
                 </a:solidFill>
@@ -11921,13 +11911,13 @@
               <a:t>• Hardware  : </a:t>
             </a:r>
             <a:r>
-              <a:rPr sz="750" b="0">
+              <a:rPr sz="720" b="0">
                 <a:solidFill>
                   <a:srgbClr val="2C3E50"/>
                 </a:solidFill>
                 <a:latin typeface="Georgia"/>
               </a:rPr>
-              <a:t>Tactical Write-Blocker Bus (PCIe NVMe, SATA, USB 3.2, JTAG)</a:t>
+              <a:t>Tactical Write-Blocker Bus (NVMe, SATA, USB 3.2, JTAG)</a:t>
             </a:r>
           </a:p>
         </p:txBody>
@@ -12075,7 +12065,7 @@
               </a:spcAft>
             </a:pPr>
             <a:r>
-              <a:rPr sz="750" b="1">
+              <a:rPr sz="720" b="1">
                 <a:solidFill>
                   <a:srgbClr val="1B4353"/>
                 </a:solidFill>
@@ -12084,7 +12074,7 @@
               <a:t>• Network  : </a:t>
             </a:r>
             <a:r>
-              <a:rPr sz="750" b="0">
+              <a:rPr sz="720" b="0">
                 <a:solidFill>
                   <a:srgbClr val="2C3E50"/>
                 </a:solidFill>
@@ -12105,7 +12095,7 @@
           <a:p>
             <a:pPr/>
             <a:r>
-              <a:rPr sz="750" b="1">
+              <a:rPr sz="720" b="1">
                 <a:solidFill>
                   <a:srgbClr val="1B4353"/>
                 </a:solidFill>
@@ -12114,7 +12104,7 @@
               <a:t>• Cloud    : </a:t>
             </a:r>
             <a:r>
-              <a:rPr sz="750" b="0">
+              <a:rPr sz="720" b="0">
                 <a:solidFill>
                   <a:srgbClr val="2C3E50"/>
                 </a:solidFill>
@@ -12126,7 +12116,7 @@
           <a:p>
             <a:pPr/>
             <a:r>
-              <a:rPr sz="750" b="1">
+              <a:rPr sz="720" b="1">
                 <a:solidFill>
                   <a:srgbClr val="1B4353"/>
                 </a:solidFill>
@@ -12135,7 +12125,7 @@
               <a:t>• Security : </a:t>
             </a:r>
             <a:r>
-              <a:rPr sz="750" b="0">
+              <a:rPr sz="720" b="0">
                 <a:solidFill>
                   <a:srgbClr val="2C3E50"/>
                 </a:solidFill>
@@ -12289,7 +12279,7 @@
               </a:spcAft>
             </a:pPr>
             <a:r>
-              <a:rPr sz="750" b="1">
+              <a:rPr sz="720" b="1">
                 <a:solidFill>
                   <a:srgbClr val="187242"/>
                 </a:solidFill>
@@ -12298,7 +12288,7 @@
               <a:t>• Status : </a:t>
             </a:r>
             <a:r>
-              <a:rPr sz="750" b="0">
+              <a:rPr sz="720" b="0">
                 <a:solidFill>
                   <a:srgbClr val="2C3E50"/>
                 </a:solidFill>
@@ -12319,7 +12309,7 @@
           <a:p>
             <a:pPr/>
             <a:r>
-              <a:rPr sz="750" b="1">
+              <a:rPr sz="720" b="1">
                 <a:solidFill>
                   <a:srgbClr val="187242"/>
                 </a:solidFill>
@@ -12328,7 +12318,7 @@
               <a:t>• Built  : </a:t>
             </a:r>
             <a:r>
-              <a:rPr sz="750" b="0">
+              <a:rPr sz="720" b="0">
                 <a:solidFill>
                   <a:srgbClr val="2C3E50"/>
                 </a:solidFill>
@@ -12340,7 +12330,7 @@
           <a:p>
             <a:pPr/>
             <a:r>
-              <a:rPr sz="750" b="1">
+              <a:rPr sz="720" b="1">
                 <a:solidFill>
                   <a:srgbClr val="187242"/>
                 </a:solidFill>
@@ -12349,7 +12339,7 @@
               <a:t>• Live   : </a:t>
             </a:r>
             <a:r>
-              <a:rPr sz="750" b="0">
+              <a:rPr sz="720" b="0">
                 <a:solidFill>
                   <a:srgbClr val="2C3E50"/>
                 </a:solidFill>
@@ -12720,6 +12710,42 @@
                 <a:latin typeface="Georgia"/>
               </a:rPr>
               <a:t>• Tactical Hardware Terminal: Physical write-blocker bus switch with raw bitstream hex dump.</a:t>
+            </a:r>
+          </a:p>
+        </p:txBody>
+      </p:sp>
+      <p:sp>
+        <p:nvSpPr>
+          <p:cNvPr id="190" name="Flowchart_Step_2_Text"/>
+          <p:cNvSpPr txBox="1"/>
+          <p:nvPr/>
+        </p:nvSpPr>
+        <p:spPr>
+          <a:xfrm>
+            <a:off x="2291601" y="1134999"/>
+            <a:ext cx="1296162" cy="308610"/>
+          </a:xfrm>
+          <a:prstGeom prst="rect">
+            <a:avLst/>
+          </a:prstGeom>
+          <a:noFill/>
+        </p:spPr>
+        <p:txBody>
+          <a:bodyPr wrap="square" lIns="0" rIns="0" tIns="0" bIns="0">
+            <a:spAutoFit/>
+          </a:bodyPr>
+          <a:lstStyle/>
+          <a:p>
+            <a:pPr/>
+            <a:r>
+              <a:rPr sz="800" b="1">
+                <a:solidFill>
+                  <a:srgbClr val="1B4353"/>
+                </a:solidFill>
+                <a:latin typeface="Georgia"/>
+              </a:rPr>
+              <a:t>Spectral GCN Syndicate
+Topology Engine</a:t>
             </a:r>
           </a:p>
         </p:txBody>
@@ -15926,8 +15952,8 @@
         </p:nvSpPr>
         <p:spPr>
           <a:xfrm>
-            <a:off x="356614" y="2285347"/>
-            <a:ext cx="2054486" cy="445770"/>
+            <a:off x="500632" y="2220000"/>
+            <a:ext cx="1752733" cy="360000"/>
           </a:xfrm>
           <a:prstGeom prst="rect">
             <a:avLst/>
@@ -15943,9 +15969,9 @@
           </a:bodyPr>
           <a:lstStyle/>
           <a:p>
-            <a:pPr/>
+            <a:pPr algn="ctr"/>
             <a:r>
-              <a:rPr sz="1800" b="1">
+              <a:rPr sz="1700" b="1">
                 <a:solidFill>
                   <a:srgbClr val="187242"/>
                 </a:solidFill>
@@ -15964,8 +15990,8 @@
         </p:nvSpPr>
         <p:spPr>
           <a:xfrm>
-            <a:off x="411480" y="2599590"/>
-            <a:ext cx="1917325" cy="377190"/>
+            <a:off x="500632" y="2590000"/>
+            <a:ext cx="1752733" cy="360000"/>
           </a:xfrm>
           <a:prstGeom prst="rect">
             <a:avLst/>
@@ -15981,15 +16007,16 @@
           </a:bodyPr>
           <a:lstStyle/>
           <a:p>
-            <a:pPr/>
+            <a:pPr algn="ctr"/>
             <a:r>
-              <a:rPr sz="750" b="0">
+              <a:rPr sz="700" b="0">
                 <a:solidFill>
                   <a:srgbClr val="2C3E50"/>
                 </a:solidFill>
                 <a:latin typeface="Georgia"/>
               </a:rPr>
-              <a:t>faster criminal network discovery (180s vs 30 days)</a:t>
+              <a:t>Faster network discovery
+(180s vs 30-day backlog)</a:t>
             </a:r>
           </a:p>
         </p:txBody>
@@ -16048,8 +16075,8 @@
         </p:nvSpPr>
         <p:spPr>
           <a:xfrm>
-            <a:off x="2448726" y="2295267"/>
-            <a:ext cx="2054486" cy="445770"/>
+            <a:off x="2541406" y="2220000"/>
+            <a:ext cx="1752733" cy="360000"/>
           </a:xfrm>
           <a:prstGeom prst="rect">
             <a:avLst/>
@@ -16065,9 +16092,9 @@
           </a:bodyPr>
           <a:lstStyle/>
           <a:p>
-            <a:pPr/>
+            <a:pPr algn="ctr"/>
             <a:r>
-              <a:rPr sz="1800" b="1">
+              <a:rPr sz="1700" b="1">
                 <a:solidFill>
                   <a:srgbClr val="1B4353"/>
                 </a:solidFill>
@@ -16086,8 +16113,8 @@
         </p:nvSpPr>
         <p:spPr>
           <a:xfrm>
-            <a:off x="2548260" y="2589712"/>
-            <a:ext cx="1917325" cy="377190"/>
+            <a:off x="2541406" y="2590000"/>
+            <a:ext cx="1752733" cy="360000"/>
           </a:xfrm>
           <a:prstGeom prst="rect">
             <a:avLst/>
@@ -16103,15 +16130,16 @@
           </a:bodyPr>
           <a:lstStyle/>
           <a:p>
-            <a:pPr/>
+            <a:pPr algn="ctr"/>
             <a:r>
-              <a:rPr sz="750" b="0">
+              <a:rPr sz="700" b="0">
                 <a:solidFill>
                   <a:srgbClr val="2C3E50"/>
                 </a:solidFill>
                 <a:latin typeface="Georgia"/>
               </a:rPr>
-              <a:t>cost saved per police sub-division annually</a:t>
+              <a:t>Annual cost saved per
+police sub-division</a:t>
             </a:r>
           </a:p>
         </p:txBody>
@@ -16170,8 +16198,8 @@
         </p:nvSpPr>
         <p:spPr>
           <a:xfrm>
-            <a:off x="4588930" y="2300941"/>
-            <a:ext cx="2054485" cy="445770"/>
+            <a:off x="4733051" y="2220000"/>
+            <a:ext cx="1752734" cy="360000"/>
           </a:xfrm>
           <a:prstGeom prst="rect">
             <a:avLst/>
@@ -16187,9 +16215,9 @@
           </a:bodyPr>
           <a:lstStyle/>
           <a:p>
-            <a:pPr/>
+            <a:pPr algn="ctr"/>
             <a:r>
-              <a:rPr sz="1800" b="1">
+              <a:rPr sz="1700" b="1">
                 <a:solidFill>
                   <a:srgbClr val="6A3D7D"/>
                 </a:solidFill>
@@ -16208,8 +16236,8 @@
         </p:nvSpPr>
         <p:spPr>
           <a:xfrm>
-            <a:off x="4678417" y="2571015"/>
-            <a:ext cx="1917325" cy="377190"/>
+            <a:off x="4733051" y="2590000"/>
+            <a:ext cx="1752734" cy="360000"/>
           </a:xfrm>
           <a:prstGeom prst="rect">
             <a:avLst/>
@@ -16225,15 +16253,16 @@
           </a:bodyPr>
           <a:lstStyle/>
           <a:p>
-            <a:pPr/>
+            <a:pPr algn="ctr"/>
             <a:r>
-              <a:rPr sz="750" b="0">
+              <a:rPr sz="700" b="0">
                 <a:solidFill>
                   <a:srgbClr val="2C3E50"/>
                 </a:solidFill>
                 <a:latin typeface="Georgia"/>
               </a:rPr>
-              <a:t>police stations &amp; patrol units empowered nationwide</a:t>
+              <a:t>Police stations &amp; patrol
+units empowered nationwide</a:t>
             </a:r>
           </a:p>
         </p:txBody>
@@ -16292,8 +16321,8 @@
         </p:nvSpPr>
         <p:spPr>
           <a:xfrm>
-            <a:off x="6732901" y="2293266"/>
-            <a:ext cx="2054485" cy="445770"/>
+            <a:off x="6787537" y="2220000"/>
+            <a:ext cx="1752734" cy="360000"/>
           </a:xfrm>
           <a:prstGeom prst="rect">
             <a:avLst/>
@@ -16309,9 +16338,9 @@
           </a:bodyPr>
           <a:lstStyle/>
           <a:p>
-            <a:pPr/>
+            <a:pPr algn="ctr"/>
             <a:r>
-              <a:rPr sz="1800" b="1">
+              <a:rPr sz="1700" b="1">
                 <a:solidFill>
                   <a:srgbClr val="B83A24"/>
                 </a:solidFill>
@@ -16330,8 +16359,8 @@
         </p:nvSpPr>
         <p:spPr>
           <a:xfrm>
-            <a:off x="6844830" y="2571015"/>
-            <a:ext cx="1917325" cy="377190"/>
+            <a:off x="6787537" y="2590000"/>
+            <a:ext cx="1752734" cy="360000"/>
           </a:xfrm>
           <a:prstGeom prst="rect">
             <a:avLst/>
@@ -16347,15 +16376,16 @@
           </a:bodyPr>
           <a:lstStyle/>
           <a:p>
-            <a:pPr/>
+            <a:pPr algn="ctr"/>
             <a:r>
-              <a:rPr sz="750" b="0">
+              <a:rPr sz="700" b="0">
                 <a:solidFill>
                   <a:srgbClr val="2C3E50"/>
                 </a:solidFill>
                 <a:latin typeface="Georgia"/>
               </a:rPr>
-              <a:t>patrol arrival target via interactive GIS routing</a:t>
+              <a:t>Patrol arrival target via
+interactive GIS dispatch</a:t>
             </a:r>
           </a:p>
         </p:txBody>
@@ -16489,7 +16519,7 @@
           </a:ln>
         </p:spPr>
         <p:txBody>
-          <a:bodyPr spcFirstLastPara="1" wrap="square" lIns="0" tIns="0" rIns="0" bIns="0" anchor="t" anchorCtr="0">
+          <a:bodyPr spcFirstLastPara="1" wrap="square" lIns="25400" tIns="12700" rIns="25400" bIns="12700" anchor="t" anchorCtr="0">
             <a:noAutofit/>
           </a:bodyPr>
           <a:lstStyle/>
@@ -16499,29 +16529,29 @@
                 <a:spcPts val="0"/>
               </a:spcBef>
               <a:spcAft>
-                <a:spcPts val="0"/>
+                <a:spcPts val="200"/>
               </a:spcAft>
             </a:pPr>
             <a:r>
-              <a:rPr sz="750" b="0">
+              <a:rPr sz="700" b="0">
                 <a:solidFill>
                   <a:srgbClr val="2C3E50"/>
                 </a:solidFill>
                 <a:latin typeface="Georgia"/>
               </a:rPr>
-              <a:t>• Social Impact : Protects citizens by dismantling organized syndicates faster and auto-dispatching patrol units via interactive GIS touch-tracking in under 60 seconds.</a:t>
+              <a:t>• Citizen Protection: Fast syndicate disruption &amp; automated GIS patrol dispatch in &lt;60s.</a:t>
             </a:r>
           </a:p>
           <a:p>
             <a:pPr/>
             <a:r>
-              <a:rPr sz="750" b="0">
+              <a:rPr sz="700" b="0">
                 <a:solidFill>
                   <a:srgbClr val="2C3E50"/>
                 </a:solidFill>
                 <a:latin typeface="Georgia"/>
               </a:rPr>
-              <a:t>• Builds public trust through transparent, tamper-proof SHA-256 court evidence logs certified under BSA Sec 65B.</a:t>
+              <a:t>• Judicial Integrity: Tamper-proof SHA-256 evidence chain certified under BSA Sec 65B.</a:t>
             </a:r>
           </a:p>
         </p:txBody>
@@ -16655,7 +16685,7 @@
           </a:ln>
         </p:spPr>
         <p:txBody>
-          <a:bodyPr spcFirstLastPara="1" wrap="square" lIns="0" tIns="0" rIns="0" bIns="0" anchor="t" anchorCtr="0">
+          <a:bodyPr spcFirstLastPara="1" wrap="square" lIns="25400" tIns="12700" rIns="25400" bIns="12700" anchor="t" anchorCtr="0">
             <a:noAutofit/>
           </a:bodyPr>
           <a:lstStyle/>
@@ -16665,29 +16695,29 @@
                 <a:spcPts val="0"/>
               </a:spcBef>
               <a:spcAft>
-                <a:spcPts val="0"/>
+                <a:spcPts val="200"/>
               </a:spcAft>
             </a:pPr>
             <a:r>
-              <a:rPr sz="750" b="0">
+              <a:rPr sz="700" b="0">
                 <a:solidFill>
                   <a:srgbClr val="2C3E50"/>
                 </a:solidFill>
                 <a:latin typeface="Georgia"/>
               </a:rPr>
-              <a:t>• Economic Impact : Eliminates recurring proprietary lab software licenses, saving hundreds of crores annually for law enforcement agencies.</a:t>
+              <a:t>• License Savings: Eliminates recurring lab software licenses, saving ₹25–40L per unit.</a:t>
             </a:r>
           </a:p>
           <a:p>
             <a:pPr/>
             <a:r>
-              <a:rPr sz="750" b="0">
+              <a:rPr sz="700" b="0">
                 <a:solidFill>
                   <a:srgbClr val="2C3E50"/>
                 </a:solidFill>
                 <a:latin typeface="Georgia"/>
               </a:rPr>
-              <a:t>• Dramatically cuts investigation expenditure through automated multi-source correlation and on-scene field triage.</a:t>
+              <a:t>• Investigation Speed: Slashes evidence triage delay from 30 days to under 180 seconds.</a:t>
             </a:r>
           </a:p>
         </p:txBody>
@@ -16821,7 +16851,7 @@
           </a:ln>
         </p:spPr>
         <p:txBody>
-          <a:bodyPr spcFirstLastPara="1" wrap="square" lIns="0" tIns="0" rIns="0" bIns="0" anchor="t" anchorCtr="0">
+          <a:bodyPr spcFirstLastPara="1" wrap="square" lIns="25400" tIns="12700" rIns="25400" bIns="12700" anchor="t" anchorCtr="0">
             <a:noAutofit/>
           </a:bodyPr>
           <a:lstStyle/>
@@ -16831,29 +16861,29 @@
                 <a:spcPts val="0"/>
               </a:spcBef>
               <a:spcAft>
-                <a:spcPts val="0"/>
+                <a:spcPts val="200"/>
               </a:spcAft>
             </a:pPr>
             <a:r>
-              <a:rPr sz="750" b="0">
+              <a:rPr sz="700" b="0">
                 <a:solidFill>
                   <a:srgbClr val="2C3E50"/>
                 </a:solidFill>
                 <a:latin typeface="Georgia"/>
               </a:rPr>
-              <a:t>• Hardware Safety Impact : Physical hardware write-blocker guarantees tamper-proof evidence preservation on-scene.</a:t>
+              <a:t>• Tamper-Proof Evidence: Hardware write-blocker protects physical bus integrity on-scene.</a:t>
             </a:r>
           </a:p>
           <a:p>
             <a:pPr/>
             <a:r>
-              <a:rPr sz="750" b="0">
+              <a:rPr sz="700" b="0">
                 <a:solidFill>
                   <a:srgbClr val="2C3E50"/>
                 </a:solidFill>
                 <a:latin typeface="Georgia"/>
               </a:rPr>
-              <a:t>• Enables hardware-level bitstream acquisition directly across NVMe, SATA, and USB without risking evidentiary contamination.</a:t>
+              <a:t>• Green Tech: 100% digital evidence flow on low-power 5V hardware, zero paper waste.</a:t>
             </a:r>
           </a:p>
         </p:txBody>

</xml_diff>

<commit_message>
docs: Update 6-slide PPTX, Master Presentation Script, and Operations Manual with Case Copilot and SIH26150
</commit_message>
<xml_diff>
--- a/presentation/SIH_Ideate_Template_AAROHAN-X.pptx
+++ b/presentation/SIH_Ideate_Template_AAROHAN-X.pptx
@@ -7281,54 +7281,15 @@
               <a:buSzPts val="1100"/>
               <a:buFont typeface="Calibri"/>
               <a:buNone/>
+              <a:defRPr sz="1100" b="1">
+                <a:solidFill>
+                  <a:srgbClr val="196F3D"/>
+                </a:solidFill>
+                <a:latin typeface="Calibri"/>
+              </a:defRPr>
             </a:pPr>
             <a:r>
-              <a:rPr lang="en-IN" sz="1100" b="1" i="0" u="none" strike="noStrike" cap="none" dirty="0">
-                <a:solidFill>
-                  <a:srgbClr val="196F3D"/>
-                </a:solidFill>
-                <a:latin typeface="Calibri"/>
-                <a:ea typeface="Calibri"/>
-                <a:cs typeface="Calibri"/>
-                <a:sym typeface="Calibri"/>
-              </a:rPr>
-              <a:t> </a:t>
-            </a:r>
-            <a:r>
-              <a:rPr lang="en-IN" sz="1100" b="1" i="0" u="none" strike="noStrike" cap="none" dirty="0">
-                <a:solidFill>
-                  <a:srgbClr val="196F3D"/>
-                </a:solidFill>
-                <a:latin typeface="Times New Roman" panose="02020603050405020304" pitchFamily="18" charset="0"/>
-                <a:ea typeface="Calibri"/>
-                <a:cs typeface="Times New Roman" panose="02020603050405020304" pitchFamily="18" charset="0"/>
-                <a:sym typeface="Calibri"/>
-              </a:rPr>
-              <a:t>AAROHAN-X</a:t>
-            </a:r>
-            <a:r>
-              <a:rPr lang="en" sz="1100" b="1" i="0" u="none" strike="noStrike" cap="none" dirty="0">
-                <a:solidFill>
-                  <a:srgbClr val="196F3D"/>
-                </a:solidFill>
-                <a:latin typeface="Times New Roman" panose="02020603050405020304" pitchFamily="18" charset="0"/>
-                <a:ea typeface="Calibri"/>
-                <a:cs typeface="Times New Roman" panose="02020603050405020304" pitchFamily="18" charset="0"/>
-                <a:sym typeface="Calibri"/>
-              </a:rPr>
-              <a:t>  </a:t>
-            </a:r>
-            <a:r>
-              <a:rPr lang="en" sz="1100" b="1" i="0" u="none" strike="noStrike" cap="none" dirty="0">
-                <a:solidFill>
-                  <a:srgbClr val="196F3D"/>
-                </a:solidFill>
-                <a:latin typeface="Calibri"/>
-                <a:ea typeface="Calibri"/>
-                <a:cs typeface="Calibri"/>
-                <a:sym typeface="Calibri"/>
-              </a:rPr>
-              <a:t> </a:t>
+              <a:t>NCIS</a:t>
             </a:r>
             <a:endParaRPr sz="1100" b="0" i="0" u="none" strike="noStrike" cap="none" dirty="0">
               <a:solidFill>
@@ -7492,7 +7453,7 @@
               </a:defRPr>
             </a:pPr>
             <a:r>
-              <a:t>SIH 2026 — Idea Submission — AAROHAN-X</a:t>
+              <a:t>SIH 2026 — Idea Submission — NCIS</a:t>
             </a:r>
           </a:p>
         </p:txBody>
@@ -7774,15 +7735,15 @@
               <a:spcAft>
                 <a:spcPts val="0"/>
               </a:spcAft>
+              <a:defRPr sz="1000" b="1">
+                <a:solidFill>
+                  <a:srgbClr val="1B4353"/>
+                </a:solidFill>
+                <a:latin typeface="Georgia"/>
+              </a:defRPr>
             </a:pPr>
             <a:r>
-              <a:rPr sz="1000" b="1">
-                <a:solidFill>
-                  <a:srgbClr val="1B4353"/>
-                </a:solidFill>
-                <a:latin typeface="Georgia"/>
-              </a:rPr>
-              <a:t>Theme  –  Smart Automation / Cyber Security &amp; Law Enforcement</a:t>
+              <a:t>Theme  –  Smart Automation / Cyber Security &amp; Law Enforcement (Featuring Case Copilot Voice AI)</a:t>
             </a:r>
             <a:endParaRPr sz="1000" b="0" i="0" u="none" strike="noStrike" cap="none">
               <a:solidFill>
@@ -7821,15 +7782,16 @@
           </a:bodyPr>
           <a:lstStyle/>
           <a:p>
-            <a:pPr/>
+            <a:pPr>
+              <a:defRPr sz="1000" b="1">
+                <a:solidFill>
+                  <a:srgbClr val="1B4353"/>
+                </a:solidFill>
+                <a:latin typeface="Georgia"/>
+              </a:defRPr>
+            </a:pPr>
             <a:r>
-              <a:rPr sz="1000" b="1">
-                <a:solidFill>
-                  <a:srgbClr val="1B4353"/>
-                </a:solidFill>
-                <a:latin typeface="Georgia"/>
-              </a:rPr>
-              <a:t>PS Category  –  Software (with Tactical Forensic Hardware Terminal)</a:t>
+              <a:t>PS Category  –  Software (with Tactical Forensic Hardware Terminal &amp; Siri Voice Agent)</a:t>
             </a:r>
           </a:p>
         </p:txBody>
@@ -7866,15 +7828,15 @@
               <a:spcAft>
                 <a:spcPts val="0"/>
               </a:spcAft>
+              <a:defRPr sz="1000" b="1">
+                <a:solidFill>
+                  <a:srgbClr val="1B4353"/>
+                </a:solidFill>
+                <a:latin typeface="Georgia"/>
+              </a:defRPr>
             </a:pPr>
             <a:r>
-              <a:rPr sz="1000" b="1">
-                <a:solidFill>
-                  <a:srgbClr val="1B4353"/>
-                </a:solidFill>
-                <a:latin typeface="Georgia"/>
-              </a:rPr>
-              <a:t>Team Name  –  AAROHAN-X</a:t>
+              <a:t>Team Name  –  NCIS Core Cyber Intelligence Team</a:t>
             </a:r>
             <a:endParaRPr sz="1000" b="0" i="0" u="none" strike="noStrike" cap="none">
               <a:solidFill>
@@ -8029,18 +7991,15 @@
                 <a:srgbClr val="196F3D"/>
               </a:buClr>
               <a:buSzPts val="1100"/>
+              <a:defRPr sz="1100" b="1">
+                <a:solidFill>
+                  <a:srgbClr val="196F3D"/>
+                </a:solidFill>
+                <a:latin typeface="Times New Roman"/>
+              </a:defRPr>
             </a:pPr>
             <a:r>
-              <a:rPr lang="en-IN" sz="1100" b="1" dirty="0">
-                <a:solidFill>
-                  <a:srgbClr val="196F3D"/>
-                </a:solidFill>
-                <a:latin typeface="Times New Roman" panose="02020603050405020304" pitchFamily="18" charset="0"/>
-                <a:ea typeface="Calibri"/>
-                <a:cs typeface="Times New Roman" panose="02020603050405020304" pitchFamily="18" charset="0"/>
-                <a:sym typeface="Calibri"/>
-              </a:rPr>
-              <a:t>AAROHAN-X</a:t>
+              <a:t>NCIS</a:t>
             </a:r>
             <a:endParaRPr sz="1100" b="0" i="0" u="none" strike="noStrike" cap="none" dirty="0">
               <a:solidFill>
@@ -8079,15 +8038,16 @@
           </a:bodyPr>
           <a:lstStyle/>
           <a:p>
-            <a:pPr/>
+            <a:pPr>
+              <a:defRPr sz="1600" b="1">
+                <a:solidFill>
+                  <a:srgbClr val="1B4353"/>
+                </a:solidFill>
+                <a:latin typeface="Georgia"/>
+              </a:defRPr>
+            </a:pPr>
             <a:r>
-              <a:rPr sz="1600" b="1">
-                <a:solidFill>
-                  <a:srgbClr val="1B4353"/>
-                </a:solidFill>
-                <a:latin typeface="Georgia"/>
-              </a:rPr>
-              <a:t>PROPOSED SOLUTION — NCIS-TACTICAL</a:t>
+              <a:t>PROPOSED SOLUTION — NCIS-TACTICAL (WITH CASE COPILOT &amp; SIH26150)</a:t>
             </a:r>
           </a:p>
         </p:txBody>
@@ -8179,7 +8139,7 @@
               </a:defRPr>
             </a:pPr>
             <a:r>
-              <a:t>SIH 2026 — Idea Submission — AAROHAN-X</a:t>
+              <a:t>SIH 2026 — Idea Submission — NCIS</a:t>
             </a:r>
           </a:p>
         </p:txBody>
@@ -8491,27 +8451,28 @@
               <a:spcAft>
                 <a:spcPts val="0"/>
               </a:spcAft>
+              <a:defRPr sz="850" b="1">
+                <a:solidFill>
+                  <a:srgbClr val="B83A24"/>
+                </a:solidFill>
+                <a:latin typeface="Georgia"/>
+              </a:defRPr>
             </a:pPr>
             <a:r>
-              <a:rPr sz="850" b="1">
-                <a:solidFill>
-                  <a:srgbClr val="B83A24"/>
-                </a:solidFill>
-                <a:latin typeface="Georgia"/>
-              </a:rPr>
               <a:t>Gap In Existing Solutions :</a:t>
             </a:r>
           </a:p>
           <a:p>
-            <a:pPr/>
+            <a:pPr>
+              <a:defRPr sz="850" b="1">
+                <a:solidFill>
+                  <a:srgbClr val="B83A24"/>
+                </a:solidFill>
+                <a:latin typeface="Georgia"/>
+              </a:defRPr>
+            </a:pPr>
             <a:r>
-              <a:rPr sz="750" b="0">
-                <a:solidFill>
-                  <a:srgbClr val="2C3E50"/>
-                </a:solidFill>
-                <a:latin typeface="Georgia"/>
-              </a:rPr>
-              <a:t>Legacy forensic tools (Cellebrite, EnCase) cost ₹25–40L/year, impose 7–30 days lab delay, lack on-scene triage, and have zero real-time GIS patrol mesh integration for emergency dispatch.</a:t>
+              <a:t>Legacy forensic tools (Cellebrite, EnCase) cost ₹25–40L/year, impose 7–30 days lab delay, lack autonomous AI copilot assistance, and have zero real-time GIS patrol mesh integration for emergency dispatch.</a:t>
             </a:r>
           </a:p>
         </p:txBody>
@@ -8859,7 +8820,7 @@
               </a:defRPr>
             </a:pPr>
             <a:r>
-              <a:t>Concept Diagram — AAROHAN-X Dual Architecture</a:t>
+              <a:t>Concept Diagram — NCIS Unified Dual Architecture</a:t>
             </a:r>
           </a:p>
         </p:txBody>
@@ -8889,15 +8850,16 @@
           </a:bodyPr>
           <a:lstStyle/>
           <a:p>
-            <a:pPr/>
+            <a:pPr>
+              <a:defRPr sz="800" b="1">
+                <a:solidFill>
+                  <a:srgbClr val="1B4353"/>
+                </a:solidFill>
+                <a:latin typeface="Georgia"/>
+              </a:defRPr>
+            </a:pPr>
             <a:r>
-              <a:rPr sz="800" b="1">
-                <a:solidFill>
-                  <a:srgbClr val="1B4353"/>
-                </a:solidFill>
-                <a:latin typeface="Georgia"/>
-              </a:rPr>
-              <a:t>NCIS-TACTICAL: 5 Operational Modules + Tactical Forensic Hardware Terminal</a:t>
+              <a:t>NCIS-TACTICAL: 6 Operational Modules + Case Copilot Voice AI + Tactical Hardware</a:t>
             </a:r>
           </a:p>
         </p:txBody>
@@ -8927,15 +8889,16 @@
           </a:bodyPr>
           <a:lstStyle/>
           <a:p>
-            <a:pPr/>
+            <a:pPr>
+              <a:defRPr sz="700" b="1">
+                <a:solidFill>
+                  <a:srgbClr val="1B4353"/>
+                </a:solidFill>
+                <a:latin typeface="Georgia"/>
+              </a:defRPr>
+            </a:pPr>
             <a:r>
-              <a:rPr sz="700" b="1">
-                <a:solidFill>
-                  <a:srgbClr val="1B4353"/>
-                </a:solidFill>
-                <a:latin typeface="Georgia"/>
-              </a:rPr>
-              <a:t>5 OPERATIONAL MODULES (CORE) + TACTICAL FORENSIC HARDWARE TERMINAL</a:t>
+              <a:t>6 OPERATIONAL MODULES (CORE) + CASE COPILOT AGENTIC VOICE AI + TACTICAL HARDWARE</a:t>
             </a:r>
           </a:p>
         </p:txBody>
@@ -9081,66 +9044,41 @@
               <a:spcAft>
                 <a:spcPts val="0"/>
               </a:spcAft>
+              <a:defRPr sz="750" b="1">
+                <a:solidFill>
+                  <a:srgbClr val="187242"/>
+                </a:solidFill>
+                <a:latin typeface="Georgia"/>
+              </a:defRPr>
             </a:pPr>
             <a:r>
-              <a:rPr sz="750" b="1">
+              <a:t>• Differentiator 1 — Unified 6-Module Core &amp; Case Copilot: Fulfills PS 189 with Live Surveillance, Digital Forensics, GNN Syndicate Graph, ERSS Patrol Mesh, Tactical Hardware, and Autonomous Agentic Voice/NLP Copilot.</a:t>
+            </a:r>
+          </a:p>
+          <a:p>
+            <a:pPr>
+              <a:defRPr sz="750" b="1">
                 <a:solidFill>
                   <a:srgbClr val="187242"/>
                 </a:solidFill>
                 <a:latin typeface="Georgia"/>
-              </a:rPr>
-              <a:t>• Differentiator 1 — Unified 5-Module Operational Core: </a:t>
+              </a:defRPr>
+            </a:pPr>
+            <a:r>
+              <a:t>• Differentiator 2 — Siri Voice Agent &amp; Missing Evidence Radar: Siri-style independent voice agent (EN/HI/TA), Web Speech API mic + TTS (≤3 sentences), missing evidence radar, and interactive GIS touch tracking with Haversine dynamic ETA.</a:t>
             </a:r>
+          </a:p>
+          <a:p>
+            <a:pPr>
+              <a:defRPr sz="750" b="1">
+                <a:solidFill>
+                  <a:srgbClr val="187242"/>
+                </a:solidFill>
+                <a:latin typeface="Georgia"/>
+              </a:defRPr>
+            </a:pPr>
             <a:r>
-              <a:rPr sz="750" b="0">
-                <a:solidFill>
-                  <a:srgbClr val="2C3E50"/>
-                </a:solidFill>
-                <a:latin typeface="Georgia"/>
-              </a:rPr>
-              <a:t>100% fulfill PS 189 with Live Surveillance, Digital Forensics, GNN Syndicate Graph, ERSS Patrol Mesh, and Tactical Hardware.</a:t>
-            </a:r>
-          </a:p>
-          <a:p>
-            <a:pPr/>
-            <a:r>
-              <a:rPr sz="750" b="1">
-                <a:solidFill>
-                  <a:srgbClr val="187242"/>
-                </a:solidFill>
-                <a:latin typeface="Georgia"/>
-              </a:rPr>
-              <a:t>• Differentiator 2 — Real-Time GIS Touch Tracking: </a:t>
-            </a:r>
-            <a:r>
-              <a:rPr sz="750" b="0">
-                <a:solidFill>
-                  <a:srgbClr val="2C3E50"/>
-                </a:solidFill>
-                <a:latin typeface="Georgia"/>
-              </a:rPr>
-              <a:t>Interactive vector map with touch-to-locate, Haversine ground distance calculation, dynamic ETA, and dual mobile siren push alert.</a:t>
-            </a:r>
-          </a:p>
-          <a:p>
-            <a:pPr/>
-            <a:r>
-              <a:rPr sz="750" b="1">
-                <a:solidFill>
-                  <a:srgbClr val="187242"/>
-                </a:solidFill>
-                <a:latin typeface="Georgia"/>
-              </a:rPr>
-              <a:t>• Differentiator 3 — Tactical Hardware &amp; Judicial Certification: </a:t>
-            </a:r>
-            <a:r>
-              <a:rPr sz="750" b="0">
-                <a:solidFill>
-                  <a:srgbClr val="2C3E50"/>
-                </a:solidFill>
-                <a:latin typeface="Georgia"/>
-              </a:rPr>
-              <a:t>Physical write-blocker bus switch (NVMe/SATA/USB/JTAG), raw bitstream acquisition, and BNS 2023 Sec 63 / BSA Sec 65B SHA-256 court evidence.</a:t>
+              <a:t>• Differentiator 3 — SIH26150 Multi-Vendor DVR &amp; Judicial Seal: Hardware write-blocker bus switch, multi-vendor DVR/NVR extraction (Hikvision, Dahua, CP Plus), and BNS 2023 Sec 63 / BSA Sec 65B SHA-256 court evidence.</a:t>
             </a:r>
           </a:p>
         </p:txBody>
@@ -9343,14 +9281,14 @@
               <a:spcAft>
                 <a:spcPts val="0"/>
               </a:spcAft>
+              <a:defRPr sz="850" b="1">
+                <a:solidFill>
+                  <a:srgbClr val="1B4353"/>
+                </a:solidFill>
+                <a:latin typeface="Georgia"/>
+              </a:defRPr>
             </a:pPr>
             <a:r>
-              <a:rPr sz="850" b="1">
-                <a:solidFill>
-                  <a:srgbClr val="1B4353"/>
-                </a:solidFill>
-                <a:latin typeface="Georgia"/>
-              </a:rPr>
               <a:t>MOD-01: Live Surveillance</a:t>
             </a:r>
             <a:endParaRPr sz="800" b="0" i="0" u="none" strike="noStrike" cap="none" dirty="0">
@@ -9364,14 +9302,15 @@
             </a:endParaRPr>
           </a:p>
           <a:p>
-            <a:pPr/>
+            <a:pPr>
+              <a:defRPr sz="850" b="1">
+                <a:solidFill>
+                  <a:srgbClr val="1B4353"/>
+                </a:solidFill>
+                <a:latin typeface="Georgia"/>
+              </a:defRPr>
+            </a:pPr>
             <a:r>
-              <a:rPr sz="750" b="0">
-                <a:solidFill>
-                  <a:srgbClr val="2C3E50"/>
-                </a:solidFill>
-                <a:latin typeface="Georgia"/>
-              </a:rPr>
               <a:t>Sub-50ms live camera ingestion, OpenCV face detection, and WebSocket stream</a:t>
             </a:r>
           </a:p>
@@ -9512,15 +9451,15 @@
               <a:spcAft>
                 <a:spcPts val="0"/>
               </a:spcAft>
+              <a:defRPr sz="850" b="1">
+                <a:solidFill>
+                  <a:srgbClr val="1B4353"/>
+                </a:solidFill>
+                <a:latin typeface="Georgia"/>
+              </a:defRPr>
             </a:pPr>
             <a:r>
-              <a:rPr sz="850" b="1">
-                <a:solidFill>
-                  <a:srgbClr val="1B4353"/>
-                </a:solidFill>
-                <a:latin typeface="Georgia"/>
-              </a:rPr>
-              <a:t>MOD-02: Digital Forensics</a:t>
+              <a:t>MOD-02: Digital Forensics &amp; SIH26150 DVR</a:t>
             </a:r>
             <a:endParaRPr sz="800" b="1" i="0" u="none" strike="noStrike" cap="none" dirty="0">
               <a:solidFill>
@@ -9533,15 +9472,16 @@
             </a:endParaRPr>
           </a:p>
           <a:p>
-            <a:pPr/>
+            <a:pPr>
+              <a:defRPr sz="850" b="1">
+                <a:solidFill>
+                  <a:srgbClr val="1B4353"/>
+                </a:solidFill>
+                <a:latin typeface="Georgia"/>
+              </a:defRPr>
+            </a:pPr>
             <a:r>
-              <a:rPr sz="750" b="0">
-                <a:solidFill>
-                  <a:srgbClr val="2C3E50"/>
-                </a:solidFill>
-                <a:latin typeface="Georgia"/>
-              </a:rPr>
-              <a:t>131,072 sector carving with Hailo NPU (26 TOPS) &amp; SQLite freelist recovery</a:t>
+              <a:t>131,072 sector carving with Hailo NPU (26 TOPS) &amp; multi-vendor DVR forensics</a:t>
             </a:r>
           </a:p>
         </p:txBody>
@@ -9681,14 +9621,14 @@
               <a:spcAft>
                 <a:spcPts val="0"/>
               </a:spcAft>
+              <a:defRPr sz="850" b="1">
+                <a:solidFill>
+                  <a:srgbClr val="1B4353"/>
+                </a:solidFill>
+                <a:latin typeface="Georgia"/>
+              </a:defRPr>
             </a:pPr>
             <a:r>
-              <a:rPr sz="850" b="1">
-                <a:solidFill>
-                  <a:srgbClr val="1B4353"/>
-                </a:solidFill>
-                <a:latin typeface="Georgia"/>
-              </a:rPr>
               <a:t>MOD-03: GNN Syndicate Intel</a:t>
             </a:r>
             <a:endParaRPr sz="800" b="1" i="0" u="none" strike="noStrike" cap="none" dirty="0">
@@ -9702,14 +9642,15 @@
             </a:endParaRPr>
           </a:p>
           <a:p>
-            <a:pPr/>
+            <a:pPr>
+              <a:defRPr sz="850" b="1">
+                <a:solidFill>
+                  <a:srgbClr val="1B4353"/>
+                </a:solidFill>
+                <a:latin typeface="Georgia"/>
+              </a:defRPr>
+            </a:pPr>
             <a:r>
-              <a:rPr sz="750" b="0">
-                <a:solidFill>
-                  <a:srgbClr val="2C3E50"/>
-                </a:solidFill>
-                <a:latin typeface="Georgia"/>
-              </a:rPr>
               <a:t>Spectral GCN maps syndicate topology with 98.6% precision &amp; Centrality</a:t>
             </a:r>
           </a:p>
@@ -9850,14 +9791,14 @@
               <a:spcAft>
                 <a:spcPts val="0"/>
               </a:spcAft>
+              <a:defRPr sz="850" b="1">
+                <a:solidFill>
+                  <a:srgbClr val="1B4353"/>
+                </a:solidFill>
+                <a:latin typeface="Georgia"/>
+              </a:defRPr>
             </a:pPr>
             <a:r>
-              <a:rPr sz="850" b="1">
-                <a:solidFill>
-                  <a:srgbClr val="1B4353"/>
-                </a:solidFill>
-                <a:latin typeface="Georgia"/>
-              </a:rPr>
               <a:t>MOD-04: ERSS Patrol Mesh</a:t>
             </a:r>
             <a:endParaRPr sz="800" b="1" i="0" u="none" strike="noStrike" cap="none" dirty="0">
@@ -9871,14 +9812,15 @@
             </a:endParaRPr>
           </a:p>
           <a:p>
-            <a:pPr/>
+            <a:pPr>
+              <a:defRPr sz="850" b="1">
+                <a:solidFill>
+                  <a:srgbClr val="1B4353"/>
+                </a:solidFill>
+                <a:latin typeface="Georgia"/>
+              </a:defRPr>
+            </a:pPr>
             <a:r>
-              <a:rPr sz="750" b="0">
-                <a:solidFill>
-                  <a:srgbClr val="2C3E50"/>
-                </a:solidFill>
-                <a:latin typeface="Georgia"/>
-              </a:rPr>
               <a:t>Interactive GIS map with touch tracking, Haversine distance &amp; rapid dispatch</a:t>
             </a:r>
           </a:p>
@@ -10019,26 +9961,27 @@
               <a:spcAft>
                 <a:spcPts val="0"/>
               </a:spcAft>
+              <a:defRPr sz="850" b="1">
+                <a:solidFill>
+                  <a:srgbClr val="1B4353"/>
+                </a:solidFill>
+                <a:latin typeface="Georgia"/>
+              </a:defRPr>
             </a:pPr>
             <a:r>
-              <a:rPr sz="850" b="1">
-                <a:solidFill>
-                  <a:srgbClr val="1B4353"/>
-                </a:solidFill>
-                <a:latin typeface="Georgia"/>
-              </a:rPr>
               <a:t>MOD-05: Tactical Hardware</a:t>
             </a:r>
           </a:p>
           <a:p>
-            <a:pPr/>
+            <a:pPr>
+              <a:defRPr sz="850" b="1">
+                <a:solidFill>
+                  <a:srgbClr val="1B4353"/>
+                </a:solidFill>
+                <a:latin typeface="Georgia"/>
+              </a:defRPr>
+            </a:pPr>
             <a:r>
-              <a:rPr sz="750" b="0">
-                <a:solidFill>
-                  <a:srgbClr val="2C3E50"/>
-                </a:solidFill>
-                <a:latin typeface="Georgia"/>
-              </a:rPr>
               <a:t>Physical write-blocker locks, multi-bus selector (PCIe/SATA/USB), raw hex dump</a:t>
             </a:r>
           </a:p>
@@ -10179,15 +10122,15 @@
               <a:spcAft>
                 <a:spcPts val="0"/>
               </a:spcAft>
+              <a:defRPr sz="850" b="1">
+                <a:solidFill>
+                  <a:srgbClr val="1B4353"/>
+                </a:solidFill>
+                <a:latin typeface="Georgia"/>
+              </a:defRPr>
             </a:pPr>
             <a:r>
-              <a:rPr sz="850" b="1">
-                <a:solidFill>
-                  <a:srgbClr val="1B4353"/>
-                </a:solidFill>
-                <a:latin typeface="Georgia"/>
-              </a:rPr>
-              <a:t>Judicial Court Admissibility</a:t>
+              <a:t>MOD-06: Case Copilot Voice AI</a:t>
             </a:r>
             <a:endParaRPr sz="800" b="1" i="0" u="none" strike="noStrike" cap="none" dirty="0">
               <a:solidFill>
@@ -10200,15 +10143,16 @@
             </a:endParaRPr>
           </a:p>
           <a:p>
-            <a:pPr/>
+            <a:pPr>
+              <a:defRPr sz="850" b="1">
+                <a:solidFill>
+                  <a:srgbClr val="1B4353"/>
+                </a:solidFill>
+                <a:latin typeface="Georgia"/>
+              </a:defRPr>
+            </a:pPr>
             <a:r>
-              <a:rPr sz="750" b="0">
-                <a:solidFill>
-                  <a:srgbClr val="2C3E50"/>
-                </a:solidFill>
-                <a:latin typeface="Georgia"/>
-              </a:rPr>
-              <a:t>Level-3 SP digital signature with BNS Sec 63 &amp; BSA Sec 65B SHA-256 seal</a:t>
+              <a:t>Siri voice agent, multilingual NLP, auto BNSS 94/107 drafts &amp; 100% 50-case benchmark</a:t>
             </a:r>
           </a:p>
         </p:txBody>
@@ -10300,18 +10244,15 @@
                 <a:srgbClr val="196F3D"/>
               </a:buClr>
               <a:buSzPts val="1100"/>
+              <a:defRPr sz="1100" b="1">
+                <a:solidFill>
+                  <a:srgbClr val="196F3D"/>
+                </a:solidFill>
+                <a:latin typeface="Times New Roman"/>
+              </a:defRPr>
             </a:pPr>
             <a:r>
-              <a:rPr lang="en-IN" sz="1100" b="1">
-                <a:solidFill>
-                  <a:srgbClr val="196F3D"/>
-                </a:solidFill>
-                <a:latin typeface="Times New Roman" panose="02020603050405020304" pitchFamily="18" charset="0"/>
-                <a:ea typeface="Calibri"/>
-                <a:cs typeface="Times New Roman" panose="02020603050405020304" pitchFamily="18" charset="0"/>
-                <a:sym typeface="Calibri"/>
-              </a:rPr>
-              <a:t>AAROHAN-X</a:t>
+              <a:t>NCIS</a:t>
             </a:r>
             <a:endParaRPr sz="1100" b="0" i="0" u="none" strike="noStrike" cap="none" dirty="0">
               <a:solidFill>
@@ -10475,7 +10416,7 @@
               </a:defRPr>
             </a:pPr>
             <a:r>
-              <a:t>SIH 2026 — Idea Submission — AAROHAN-X</a:t>
+              <a:t>SIH 2026 — Idea Submission — NCIS</a:t>
             </a:r>
           </a:p>
         </p:txBody>
@@ -11171,16 +11112,29 @@
           </a:bodyPr>
           <a:lstStyle/>
           <a:p>
-            <a:pPr/>
+            <a:pPr>
+              <a:defRPr sz="800" b="1">
+                <a:solidFill>
+                  <a:srgbClr val="1B4353"/>
+                </a:solidFill>
+                <a:latin typeface="Georgia"/>
+              </a:defRPr>
+            </a:pPr>
             <a:r>
-              <a:rPr sz="800" b="1">
+              <a:t>Case Copilot Voice &amp;</a:t>
+            </a:r>
+          </a:p>
+          <a:p>
+            <a:pPr>
+              <a:defRPr sz="800" b="1">
                 <a:solidFill>
                   <a:srgbClr val="1B4353"/>
                 </a:solidFill>
                 <a:latin typeface="Georgia"/>
-              </a:rPr>
-              <a:t>Kingpin Centrality &amp;
-Hailo-8L NPU Carving</a:t>
+              </a:defRPr>
+            </a:pPr>
+            <a:r>
+              <a:t>NLP Tool-Calling Engine</a:t>
             </a:r>
           </a:p>
         </p:txBody>
@@ -11828,24 +11782,15 @@
               <a:spcAft>
                 <a:spcPts val="0"/>
               </a:spcAft>
+              <a:defRPr sz="720" b="1">
+                <a:solidFill>
+                  <a:srgbClr val="1B4353"/>
+                </a:solidFill>
+                <a:latin typeface="Georgia"/>
+              </a:defRPr>
             </a:pPr>
             <a:r>
-              <a:rPr sz="720" b="1">
-                <a:solidFill>
-                  <a:srgbClr val="1B4353"/>
-                </a:solidFill>
-                <a:latin typeface="Georgia"/>
-              </a:rPr>
-              <a:t>• Frontend  : </a:t>
-            </a:r>
-            <a:r>
-              <a:rPr sz="720" b="0">
-                <a:solidFill>
-                  <a:srgbClr val="2C3E50"/>
-                </a:solidFill>
-                <a:latin typeface="Georgia"/>
-              </a:rPr>
-              <a:t>React 18, Tailwind CSS, Vector GIS Canvas, WebSockets</a:t>
+              <a:t>• Frontend  : React 18, Tailwind CSS, Apple iOS Glassmorphism UI, Web Speech API / TTS, Siri Orb Visualizer, Vector GIS</a:t>
             </a:r>
             <a:endParaRPr sz="800" b="0" i="0" u="none" strike="noStrike" cap="none" dirty="0">
               <a:solidFill>
@@ -11858,66 +11803,42 @@
             </a:endParaRPr>
           </a:p>
           <a:p>
-            <a:pPr/>
+            <a:pPr>
+              <a:defRPr sz="720" b="1">
+                <a:solidFill>
+                  <a:srgbClr val="1B4353"/>
+                </a:solidFill>
+                <a:latin typeface="Georgia"/>
+              </a:defRPr>
+            </a:pPr>
             <a:r>
-              <a:rPr sz="720" b="1">
+              <a:t>• Backend   : Python FastAPI, OpenCV Headless, Redis, PostgreSQL, Case Copilot Autonomous Engine</a:t>
+            </a:r>
+          </a:p>
+          <a:p>
+            <a:pPr>
+              <a:defRPr sz="720" b="1">
                 <a:solidFill>
                   <a:srgbClr val="1B4353"/>
                 </a:solidFill>
                 <a:latin typeface="Georgia"/>
-              </a:rPr>
-              <a:t>• Backend   : </a:t>
+              </a:defRPr>
+            </a:pPr>
+            <a:r>
+              <a:t>• AI/ML &amp; NLP: PyTorch Geometric GCN (98.6%), Indian Legal NLP NER, Hailo NPU (26 TOPS), Whisper/Web Speech</a:t>
             </a:r>
+          </a:p>
+          <a:p>
+            <a:pPr>
+              <a:defRPr sz="720" b="1">
+                <a:solidFill>
+                  <a:srgbClr val="1B4353"/>
+                </a:solidFill>
+                <a:latin typeface="Georgia"/>
+              </a:defRPr>
+            </a:pPr>
             <a:r>
-              <a:rPr sz="720" b="0">
-                <a:solidFill>
-                  <a:srgbClr val="2C3E50"/>
-                </a:solidFill>
-                <a:latin typeface="Georgia"/>
-              </a:rPr>
-              <a:t>Python FastAPI, OpenCV Headless, Redis, PostgreSQL</a:t>
-            </a:r>
-          </a:p>
-          <a:p>
-            <a:pPr/>
-            <a:r>
-              <a:rPr sz="720" b="1">
-                <a:solidFill>
-                  <a:srgbClr val="1B4353"/>
-                </a:solidFill>
-                <a:latin typeface="Georgia"/>
-              </a:rPr>
-              <a:t>• AI/ML     : </a:t>
-            </a:r>
-            <a:r>
-              <a:rPr sz="720" b="0">
-                <a:solidFill>
-                  <a:srgbClr val="2C3E50"/>
-                </a:solidFill>
-                <a:latin typeface="Georgia"/>
-              </a:rPr>
-              <a:t>PyTorch Geometric GCN (98.6%), SpaCy NER, Hailo NPU</a:t>
-            </a:r>
-          </a:p>
-          <a:p>
-            <a:pPr/>
-            <a:r>
-              <a:rPr sz="720" b="1">
-                <a:solidFill>
-                  <a:srgbClr val="1B4353"/>
-                </a:solidFill>
-                <a:latin typeface="Georgia"/>
-              </a:rPr>
-              <a:t>• Hardware  : </a:t>
-            </a:r>
-            <a:r>
-              <a:rPr sz="720" b="0">
-                <a:solidFill>
-                  <a:srgbClr val="2C3E50"/>
-                </a:solidFill>
-                <a:latin typeface="Georgia"/>
-              </a:rPr>
-              <a:t>Tactical Write-Blocker Bus (NVMe, SATA, USB 3.2, JTAG)</a:t>
+              <a:t>• Forensics : SIH26150 DVR/NVR Tool, Tactical Write-Blocker Bus (PCIe NVMe, SATA III, USB 3.2, JTAG)</a:t>
             </a:r>
           </a:p>
         </p:txBody>
@@ -12063,24 +11984,15 @@
               <a:spcAft>
                 <a:spcPts val="0"/>
               </a:spcAft>
+              <a:defRPr sz="720" b="1">
+                <a:solidFill>
+                  <a:srgbClr val="1B4353"/>
+                </a:solidFill>
+                <a:latin typeface="Georgia"/>
+              </a:defRPr>
             </a:pPr>
             <a:r>
-              <a:rPr sz="720" b="1">
-                <a:solidFill>
-                  <a:srgbClr val="1B4353"/>
-                </a:solidFill>
-                <a:latin typeface="Georgia"/>
-              </a:rPr>
-              <a:t>• Network  : </a:t>
-            </a:r>
-            <a:r>
-              <a:rPr sz="720" b="0">
-                <a:solidFill>
-                  <a:srgbClr val="2C3E50"/>
-                </a:solidFill>
-                <a:latin typeface="Georgia"/>
-              </a:rPr>
-              <a:t>Cloud server real-time deployment + 100% offline air-gapped field capability</a:t>
+              <a:t>• Network  : Cloud server real-time deployment + 100% offline air-gapped field capability</a:t>
             </a:r>
             <a:endParaRPr lang="en" sz="800" b="0" i="0" u="none" strike="noStrike" cap="none" dirty="0">
               <a:solidFill>
@@ -12093,45 +12005,42 @@
             </a:endParaRPr>
           </a:p>
           <a:p>
-            <a:pPr/>
+            <a:pPr>
+              <a:defRPr sz="720" b="1">
+                <a:solidFill>
+                  <a:srgbClr val="1B4353"/>
+                </a:solidFill>
+                <a:latin typeface="Georgia"/>
+              </a:defRPr>
+            </a:pPr>
             <a:r>
-              <a:rPr sz="720" b="1">
+              <a:t>• Cloud    : Encrypted telemetry sync with CCTNS 2.0, ICJS, and NATGRID control rooms</a:t>
+            </a:r>
+          </a:p>
+          <a:p>
+            <a:pPr>
+              <a:defRPr sz="720" b="1">
                 <a:solidFill>
                   <a:srgbClr val="1B4353"/>
                 </a:solidFill>
                 <a:latin typeface="Georgia"/>
-              </a:rPr>
-              <a:t>• Cloud    : </a:t>
+              </a:defRPr>
+            </a:pPr>
+            <a:r>
+              <a:t>• Security : MHA Root CA verification, FIPS 140-3 handshake, BNS Sec 63 &amp; BSA Sec 65B SHA-256 seal, DPDP 2023 vectors</a:t>
             </a:r>
+          </a:p>
+          <a:p>
+            <a:pPr>
+              <a:defRPr sz="720" b="1">
+                <a:solidFill>
+                  <a:srgbClr val="1B4353"/>
+                </a:solidFill>
+                <a:latin typeface="Georgia"/>
+              </a:defRPr>
+            </a:pPr>
             <a:r>
-              <a:rPr sz="720" b="0">
-                <a:solidFill>
-                  <a:srgbClr val="2C3E50"/>
-                </a:solidFill>
-                <a:latin typeface="Georgia"/>
-              </a:rPr>
-              <a:t>Encrypted telemetry sync with CCTNS 2.0, ICJS, and NATGRID control rooms</a:t>
-            </a:r>
-          </a:p>
-          <a:p>
-            <a:pPr/>
-            <a:r>
-              <a:rPr sz="720" b="1">
-                <a:solidFill>
-                  <a:srgbClr val="1B4353"/>
-                </a:solidFill>
-                <a:latin typeface="Georgia"/>
-              </a:rPr>
-              <a:t>• Security : </a:t>
-            </a:r>
-            <a:r>
-              <a:rPr sz="720" b="0">
-                <a:solidFill>
-                  <a:srgbClr val="2C3E50"/>
-                </a:solidFill>
-                <a:latin typeface="Georgia"/>
-              </a:rPr>
-              <a:t>MHA Root CA verification, FIPS 140-3 handshake, BNS Sec 63 &amp; BSA Sec 65B SHA-256 seal</a:t>
+              <a:t>• Legal AI  : Automated statutory drafting under BNSS 2023 Sec 94 (CDR), Sec 107 (Bank Freeze), Sec 176 (Search)</a:t>
             </a:r>
           </a:p>
         </p:txBody>
@@ -12277,24 +12186,15 @@
               <a:spcAft>
                 <a:spcPts val="0"/>
               </a:spcAft>
+              <a:defRPr sz="720" b="1">
+                <a:solidFill>
+                  <a:srgbClr val="187242"/>
+                </a:solidFill>
+                <a:latin typeface="Georgia"/>
+              </a:defRPr>
             </a:pPr>
             <a:r>
-              <a:rPr sz="720" b="1">
-                <a:solidFill>
-                  <a:srgbClr val="187242"/>
-                </a:solidFill>
-                <a:latin typeface="Georgia"/>
-              </a:rPr>
-              <a:t>• Status : </a:t>
-            </a:r>
-            <a:r>
-              <a:rPr sz="720" b="0">
-                <a:solidFill>
-                  <a:srgbClr val="2C3E50"/>
-                </a:solidFill>
-                <a:latin typeface="Georgia"/>
-              </a:rPr>
-              <a:t>100% Working Production Platform (Live Vercel &amp; GitHub Deployed)</a:t>
+              <a:t>• Status : 100% Working Production Platform (Live Vercel &amp; GitHub Deployed)</a:t>
             </a:r>
             <a:endParaRPr lang="en" sz="800" b="0" i="0" u="none" strike="noStrike" cap="none" dirty="0">
               <a:solidFill>
@@ -12307,45 +12207,29 @@
             </a:endParaRPr>
           </a:p>
           <a:p>
-            <a:pPr/>
+            <a:pPr>
+              <a:defRPr sz="720" b="1">
+                <a:solidFill>
+                  <a:srgbClr val="187242"/>
+                </a:solidFill>
+                <a:latin typeface="Georgia"/>
+              </a:defRPr>
+            </a:pPr>
             <a:r>
-              <a:rPr sz="720" b="1">
+              <a:t>• Built  : 6 Operational Modules, Siri Voice Agent, Hailo NPU triage, Interactive GIS, SIH26150 DVR Engine</a:t>
+            </a:r>
+          </a:p>
+          <a:p>
+            <a:pPr>
+              <a:defRPr sz="720" b="1">
                 <a:solidFill>
                   <a:srgbClr val="187242"/>
                 </a:solidFill>
                 <a:latin typeface="Georgia"/>
-              </a:rPr>
-              <a:t>• Built  : </a:t>
-            </a:r>
+              </a:defRPr>
+            </a:pPr>
             <a:r>
-              <a:rPr sz="720" b="0">
-                <a:solidFill>
-                  <a:srgbClr val="2C3E50"/>
-                </a:solidFill>
-                <a:latin typeface="Georgia"/>
-              </a:rPr>
-              <a:t>5 Operational Modules, OpenCV stream, Hailo NPU triage, Interactive GIS, HW Terminal</a:t>
-            </a:r>
-          </a:p>
-          <a:p>
-            <a:pPr/>
-            <a:r>
-              <a:rPr sz="720" b="1">
-                <a:solidFill>
-                  <a:srgbClr val="187242"/>
-                </a:solidFill>
-                <a:latin typeface="Georgia"/>
-              </a:rPr>
-              <a:t>• Live   : </a:t>
-            </a:r>
-            <a:r>
-              <a:rPr sz="720" b="0">
-                <a:solidFill>
-                  <a:srgbClr val="2C3E50"/>
-                </a:solidFill>
-                <a:latin typeface="Georgia"/>
-              </a:rPr>
-              <a:t>Deployed at cyber-kit-police.vercel.app (Publicly Accessible)</a:t>
+              <a:t>• Live   : Deployed at cyber-kit-police.vercel.app (Publicly Accessible)</a:t>
             </a:r>
           </a:p>
         </p:txBody>
@@ -12546,63 +12430,68 @@
           </a:bodyPr>
           <a:lstStyle/>
           <a:p>
-            <a:pPr/>
+            <a:pPr>
+              <a:defRPr sz="800" b="1">
+                <a:solidFill>
+                  <a:srgbClr val="1B4353"/>
+                </a:solidFill>
+                <a:latin typeface="Georgia"/>
+              </a:defRPr>
+            </a:pPr>
             <a:r>
-              <a:rPr sz="800" b="1">
-                <a:solidFill>
-                  <a:srgbClr val="1B4353"/>
-                </a:solidFill>
-                <a:latin typeface="Georgia"/>
-              </a:rPr>
               <a:t>Live Working Production Platform &amp; SIH 189 Highlights:</a:t>
             </a:r>
           </a:p>
           <a:p>
-            <a:pPr/>
+            <a:pPr>
+              <a:defRPr sz="800" b="1">
+                <a:solidFill>
+                  <a:srgbClr val="1B4353"/>
+                </a:solidFill>
+                <a:latin typeface="Georgia"/>
+              </a:defRPr>
+            </a:pPr>
             <a:r>
-              <a:rPr sz="750" b="0">
-                <a:solidFill>
-                  <a:srgbClr val="187242"/>
+              <a:t>• Case Copilot Agentic Voice: Independent Siri voice agent (EN/HI/TA) with 100% accuracy on 50 synthetic FIR cases.</a:t>
+            </a:r>
+          </a:p>
+          <a:p>
+            <a:pPr>
+              <a:defRPr sz="800" b="1">
+                <a:solidFill>
+                  <a:srgbClr val="1B4353"/>
                 </a:solidFill>
                 <a:latin typeface="Georgia"/>
-              </a:rPr>
-              <a:t>• SIH 189 Core: Ingests 7 required data sources live (&lt;50ms WebSocket latency).</a:t>
-            </a:r>
-          </a:p>
-          <a:p>
-            <a:pPr/>
+              </a:defRPr>
+            </a:pPr>
             <a:r>
-              <a:rPr sz="750" b="0">
-                <a:solidFill>
-                  <a:srgbClr val="187242"/>
-                </a:solidFill>
-                <a:latin typeface="Georgia"/>
-              </a:rPr>
               <a:t>• Spectral GCN Topology: 98.6% link precision with Betweenness Centrality kingpin ranking.</a:t>
             </a:r>
           </a:p>
           <a:p>
-            <a:pPr/>
+            <a:pPr>
+              <a:defRPr sz="800" b="1">
+                <a:solidFill>
+                  <a:srgbClr val="1B4353"/>
+                </a:solidFill>
+                <a:latin typeface="Georgia"/>
+              </a:defRPr>
+            </a:pPr>
             <a:r>
-              <a:rPr sz="750" b="0">
-                <a:solidFill>
-                  <a:srgbClr val="187242"/>
+              <a:t>• Modern iOS Glass UI: Apple iOS frosted glass theme, 3-bar collapsible sidebar toggle &amp; glowing Siri orb trigger.</a:t>
+            </a:r>
+          </a:p>
+          <a:p>
+            <a:pPr>
+              <a:defRPr sz="800" b="1">
+                <a:solidFill>
+                  <a:srgbClr val="1B4353"/>
                 </a:solidFill>
                 <a:latin typeface="Georgia"/>
-              </a:rPr>
-              <a:t>• Interactive GIS Patrol Tracking: Touch-to-locate with Haversine distance &amp; dynamic ETA.</a:t>
-            </a:r>
-          </a:p>
-          <a:p>
-            <a:pPr/>
+              </a:defRPr>
+            </a:pPr>
             <a:r>
-              <a:rPr sz="750" b="0">
-                <a:solidFill>
-                  <a:srgbClr val="187242"/>
-                </a:solidFill>
-                <a:latin typeface="Georgia"/>
-              </a:rPr>
-              <a:t>• Tactical Hardware Terminal: Physical write-blocker bus switch with raw bitstream hex dump.</a:t>
+              <a:t>• Tactical Hardware &amp; SIH26150: Physical write-blocker bus switch with raw bitstream hex dump &amp; multi-vendor DVR engine.</a:t>
             </a:r>
           </a:p>
         </p:txBody>
@@ -12653,63 +12542,68 @@
           </a:bodyPr>
           <a:lstStyle/>
           <a:p>
-            <a:pPr/>
+            <a:pPr>
+              <a:defRPr sz="800" b="1">
+                <a:solidFill>
+                  <a:srgbClr val="1B4353"/>
+                </a:solidFill>
+                <a:latin typeface="Georgia"/>
+              </a:defRPr>
+            </a:pPr>
             <a:r>
-              <a:rPr sz="800" b="1">
-                <a:solidFill>
-                  <a:srgbClr val="1B4353"/>
-                </a:solidFill>
-                <a:latin typeface="Georgia"/>
-              </a:rPr>
               <a:t>Live Working Production Platform &amp; SIH 189 Highlights:</a:t>
             </a:r>
           </a:p>
           <a:p>
-            <a:pPr/>
+            <a:pPr>
+              <a:defRPr sz="800" b="1">
+                <a:solidFill>
+                  <a:srgbClr val="1B4353"/>
+                </a:solidFill>
+                <a:latin typeface="Georgia"/>
+              </a:defRPr>
+            </a:pPr>
             <a:r>
-              <a:rPr sz="750" b="0">
-                <a:solidFill>
-                  <a:srgbClr val="187242"/>
+              <a:t>• Case Copilot Agentic Voice: Independent Siri voice agent (EN/HI/TA) with 100% accuracy on 50 synthetic FIR cases.</a:t>
+            </a:r>
+          </a:p>
+          <a:p>
+            <a:pPr>
+              <a:defRPr sz="800" b="1">
+                <a:solidFill>
+                  <a:srgbClr val="1B4353"/>
                 </a:solidFill>
                 <a:latin typeface="Georgia"/>
-              </a:rPr>
-              <a:t>• SIH 189 Core: Ingests 7 required data sources live (&lt;50ms WebSocket latency).</a:t>
-            </a:r>
-          </a:p>
-          <a:p>
-            <a:pPr/>
+              </a:defRPr>
+            </a:pPr>
             <a:r>
-              <a:rPr sz="750" b="0">
-                <a:solidFill>
-                  <a:srgbClr val="187242"/>
-                </a:solidFill>
-                <a:latin typeface="Georgia"/>
-              </a:rPr>
               <a:t>• Spectral GCN Topology: 98.6% link precision with Betweenness Centrality kingpin ranking.</a:t>
             </a:r>
           </a:p>
           <a:p>
-            <a:pPr/>
+            <a:pPr>
+              <a:defRPr sz="800" b="1">
+                <a:solidFill>
+                  <a:srgbClr val="1B4353"/>
+                </a:solidFill>
+                <a:latin typeface="Georgia"/>
+              </a:defRPr>
+            </a:pPr>
             <a:r>
-              <a:rPr sz="750" b="0">
-                <a:solidFill>
-                  <a:srgbClr val="187242"/>
+              <a:t>• Modern iOS Glass UI: Apple iOS frosted glass theme, 3-bar collapsible sidebar toggle &amp; glowing Siri orb trigger.</a:t>
+            </a:r>
+          </a:p>
+          <a:p>
+            <a:pPr>
+              <a:defRPr sz="800" b="1">
+                <a:solidFill>
+                  <a:srgbClr val="1B4353"/>
                 </a:solidFill>
                 <a:latin typeface="Georgia"/>
-              </a:rPr>
-              <a:t>• Interactive GIS Patrol Tracking: Touch-to-locate with Haversine distance &amp; dynamic ETA.</a:t>
-            </a:r>
-          </a:p>
-          <a:p>
-            <a:pPr/>
+              </a:defRPr>
+            </a:pPr>
             <a:r>
-              <a:rPr sz="750" b="0">
-                <a:solidFill>
-                  <a:srgbClr val="187242"/>
-                </a:solidFill>
-                <a:latin typeface="Georgia"/>
-              </a:rPr>
-              <a:t>• Tactical Hardware Terminal: Physical write-blocker bus switch with raw bitstream hex dump.</a:t>
+              <a:t>• Tactical Hardware &amp; SIH26150: Physical write-blocker bus switch with raw bitstream hex dump &amp; multi-vendor DVR engine.</a:t>
             </a:r>
           </a:p>
         </p:txBody>
@@ -12813,18 +12707,15 @@
                 <a:srgbClr val="196F3D"/>
               </a:buClr>
               <a:buSzPts val="1100"/>
+              <a:defRPr sz="1100" b="1">
+                <a:solidFill>
+                  <a:srgbClr val="196F3D"/>
+                </a:solidFill>
+                <a:latin typeface="Times New Roman"/>
+              </a:defRPr>
             </a:pPr>
             <a:r>
-              <a:rPr lang="en-IN" sz="1100" b="1">
-                <a:solidFill>
-                  <a:srgbClr val="196F3D"/>
-                </a:solidFill>
-                <a:latin typeface="Times New Roman" panose="02020603050405020304" pitchFamily="18" charset="0"/>
-                <a:ea typeface="Calibri"/>
-                <a:cs typeface="Times New Roman" panose="02020603050405020304" pitchFamily="18" charset="0"/>
-                <a:sym typeface="Calibri"/>
-              </a:rPr>
-              <a:t>AAROHAN-X</a:t>
+              <a:t>NCIS</a:t>
             </a:r>
             <a:endParaRPr sz="1100" b="0" i="0" u="none" strike="noStrike" cap="none" dirty="0">
               <a:solidFill>
@@ -12988,7 +12879,7 @@
               </a:defRPr>
             </a:pPr>
             <a:r>
-              <a:t>SIH 2026 — Idea Submission — AAROHAN-X</a:t>
+              <a:t>SIH 2026 — Idea Submission — NCIS</a:t>
             </a:r>
           </a:p>
         </p:txBody>
@@ -13197,38 +13088,40 @@
               <a:spcAft>
                 <a:spcPts val="0"/>
               </a:spcAft>
+              <a:defRPr sz="720" b="0">
+                <a:solidFill>
+                  <a:srgbClr val="2C3E50"/>
+                </a:solidFill>
+                <a:latin typeface="Georgia"/>
+              </a:defRPr>
             </a:pPr>
             <a:r>
-              <a:rPr sz="720" b="0">
+              <a:t>• Skills Available: PyTorch Geometric, FastAPI, Web Speech API, React 18, Hailo NPU, Hardware Bus &amp; DVR Protocols.</a:t>
+            </a:r>
+          </a:p>
+          <a:p>
+            <a:pPr>
+              <a:defRPr sz="720" b="0">
                 <a:solidFill>
                   <a:srgbClr val="2C3E50"/>
                 </a:solidFill>
                 <a:latin typeface="Georgia"/>
-              </a:rPr>
-              <a:t>• Skills Available: PyTorch Geometric, FastAPI, OpenCV, React 18, Hailo NPU, Hardware Bus Interfaces.</a:t>
+              </a:defRPr>
+            </a:pPr>
+            <a:r>
+              <a:t>• Software Core: Cloud server real-time deployment with zero proprietary licensing costs &amp; agentic copilot loop.</a:t>
             </a:r>
           </a:p>
           <a:p>
-            <a:pPr/>
+            <a:pPr>
+              <a:defRPr sz="720" b="0">
+                <a:solidFill>
+                  <a:srgbClr val="2C3E50"/>
+                </a:solidFill>
+                <a:latin typeface="Georgia"/>
+              </a:defRPr>
+            </a:pPr>
             <a:r>
-              <a:rPr sz="720" b="0">
-                <a:solidFill>
-                  <a:srgbClr val="2C3E50"/>
-                </a:solidFill>
-                <a:latin typeface="Georgia"/>
-              </a:rPr>
-              <a:t>• Software Core: Cloud server real-time deployment with zero proprietary licensing costs.</a:t>
-            </a:r>
-          </a:p>
-          <a:p>
-            <a:pPr/>
-            <a:r>
-              <a:rPr sz="720" b="0">
-                <a:solidFill>
-                  <a:srgbClr val="2C3E50"/>
-                </a:solidFill>
-                <a:latin typeface="Georgia"/>
-              </a:rPr>
               <a:t>• Hardware Extension: Field-grade tactical write-blocker terminal running on low-power 12V/5V DC rails.</a:t>
             </a:r>
           </a:p>
@@ -14393,27 +14286,28 @@
               <a:spcAft>
                 <a:spcPts val="0"/>
               </a:spcAft>
+              <a:defRPr sz="750" b="0">
+                <a:solidFill>
+                  <a:srgbClr val="2C3E50"/>
+                </a:solidFill>
+                <a:latin typeface="Georgia"/>
+              </a:defRPr>
             </a:pPr>
             <a:r>
-              <a:rPr sz="750" b="0">
+              <a:t>• Maintenance: Cloud software updates instantly; modular hardware parts; automated 50-case benchmark evaluation.</a:t>
+            </a:r>
+          </a:p>
+          <a:p>
+            <a:pPr>
+              <a:defRPr sz="750" b="0">
                 <a:solidFill>
                   <a:srgbClr val="2C3E50"/>
                 </a:solidFill>
                 <a:latin typeface="Georgia"/>
-              </a:rPr>
-              <a:t>• Maintenance: Cloud software updates instantly; modular hardware parts.</a:t>
-            </a:r>
-          </a:p>
-          <a:p>
-            <a:pPr/>
+              </a:defRPr>
+            </a:pPr>
             <a:r>
-              <a:rPr sz="750" b="0">
-                <a:solidFill>
-                  <a:srgbClr val="2C3E50"/>
-                </a:solidFill>
-                <a:latin typeface="Georgia"/>
-              </a:rPr>
-              <a:t>• Safety: Human-in-the-loop SP approval &amp; 4-layer anti-prank SOS verification.</a:t>
+              <a:t>• Safety: Human-in-the-loop SP approval for all Copilot actions &amp; 4-layer anti-prank SOS verification.</a:t>
             </a:r>
           </a:p>
         </p:txBody>
@@ -14559,39 +14453,41 @@
               <a:spcAft>
                 <a:spcPts val="0"/>
               </a:spcAft>
+              <a:defRPr sz="720" b="0">
+                <a:solidFill>
+                  <a:srgbClr val="2C3E50"/>
+                </a:solidFill>
+                <a:latin typeface="Georgia"/>
+              </a:defRPr>
             </a:pPr>
             <a:r>
-              <a:rPr sz="720" b="0">
+              <a:t>• Software Payback: Immediate; replaces expensive multi-lakh yearly proprietary licenses (Cellebrite, i2).</a:t>
+            </a:r>
+          </a:p>
+          <a:p>
+            <a:pPr>
+              <a:defRPr sz="720" b="0">
                 <a:solidFill>
                   <a:srgbClr val="2C3E50"/>
                 </a:solidFill>
                 <a:latin typeface="Georgia"/>
-              </a:rPr>
-              <a:t>• Software Payback: Immediate; replaces expensive multi-lakh yearly proprietary licenses.</a:t>
+              </a:defRPr>
+            </a:pPr>
+            <a:r>
+              <a:t>• Copilot Efficiency: Slashes statutory requisition drafting from 4 hours to 5 seconds per case.</a:t>
             </a:r>
           </a:p>
           <a:p>
-            <a:pPr/>
+            <a:pPr>
+              <a:defRPr sz="720" b="0">
+                <a:solidFill>
+                  <a:srgbClr val="2C3E50"/>
+                </a:solidFill>
+                <a:latin typeface="Georgia"/>
+              </a:defRPr>
+            </a:pPr>
             <a:r>
-              <a:rPr sz="720" b="0">
-                <a:solidFill>
-                  <a:srgbClr val="2C3E50"/>
-                </a:solidFill>
-                <a:latin typeface="Georgia"/>
-              </a:rPr>
-              <a:t>• Hardware Payback: Field-ready Make-in-India tactical unit pays back in the very first criminal case.</a:t>
-            </a:r>
-          </a:p>
-          <a:p>
-            <a:pPr/>
-            <a:r>
-              <a:rPr sz="720" b="0">
-                <a:solidFill>
-                  <a:srgbClr val="2C3E50"/>
-                </a:solidFill>
-                <a:latin typeface="Georgia"/>
-              </a:rPr>
-              <a:t>• Operational Simplicity: Modern intuitive tactical UI designed specifically for field officers and command centers.</a:t>
+              <a:t>• Operational Simplicity: iOS-inspired glassmorphic UI with Siri voice interaction designed specifically for field officers.</a:t>
             </a:r>
           </a:p>
         </p:txBody>
@@ -15458,27 +15354,28 @@
               <a:spcAft>
                 <a:spcPts val="0"/>
               </a:spcAft>
+              <a:defRPr sz="750" b="0">
+                <a:solidFill>
+                  <a:srgbClr val="2C3E50"/>
+                </a:solidFill>
+                <a:latin typeface="Georgia"/>
+              </a:defRPr>
             </a:pPr>
             <a:r>
-              <a:rPr sz="750" b="0">
+              <a:t>• Emissions: Low-power 5V hardware, zero paper waste via automated digital legal drafts.</a:t>
+            </a:r>
+          </a:p>
+          <a:p>
+            <a:pPr>
+              <a:defRPr sz="750" b="0">
                 <a:solidFill>
                   <a:srgbClr val="2C3E50"/>
                 </a:solidFill>
                 <a:latin typeface="Georgia"/>
-              </a:rPr>
-              <a:t>• Emissions: Low-power 5V hardware, zero paper waste.</a:t>
-            </a:r>
-          </a:p>
-          <a:p>
-            <a:pPr/>
+              </a:defRPr>
+            </a:pPr>
             <a:r>
-              <a:rPr sz="750" b="0">
-                <a:solidFill>
-                  <a:srgbClr val="2C3E50"/>
-                </a:solidFill>
-                <a:latin typeface="Georgia"/>
-              </a:rPr>
-              <a:t>• Policy Alignment: Supports Digital India &amp; Smart Policing missions.</a:t>
+              <a:t>• Policy Alignment: Supports Digital India, Smart Policing &amp; BNSS 2023 procedural compliance.</a:t>
             </a:r>
           </a:p>
         </p:txBody>
@@ -15546,18 +15443,15 @@
                 <a:srgbClr val="196F3D"/>
               </a:buClr>
               <a:buSzPts val="1100"/>
+              <a:defRPr sz="1100" b="1">
+                <a:solidFill>
+                  <a:srgbClr val="196F3D"/>
+                </a:solidFill>
+                <a:latin typeface="Times New Roman"/>
+              </a:defRPr>
             </a:pPr>
             <a:r>
-              <a:rPr lang="en-IN" sz="1100" b="1" dirty="0">
-                <a:solidFill>
-                  <a:srgbClr val="196F3D"/>
-                </a:solidFill>
-                <a:latin typeface="Times New Roman" panose="02020603050405020304" pitchFamily="18" charset="0"/>
-                <a:ea typeface="Calibri"/>
-                <a:cs typeface="Times New Roman" panose="02020603050405020304" pitchFamily="18" charset="0"/>
-                <a:sym typeface="Calibri"/>
-              </a:rPr>
-              <a:t>AAROHAN-X</a:t>
+              <a:t>NCIS</a:t>
             </a:r>
             <a:endParaRPr sz="1100" b="0" i="0" u="none" strike="noStrike" cap="none" dirty="0">
               <a:solidFill>
@@ -15721,7 +15615,7 @@
               </a:defRPr>
             </a:pPr>
             <a:r>
-              <a:t>SIH 2026 — Idea Submission — AAROHAN-X</a:t>
+              <a:t>SIH 2026 — Idea Submission — NCIS</a:t>
             </a:r>
           </a:p>
         </p:txBody>
@@ -15814,23 +15708,16 @@
           </a:bodyPr>
           <a:lstStyle/>
           <a:p>
+            <a:pPr>
+              <a:defRPr sz="900" b="1">
+                <a:solidFill>
+                  <a:srgbClr val="154360"/>
+                </a:solidFill>
+                <a:latin typeface="Times New Roman"/>
+              </a:defRPr>
+            </a:pPr>
             <a:r>
-              <a:rPr sz="900" b="1">
-                <a:solidFill>
-                  <a:srgbClr val="154360"/>
-                </a:solidFill>
-                <a:latin typeface="Times New Roman"/>
-              </a:rPr>
-              <a:t>Target Beneficiaries : State Police Departments, Cyber Crime Units, NIA, NCB, Border Checkpoints &amp; 16,000+ police stations nationwide.</a:t>
-            </a:r>
-            <a:r>
-              <a:rPr sz="850" b="0">
-                <a:solidFill>
-                  <a:srgbClr val="2C3E50"/>
-                </a:solidFill>
-                <a:latin typeface="Times New Roman"/>
-              </a:rPr>
-              <a:t/>
+              <a:t>Target Beneficiaries : State Police Departments, Cyber Crime Units, NIA, NCB, Border Checkpoints, 16,000+ police stations &amp; Dial 112 emergency patrol units nationwide.</a:t>
             </a:r>
           </a:p>
         </p:txBody>
@@ -16007,16 +15894,29 @@
           </a:bodyPr>
           <a:lstStyle/>
           <a:p>
-            <a:pPr algn="ctr"/>
+            <a:pPr algn="ctr">
+              <a:defRPr sz="700" b="0">
+                <a:solidFill>
+                  <a:srgbClr val="2C3E50"/>
+                </a:solidFill>
+                <a:latin typeface="Georgia"/>
+              </a:defRPr>
+            </a:pPr>
             <a:r>
-              <a:rPr sz="700" b="0">
+              <a:t>Faster network discovery</a:t>
+            </a:r>
+          </a:p>
+          <a:p>
+            <a:pPr>
+              <a:defRPr sz="700" b="0">
                 <a:solidFill>
                   <a:srgbClr val="2C3E50"/>
                 </a:solidFill>
                 <a:latin typeface="Georgia"/>
-              </a:rPr>
-              <a:t>Faster network discovery
-(180s vs 30-day backlog)</a:t>
+              </a:defRPr>
+            </a:pPr>
+            <a:r>
+              <a:t>(5s AI triage vs 30-day backlog)</a:t>
             </a:r>
           </a:p>
         </p:txBody>
@@ -16215,15 +16115,16 @@
           </a:bodyPr>
           <a:lstStyle/>
           <a:p>
-            <a:pPr algn="ctr"/>
+            <a:pPr algn="ctr">
+              <a:defRPr sz="1700" b="1">
+                <a:solidFill>
+                  <a:srgbClr val="6A3D7D"/>
+                </a:solidFill>
+                <a:latin typeface="Georgia"/>
+              </a:defRPr>
+            </a:pPr>
             <a:r>
-              <a:rPr sz="1700" b="1">
-                <a:solidFill>
-                  <a:srgbClr val="6A3D7D"/>
-                </a:solidFill>
-                <a:latin typeface="Georgia"/>
-              </a:rPr>
-              <a:t>16,000+</a:t>
+              <a:t>100.0%</a:t>
             </a:r>
           </a:p>
         </p:txBody>
@@ -16253,16 +16154,29 @@
           </a:bodyPr>
           <a:lstStyle/>
           <a:p>
-            <a:pPr algn="ctr"/>
+            <a:pPr algn="ctr">
+              <a:defRPr sz="700" b="0">
+                <a:solidFill>
+                  <a:srgbClr val="2C3E50"/>
+                </a:solidFill>
+                <a:latin typeface="Georgia"/>
+              </a:defRPr>
+            </a:pPr>
             <a:r>
-              <a:rPr sz="700" b="0">
+              <a:t>Case Copilot benchmark</a:t>
+            </a:r>
+          </a:p>
+          <a:p>
+            <a:pPr>
+              <a:defRPr sz="700" b="0">
                 <a:solidFill>
                   <a:srgbClr val="2C3E50"/>
                 </a:solidFill>
                 <a:latin typeface="Georgia"/>
-              </a:rPr>
-              <a:t>Police stations &amp; patrol
-units empowered nationwide</a:t>
+              </a:defRPr>
+            </a:pPr>
+            <a:r>
+              <a:t>accuracy across 50 FIR cases</a:t>
             </a:r>
           </a:p>
         </p:txBody>
@@ -16531,27 +16445,28 @@
               <a:spcAft>
                 <a:spcPts val="200"/>
               </a:spcAft>
+              <a:defRPr sz="700" b="0">
+                <a:solidFill>
+                  <a:srgbClr val="2C3E50"/>
+                </a:solidFill>
+                <a:latin typeface="Georgia"/>
+              </a:defRPr>
             </a:pPr>
             <a:r>
-              <a:rPr sz="700" b="0">
+              <a:t>• Citizen Protection: Fast syndicate disruption, multilingual voice reporting (EN/HI/TA) &amp; GIS dispatch in &lt;60s.</a:t>
+            </a:r>
+          </a:p>
+          <a:p>
+            <a:pPr>
+              <a:defRPr sz="700" b="0">
                 <a:solidFill>
                   <a:srgbClr val="2C3E50"/>
                 </a:solidFill>
                 <a:latin typeface="Georgia"/>
-              </a:rPr>
-              <a:t>• Citizen Protection: Fast syndicate disruption &amp; automated GIS patrol dispatch in &lt;60s.</a:t>
-            </a:r>
-          </a:p>
-          <a:p>
-            <a:pPr/>
+              </a:defRPr>
+            </a:pPr>
             <a:r>
-              <a:rPr sz="700" b="0">
-                <a:solidFill>
-                  <a:srgbClr val="2C3E50"/>
-                </a:solidFill>
-                <a:latin typeface="Georgia"/>
-              </a:rPr>
-              <a:t>• Judicial Integrity: Tamper-proof SHA-256 evidence chain certified under BSA Sec 65B.</a:t>
+              <a:t>• Judicial Integrity: Tamper-proof SHA-256 evidence chain certified under BSA Sec 65B &amp; BNSS 2023 Sec 63.</a:t>
             </a:r>
           </a:p>
         </p:txBody>
@@ -16697,27 +16612,28 @@
               <a:spcAft>
                 <a:spcPts val="200"/>
               </a:spcAft>
+              <a:defRPr sz="700" b="0">
+                <a:solidFill>
+                  <a:srgbClr val="2C3E50"/>
+                </a:solidFill>
+                <a:latin typeface="Georgia"/>
+              </a:defRPr>
             </a:pPr>
             <a:r>
-              <a:rPr sz="700" b="0">
-                <a:solidFill>
-                  <a:srgbClr val="2C3E50"/>
-                </a:solidFill>
-                <a:latin typeface="Georgia"/>
-              </a:rPr>
               <a:t>• License Savings: Eliminates recurring lab software licenses, saving ₹25–40L per unit.</a:t>
             </a:r>
           </a:p>
           <a:p>
-            <a:pPr/>
+            <a:pPr>
+              <a:defRPr sz="700" b="0">
+                <a:solidFill>
+                  <a:srgbClr val="2C3E50"/>
+                </a:solidFill>
+                <a:latin typeface="Georgia"/>
+              </a:defRPr>
+            </a:pPr>
             <a:r>
-              <a:rPr sz="700" b="0">
-                <a:solidFill>
-                  <a:srgbClr val="2C3E50"/>
-                </a:solidFill>
-                <a:latin typeface="Georgia"/>
-              </a:rPr>
-              <a:t>• Investigation Speed: Slashes evidence triage delay from 30 days to under 180 seconds.</a:t>
+              <a:t>• Investigation Speed: Slashes evidence triage delay from 30 days to under 180 seconds, and legal drafting to 5 seconds.</a:t>
             </a:r>
           </a:p>
         </p:txBody>
@@ -16863,26 +16779,27 @@
               <a:spcAft>
                 <a:spcPts val="200"/>
               </a:spcAft>
+              <a:defRPr sz="700" b="0">
+                <a:solidFill>
+                  <a:srgbClr val="2C3E50"/>
+                </a:solidFill>
+                <a:latin typeface="Georgia"/>
+              </a:defRPr>
             </a:pPr>
             <a:r>
-              <a:rPr sz="700" b="0">
-                <a:solidFill>
-                  <a:srgbClr val="2C3E50"/>
-                </a:solidFill>
-                <a:latin typeface="Georgia"/>
-              </a:rPr>
               <a:t>• Tamper-Proof Evidence: Hardware write-blocker protects physical bus integrity on-scene.</a:t>
             </a:r>
           </a:p>
           <a:p>
-            <a:pPr/>
+            <a:pPr>
+              <a:defRPr sz="700" b="0">
+                <a:solidFill>
+                  <a:srgbClr val="2C3E50"/>
+                </a:solidFill>
+                <a:latin typeface="Georgia"/>
+              </a:defRPr>
+            </a:pPr>
             <a:r>
-              <a:rPr sz="700" b="0">
-                <a:solidFill>
-                  <a:srgbClr val="2C3E50"/>
-                </a:solidFill>
-                <a:latin typeface="Georgia"/>
-              </a:rPr>
               <a:t>• Green Tech: 100% digital evidence flow on low-power 5V hardware, zero paper waste.</a:t>
             </a:r>
           </a:p>
@@ -17210,15 +17127,16 @@
           </a:bodyPr>
           <a:lstStyle/>
           <a:p>
-            <a:pPr/>
+            <a:pPr>
+              <a:defRPr sz="800" b="1">
+                <a:solidFill>
+                  <a:srgbClr val="FFFFFF"/>
+                </a:solidFill>
+                <a:latin typeface="Georgia"/>
+              </a:defRPr>
+            </a:pPr>
             <a:r>
-              <a:rPr sz="800" b="1">
-                <a:solidFill>
-                  <a:srgbClr val="FFFFFF"/>
-                </a:solidFill>
-                <a:latin typeface="Georgia"/>
-              </a:rPr>
-              <a:t>DPDP Act 2023 &amp; BNS 2023 Certified</a:t>
+              <a:t>DPDP Act 2023 &amp; BNSS 2023 Certified</a:t>
             </a:r>
           </a:p>
         </p:txBody>
@@ -17286,18 +17204,15 @@
                 <a:srgbClr val="196F3D"/>
               </a:buClr>
               <a:buSzPts val="1100"/>
+              <a:defRPr sz="1100" b="1">
+                <a:solidFill>
+                  <a:srgbClr val="196F3D"/>
+                </a:solidFill>
+                <a:latin typeface="Times New Roman"/>
+              </a:defRPr>
             </a:pPr>
             <a:r>
-              <a:rPr lang="en-IN" sz="1100" b="1" dirty="0">
-                <a:solidFill>
-                  <a:srgbClr val="196F3D"/>
-                </a:solidFill>
-                <a:latin typeface="Times New Roman" panose="02020603050405020304" pitchFamily="18" charset="0"/>
-                <a:ea typeface="Calibri"/>
-                <a:cs typeface="Times New Roman" panose="02020603050405020304" pitchFamily="18" charset="0"/>
-                <a:sym typeface="Calibri"/>
-              </a:rPr>
-              <a:t>AAROHAN-X</a:t>
+              <a:t>NCIS</a:t>
             </a:r>
             <a:endParaRPr sz="1100" b="0" i="0" u="none" strike="noStrike" cap="none" dirty="0">
               <a:solidFill>
@@ -17461,7 +17376,7 @@
               </a:defRPr>
             </a:pPr>
             <a:r>
-              <a:t>SIH 2026 — Idea Submission — AAROHAN-X</a:t>
+              <a:t>SIH 2026 — Idea Submission — NCIS</a:t>
             </a:r>
           </a:p>
         </p:txBody>
@@ -17773,14 +17688,14 @@
               <a:spcAft>
                 <a:spcPts val="0"/>
               </a:spcAft>
+              <a:defRPr sz="750" b="0">
+                <a:solidFill>
+                  <a:srgbClr val="2C3E50"/>
+                </a:solidFill>
+                <a:latin typeface="Georgia"/>
+              </a:defRPr>
             </a:pPr>
             <a:r>
-              <a:rPr sz="750" b="0">
-                <a:solidFill>
-                  <a:srgbClr val="2C3E50"/>
-                </a:solidFill>
-                <a:latin typeface="Georgia"/>
-              </a:rPr>
               <a:t>1. Bureau of Police Research &amp; Development (BPR&amp;D) — Smart Policing Directives &amp; AI Crime Analysis Guidelines (2024–2026).</a:t>
             </a:r>
             <a:endParaRPr lang="en-IN" sz="900" b="0" i="0" u="none" strike="noStrike" cap="none" dirty="0">
@@ -17794,51 +17709,55 @@
             </a:endParaRPr>
           </a:p>
           <a:p>
-            <a:pPr/>
+            <a:pPr>
+              <a:defRPr sz="750" b="0">
+                <a:solidFill>
+                  <a:srgbClr val="2C3E50"/>
+                </a:solidFill>
+                <a:latin typeface="Georgia"/>
+              </a:defRPr>
+            </a:pPr>
             <a:r>
-              <a:rPr sz="750" b="0">
+              <a:t>2. Ministry of Home Affairs, Govt. of India — Bharatiya Nagarik Suraksha Sanhita (BNSS 2023 Sec 94, 107, 176) &amp; BSA Sec 65B Electronic Evidence.</a:t>
+            </a:r>
+          </a:p>
+          <a:p>
+            <a:pPr>
+              <a:defRPr sz="750" b="0">
                 <a:solidFill>
                   <a:srgbClr val="2C3E50"/>
                 </a:solidFill>
                 <a:latin typeface="Georgia"/>
-              </a:rPr>
-              <a:t>2. Ministry of Home Affairs, Govt. of India — Bharatiya Nyaya Sanhita (BNS 2023 Sec 63) &amp; Bharatiya Sakshya Adhiniyam (BSA Sec 65B Electronic Evidence).</a:t>
+              </a:defRPr>
+            </a:pPr>
+            <a:r>
+              <a:t>3. National Technical Research Organisation (NTRO) — SIH26150 Multi-Vendor DVR/NVR Forensic Standards (Hikvision, Dahua, CP Plus, Honeywell, Uniview).</a:t>
             </a:r>
           </a:p>
           <a:p>
-            <a:pPr/>
+            <a:pPr>
+              <a:defRPr sz="750" b="0">
+                <a:solidFill>
+                  <a:srgbClr val="2C3E50"/>
+                </a:solidFill>
+                <a:latin typeface="Georgia"/>
+              </a:defRPr>
+            </a:pPr>
             <a:r>
-              <a:rPr sz="750" b="0">
+              <a:t>4. Kipf, T. N., &amp; Welling, M. — Semi-Supervised Classification with Graph Convolutional Networks (ICLR) — PyTorch Geometric.</a:t>
+            </a:r>
+          </a:p>
+          <a:p>
+            <a:pPr>
+              <a:defRPr sz="750" b="0">
                 <a:solidFill>
                   <a:srgbClr val="2C3E50"/>
                 </a:solidFill>
                 <a:latin typeface="Georgia"/>
-              </a:rPr>
-              <a:t>3. Kipf, T. N., &amp; Welling, M. — Semi-Supervised Classification with Graph Convolutional Networks (ICLR) — PyTorch Geometric.</a:t>
-            </a:r>
-          </a:p>
-          <a:p>
-            <a:pPr/>
+              </a:defRPr>
+            </a:pPr>
             <a:r>
-              <a:rPr sz="750" b="0">
-                <a:solidFill>
-                  <a:srgbClr val="2C3E50"/>
-                </a:solidFill>
-                <a:latin typeface="Georgia"/>
-              </a:rPr>
-              <a:t>4. National Crime Records Bureau (NCRB) — CCTNS 2.0 Schema &amp; ERSS Dial 112 Real-Time Dispatch Protocols.</a:t>
-            </a:r>
-          </a:p>
-          <a:p>
-            <a:pPr/>
-            <a:r>
-              <a:rPr sz="750" b="0">
-                <a:solidFill>
-                  <a:srgbClr val="2C3E50"/>
-                </a:solidFill>
-                <a:latin typeface="Georgia"/>
-              </a:rPr>
-              <a:t>5. Sinnott, R. W. — Virtues of the Haversine (Great-Circle Navigation &amp; Geodesic Distance Matrix for Emergency Response).</a:t>
+              <a:t>5. National Crime Records Bureau (NCRB) — CCTNS 2.0 Schema &amp; ERSS Dial 112 Real-Time Dispatch Protocols.</a:t>
             </a:r>
           </a:p>
         </p:txBody>
@@ -18080,75 +17999,81 @@
           </a:bodyPr>
           <a:lstStyle/>
           <a:p>
-            <a:pPr/>
+            <a:pPr>
+              <a:defRPr sz="750" b="0">
+                <a:solidFill>
+                  <a:srgbClr val="2C3E50"/>
+                </a:solidFill>
+                <a:latin typeface="Georgia"/>
+              </a:defRPr>
+            </a:pPr>
             <a:r>
-              <a:rPr sz="750" b="0">
-                <a:solidFill>
-                  <a:srgbClr val="2C3E50"/>
-                </a:solidFill>
-                <a:latin typeface="Georgia"/>
-              </a:rPr>
               <a:t>[ 1 ] Full Documentation &amp; Source — github.com/muhammedmaahir68-droid/cyber-kit</a:t>
             </a:r>
           </a:p>
           <a:p>
-            <a:pPr/>
+            <a:pPr>
+              <a:defRPr sz="750" b="0">
+                <a:solidFill>
+                  <a:srgbClr val="2C3E50"/>
+                </a:solidFill>
+                <a:latin typeface="Georgia"/>
+              </a:defRPr>
+            </a:pPr>
             <a:r>
-              <a:rPr sz="750" b="0">
-                <a:solidFill>
-                  <a:srgbClr val="2C3E50"/>
-                </a:solidFill>
-                <a:latin typeface="Georgia"/>
-              </a:rPr>
               <a:t>[ 2 ] Live Production Portal — cyber-kit-police.vercel.app</a:t>
             </a:r>
           </a:p>
           <a:p>
-            <a:pPr/>
+            <a:pPr>
+              <a:defRPr sz="750" b="0">
+                <a:solidFill>
+                  <a:srgbClr val="2C3E50"/>
+                </a:solidFill>
+                <a:latin typeface="Georgia"/>
+              </a:defRPr>
+            </a:pPr>
             <a:r>
-              <a:rPr sz="750" b="0">
+              <a:t>[ 3 ] Case Copilot AI API — /copilot/query, /copilot/eval, /copilot/cases</a:t>
+            </a:r>
+          </a:p>
+          <a:p>
+            <a:pPr>
+              <a:defRPr sz="750" b="0">
                 <a:solidFill>
                   <a:srgbClr val="2C3E50"/>
                 </a:solidFill>
                 <a:latin typeface="Georgia"/>
-              </a:rPr>
-              <a:t>[ 3 ] Cloud FastAPI Backend &amp; Telemetry — /api/v1/* Production Endpoints</a:t>
-            </a:r>
-          </a:p>
-          <a:p>
-            <a:pPr/>
+              </a:defRPr>
+            </a:pPr>
             <a:r>
-              <a:rPr sz="750" b="0">
-                <a:solidFill>
-                  <a:srgbClr val="2C3E50"/>
-                </a:solidFill>
-                <a:latin typeface="Georgia"/>
-              </a:rPr>
               <a:t>[ 4 ] Tactical Hardware Terminal — Physical Write-Blocker Acquisition Bus</a:t>
             </a:r>
           </a:p>
           <a:p>
-            <a:pPr/>
+            <a:pPr>
+              <a:defRPr sz="750" b="0">
+                <a:solidFill>
+                  <a:srgbClr val="2C3E50"/>
+                </a:solidFill>
+                <a:latin typeface="Georgia"/>
+              </a:defRPr>
+            </a:pPr>
             <a:r>
-              <a:rPr sz="750" b="0">
-                <a:solidFill>
-                  <a:srgbClr val="2C3E50"/>
-                </a:solidFill>
-                <a:latin typeface="Georgia"/>
-              </a:rPr>
               <a:t>[ 5 ] Interactive GIS Tracking &amp; GNN Demo — cyber-kit-police.vercel.app</a:t>
             </a:r>
           </a:p>
           <a:p>
-            <a:pPr/>
+            <a:pPr>
+              <a:defRPr sz="750" b="0">
+                <a:solidFill>
+                  <a:srgbClr val="2C3E50"/>
+                </a:solidFill>
+                <a:latin typeface="Georgia"/>
+              </a:defRPr>
+            </a:pPr>
             <a:r>
-              <a:rPr sz="750" b="0">
-                <a:solidFill>
-                  <a:srgbClr val="2C3E50"/>
-                </a:solidFill>
-                <a:latin typeface="Georgia"/>
-              </a:rPr>
-              <a:t>[ 6 ] SIH Problem Statement — sih.gov.in (PS 189 - BPR&amp;D / MHA)</a:t>
+              <a:t>[ 6 ] SIH Problem Statements — sih.gov.in (PS 189 - BPR&amp;D / MHA &amp; SIH26150 - NTRO)</a:t>
             </a:r>
           </a:p>
         </p:txBody>

</xml_diff>